<commit_message>
Make Zoom participant scope mandatory
</commit_message>
<xml_diff>
--- a/public/docs/Zoom_AxioMeet_setup_RU.pptx
+++ b/public/docs/Zoom_AxioMeet_setup_RU.pptx
@@ -2,25 +2,25 @@
 <file path=ppt/presentation.xml><?xml version="1.0" encoding="utf-8"?>
 <p:presentation xmlns:p="http://schemas.openxmlformats.org/presentationml/2006/main">
   <p:sldMasterIdLst>
-    <p:sldMasterId xmlns:r="http://schemas.openxmlformats.org/officeDocument/2006/relationships" id="2147483648" r:id="Rdb659b0a80b24c93"/>
+    <p:sldMasterId xmlns:r="http://schemas.openxmlformats.org/officeDocument/2006/relationships" id="2147483648" r:id="R64b18f981a8e4ff1"/>
   </p:sldMasterIdLst>
   <p:notesMasterIdLst>
-    <p:notesMasterId xmlns:r="http://schemas.openxmlformats.org/officeDocument/2006/relationships" r:id="Rbedf70944e674aeb"/>
+    <p:notesMasterId xmlns:r="http://schemas.openxmlformats.org/officeDocument/2006/relationships" r:id="R9491323b182d4241"/>
   </p:notesMasterIdLst>
   <p:sldIdLst>
-    <p:sldId xmlns:r="http://schemas.openxmlformats.org/officeDocument/2006/relationships" id="256" r:id="R0319733da6f14cf8"/>
-    <p:sldId xmlns:r="http://schemas.openxmlformats.org/officeDocument/2006/relationships" id="257" r:id="Rf3512b226bed4352"/>
-    <p:sldId xmlns:r="http://schemas.openxmlformats.org/officeDocument/2006/relationships" id="258" r:id="R42c2430aa7e6440e"/>
-    <p:sldId xmlns:r="http://schemas.openxmlformats.org/officeDocument/2006/relationships" id="259" r:id="Rdd714eb58dc44c47"/>
-    <p:sldId xmlns:r="http://schemas.openxmlformats.org/officeDocument/2006/relationships" id="260" r:id="R26dae08b75c64b76"/>
-    <p:sldId xmlns:r="http://schemas.openxmlformats.org/officeDocument/2006/relationships" id="261" r:id="R1814590f78524a8f"/>
-    <p:sldId xmlns:r="http://schemas.openxmlformats.org/officeDocument/2006/relationships" id="262" r:id="R7d4d3eb4cf49422f"/>
-    <p:sldId xmlns:r="http://schemas.openxmlformats.org/officeDocument/2006/relationships" id="263" r:id="Rd9aa8d6c8fc447be"/>
-    <p:sldId xmlns:r="http://schemas.openxmlformats.org/officeDocument/2006/relationships" id="264" r:id="R29431f6b474c47ed"/>
-    <p:sldId xmlns:r="http://schemas.openxmlformats.org/officeDocument/2006/relationships" id="265" r:id="R8f24037d70ea4d3c"/>
-    <p:sldId xmlns:r="http://schemas.openxmlformats.org/officeDocument/2006/relationships" id="266" r:id="Rc39f4d6cd3aa445c"/>
-    <p:sldId xmlns:r="http://schemas.openxmlformats.org/officeDocument/2006/relationships" id="267" r:id="R3a57e395ddcb4b17"/>
-    <p:sldId xmlns:r="http://schemas.openxmlformats.org/officeDocument/2006/relationships" id="268" r:id="R41c3c6824fcf4a51"/>
+    <p:sldId xmlns:r="http://schemas.openxmlformats.org/officeDocument/2006/relationships" id="256" r:id="R46898a2d7937406f"/>
+    <p:sldId xmlns:r="http://schemas.openxmlformats.org/officeDocument/2006/relationships" id="257" r:id="Rb025ebc94ebb4bc0"/>
+    <p:sldId xmlns:r="http://schemas.openxmlformats.org/officeDocument/2006/relationships" id="258" r:id="Ra216e14e3fa242c5"/>
+    <p:sldId xmlns:r="http://schemas.openxmlformats.org/officeDocument/2006/relationships" id="259" r:id="R5d089f7cf8f142f5"/>
+    <p:sldId xmlns:r="http://schemas.openxmlformats.org/officeDocument/2006/relationships" id="260" r:id="R762a50a74aa94479"/>
+    <p:sldId xmlns:r="http://schemas.openxmlformats.org/officeDocument/2006/relationships" id="261" r:id="Rc5815b3efc584fc9"/>
+    <p:sldId xmlns:r="http://schemas.openxmlformats.org/officeDocument/2006/relationships" id="262" r:id="R5b4b3405b86d40f7"/>
+    <p:sldId xmlns:r="http://schemas.openxmlformats.org/officeDocument/2006/relationships" id="263" r:id="R182a5db37d734322"/>
+    <p:sldId xmlns:r="http://schemas.openxmlformats.org/officeDocument/2006/relationships" id="264" r:id="Re41a79e8e5804861"/>
+    <p:sldId xmlns:r="http://schemas.openxmlformats.org/officeDocument/2006/relationships" id="265" r:id="Re46d728a79fc4bc2"/>
+    <p:sldId xmlns:r="http://schemas.openxmlformats.org/officeDocument/2006/relationships" id="266" r:id="R769b6eeb0368483c"/>
+    <p:sldId xmlns:r="http://schemas.openxmlformats.org/officeDocument/2006/relationships" id="267" r:id="R2967d57e944c481f"/>
+    <p:sldId xmlns:r="http://schemas.openxmlformats.org/officeDocument/2006/relationships" id="268" r:id="R355ddfd9b57446ec"/>
   </p:sldIdLst>
   <p:sldSz cx="12192000" cy="6858000"/>
   <p:notesSz cx="6858000" cy="9144000"/>
@@ -1409,7 +1409,7 @@
           <a:lstStyle xmlns:a="http://schemas.openxmlformats.org/drawingml/2006/main"/>
           <a:p xmlns:a="http://schemas.openxmlformats.org/drawingml/2006/main">
             <a:r>
-              <a:t>Первые шесть scopes — обязательные для текущей реализации. Scope участников нужен для списка участников; если его нет, запись может импортироваться, но данные участников будут неполными.</a:t>
+              <a:t>Все семь scopes обязательны для текущей реализации. Последний scope нужен для надёжного получения имён и состава участников встречи.</a:t>
             </a:r>
           </a:p>
           <a:p xmlns:a="http://schemas.openxmlformats.org/drawingml/2006/main">
@@ -1692,7 +1692,7 @@
   </p:cSld>
   <p:clrMap bg1="lt1" tx1="dk1" bg2="lt2" tx2="dk2" accent1="accent1" accent2="accent2" accent3="accent3" accent4="accent4" accent5="accent5" accent6="accent6" hlink="hlink" folHlink="folHlink"/>
   <p:sldLayoutIdLst>
-    <p:sldLayoutId xmlns:r="http://schemas.openxmlformats.org/officeDocument/2006/relationships" id="2147483649" r:id="R4355533f39cc4a9d"/>
+    <p:sldLayoutId xmlns:r="http://schemas.openxmlformats.org/officeDocument/2006/relationships" id="2147483649" r:id="R091e2e5421d94b89"/>
   </p:sldLayoutIdLst>
   <p:txStyles>
     <p:titleStyle>
@@ -2306,6 +2306,7 @@
           <a:lstStyle xmlns:a="http://schemas.openxmlformats.org/drawingml/2006/main"/>
           <a:p xmlns:a="http://schemas.openxmlformats.org/drawingml/2006/main">
             <a:pPr algn="ctr">
+              <a:buNone/>
               <a:defRPr sz="1050" b="1">
                 <a:solidFill>
                   <a:srgbClr val="2D8CFF"/>
@@ -2362,6 +2363,7 @@
           <a:lstStyle xmlns:a="http://schemas.openxmlformats.org/drawingml/2006/main"/>
           <a:p xmlns:a="http://schemas.openxmlformats.org/drawingml/2006/main">
             <a:pPr algn="l">
+              <a:buNone/>
               <a:defRPr sz="4050" b="1">
                 <a:solidFill>
                   <a:srgbClr val="101820"/>
@@ -2418,6 +2420,7 @@
           <a:lstStyle xmlns:a="http://schemas.openxmlformats.org/drawingml/2006/main"/>
           <a:p xmlns:a="http://schemas.openxmlformats.org/drawingml/2006/main">
             <a:pPr algn="l">
+              <a:buNone/>
               <a:defRPr sz="3000" b="1">
                 <a:solidFill>
                   <a:srgbClr val="1B5964"/>
@@ -2441,6 +2444,7 @@
           </a:p>
           <a:p xmlns:a="http://schemas.openxmlformats.org/drawingml/2006/main">
             <a:pPr algn="l">
+              <a:buNone/>
               <a:defRPr sz="3000" b="1">
                 <a:solidFill>
                   <a:srgbClr val="1B5964"/>
@@ -2497,6 +2501,7 @@
           <a:lstStyle xmlns:a="http://schemas.openxmlformats.org/drawingml/2006/main"/>
           <a:p xmlns:a="http://schemas.openxmlformats.org/drawingml/2006/main">
             <a:pPr algn="l">
+              <a:buNone/>
               <a:defRPr sz="1350" b="0">
                 <a:solidFill>
                   <a:srgbClr val="59636E"/>
@@ -2520,6 +2525,7 @@
           </a:p>
           <a:p xmlns:a="http://schemas.openxmlformats.org/drawingml/2006/main">
             <a:pPr algn="l">
+              <a:buNone/>
               <a:defRPr sz="1350" b="0">
                 <a:solidFill>
                   <a:srgbClr val="59636E"/>
@@ -2611,6 +2617,7 @@
           <a:lstStyle xmlns:a="http://schemas.openxmlformats.org/drawingml/2006/main"/>
           <a:p xmlns:a="http://schemas.openxmlformats.org/drawingml/2006/main">
             <a:pPr algn="ctr">
+              <a:buNone/>
               <a:defRPr sz="1050" b="1">
                 <a:solidFill>
                   <a:srgbClr val="101820"/>
@@ -2702,6 +2709,7 @@
           <a:lstStyle xmlns:a="http://schemas.openxmlformats.org/drawingml/2006/main"/>
           <a:p xmlns:a="http://schemas.openxmlformats.org/drawingml/2006/main">
             <a:pPr algn="ctr">
+              <a:buNone/>
               <a:defRPr sz="1050" b="1">
                 <a:solidFill>
                   <a:srgbClr val="101820"/>
@@ -2793,6 +2801,7 @@
           <a:lstStyle xmlns:a="http://schemas.openxmlformats.org/drawingml/2006/main"/>
           <a:p xmlns:a="http://schemas.openxmlformats.org/drawingml/2006/main">
             <a:pPr algn="ctr">
+              <a:buNone/>
               <a:defRPr sz="1050" b="1">
                 <a:solidFill>
                   <a:srgbClr val="101820"/>
@@ -2853,14 +2862,14 @@
       </p:sp>
       <p:pic>
         <p:nvPicPr>
-          <p:cNvPr id="29" name=""/>
+          <p:cNvPr id="31" name=""/>
           <p:cNvPicPr>
             <a:picLocks xmlns:a="http://schemas.openxmlformats.org/drawingml/2006/main" noChangeAspect="1"/>
           </p:cNvPicPr>
           <p:nvPr/>
         </p:nvPicPr>
         <p:blipFill>
-          <a:blip xmlns:r="http://schemas.openxmlformats.org/officeDocument/2006/relationships" xmlns:a="http://schemas.openxmlformats.org/drawingml/2006/main" r:embed="Rcbff927759c2489e"/>
+          <a:blip xmlns:r="http://schemas.openxmlformats.org/officeDocument/2006/relationships" xmlns:a="http://schemas.openxmlformats.org/drawingml/2006/main" r:embed="R26e8940e51e94b3c"/>
           <a:srcRect xmlns:a="http://schemas.openxmlformats.org/drawingml/2006/main" l="16367" t="0" r="16367" b="0"/>
           <a:stretch xmlns:a="http://schemas.openxmlformats.org/drawingml/2006/main">
             <a:fillRect l="0" t="0" r="0" b="0"/>
@@ -2944,6 +2953,7 @@
           <a:lstStyle xmlns:a="http://schemas.openxmlformats.org/drawingml/2006/main"/>
           <a:p xmlns:a="http://schemas.openxmlformats.org/drawingml/2006/main">
             <a:pPr algn="l">
+              <a:buNone/>
               <a:defRPr sz="750" b="1">
                 <a:solidFill>
                   <a:srgbClr val="59636E"/>
@@ -3000,6 +3010,7 @@
           <a:lstStyle xmlns:a="http://schemas.openxmlformats.org/drawingml/2006/main"/>
           <a:p xmlns:a="http://schemas.openxmlformats.org/drawingml/2006/main">
             <a:pPr algn="r">
+              <a:buNone/>
               <a:defRPr sz="900" b="1">
                 <a:solidFill>
                   <a:srgbClr val="59636E"/>
@@ -3085,6 +3096,7 @@
           <a:lstStyle xmlns:a="http://schemas.openxmlformats.org/drawingml/2006/main"/>
           <a:p xmlns:a="http://schemas.openxmlformats.org/drawingml/2006/main">
             <a:pPr algn="l">
+              <a:buNone/>
               <a:defRPr sz="900" b="1">
                 <a:solidFill>
                   <a:srgbClr val="2D8CFF"/>
@@ -3141,6 +3153,7 @@
           <a:lstStyle xmlns:a="http://schemas.openxmlformats.org/drawingml/2006/main"/>
           <a:p xmlns:a="http://schemas.openxmlformats.org/drawingml/2006/main">
             <a:pPr algn="l">
+              <a:buNone/>
               <a:defRPr sz="3000" b="1">
                 <a:solidFill>
                   <a:srgbClr val="101820"/>
@@ -3197,6 +3210,7 @@
           <a:lstStyle xmlns:a="http://schemas.openxmlformats.org/drawingml/2006/main"/>
           <a:p xmlns:a="http://schemas.openxmlformats.org/drawingml/2006/main">
             <a:pPr algn="l">
+              <a:buNone/>
               <a:defRPr sz="3000" b="1">
                 <a:solidFill>
                   <a:srgbClr val="101820"/>
@@ -3286,6 +3300,7 @@
           <a:lstStyle xmlns:a="http://schemas.openxmlformats.org/drawingml/2006/main"/>
           <a:p xmlns:a="http://schemas.openxmlformats.org/drawingml/2006/main">
             <a:pPr algn="l">
+              <a:buNone/>
               <a:defRPr sz="750" b="1">
                 <a:solidFill>
                   <a:srgbClr val="59636E"/>
@@ -3342,6 +3357,7 @@
           <a:lstStyle xmlns:a="http://schemas.openxmlformats.org/drawingml/2006/main"/>
           <a:p xmlns:a="http://schemas.openxmlformats.org/drawingml/2006/main">
             <a:pPr algn="r">
+              <a:buNone/>
               <a:defRPr sz="900" b="1">
                 <a:solidFill>
                   <a:srgbClr val="59636E"/>
@@ -3398,6 +3414,7 @@
           <a:lstStyle xmlns:a="http://schemas.openxmlformats.org/drawingml/2006/main"/>
           <a:p xmlns:a="http://schemas.openxmlformats.org/drawingml/2006/main">
             <a:pPr algn="l">
+              <a:buNone/>
               <a:defRPr sz="900" b="1">
                 <a:solidFill>
                   <a:srgbClr val="2D8CFF"/>
@@ -3454,6 +3471,7 @@
           <a:lstStyle xmlns:a="http://schemas.openxmlformats.org/drawingml/2006/main"/>
           <a:p xmlns:a="http://schemas.openxmlformats.org/drawingml/2006/main">
             <a:pPr algn="l">
+              <a:buNone/>
               <a:defRPr sz="3000" b="1">
                 <a:solidFill>
                   <a:srgbClr val="101820"/>
@@ -3514,6 +3532,7 @@
           <a:lstStyle xmlns:a="http://schemas.openxmlformats.org/drawingml/2006/main"/>
           <a:p xmlns:a="http://schemas.openxmlformats.org/drawingml/2006/main">
             <a:pPr algn="ctr">
+              <a:buNone/>
               <a:defRPr sz="1200" b="1">
                 <a:solidFill>
                   <a:srgbClr val="FFFFFF"/>
@@ -3603,6 +3622,7 @@
           <a:lstStyle xmlns:a="http://schemas.openxmlformats.org/drawingml/2006/main"/>
           <a:p xmlns:a="http://schemas.openxmlformats.org/drawingml/2006/main">
             <a:pPr algn="ctr">
+              <a:buNone/>
               <a:defRPr sz="1575" b="1">
                 <a:solidFill>
                   <a:srgbClr val="101820"/>
@@ -3659,6 +3679,7 @@
           <a:lstStyle xmlns:a="http://schemas.openxmlformats.org/drawingml/2006/main"/>
           <a:p xmlns:a="http://schemas.openxmlformats.org/drawingml/2006/main">
             <a:pPr algn="ctr">
+              <a:buNone/>
               <a:defRPr sz="1200" b="0">
                 <a:solidFill>
                   <a:srgbClr val="59636E"/>
@@ -3719,6 +3740,7 @@
           <a:lstStyle xmlns:a="http://schemas.openxmlformats.org/drawingml/2006/main"/>
           <a:p xmlns:a="http://schemas.openxmlformats.org/drawingml/2006/main">
             <a:pPr algn="ctr">
+              <a:buNone/>
               <a:defRPr sz="1200" b="1">
                 <a:solidFill>
                   <a:srgbClr val="FFFFFF"/>
@@ -3808,6 +3830,7 @@
           <a:lstStyle xmlns:a="http://schemas.openxmlformats.org/drawingml/2006/main"/>
           <a:p xmlns:a="http://schemas.openxmlformats.org/drawingml/2006/main">
             <a:pPr algn="ctr">
+              <a:buNone/>
               <a:defRPr sz="1575" b="1">
                 <a:solidFill>
                   <a:srgbClr val="101820"/>
@@ -3864,6 +3887,7 @@
           <a:lstStyle xmlns:a="http://schemas.openxmlformats.org/drawingml/2006/main"/>
           <a:p xmlns:a="http://schemas.openxmlformats.org/drawingml/2006/main">
             <a:pPr algn="ctr">
+              <a:buNone/>
               <a:defRPr sz="1200" b="0">
                 <a:solidFill>
                   <a:srgbClr val="59636E"/>
@@ -3924,6 +3948,7 @@
           <a:lstStyle xmlns:a="http://schemas.openxmlformats.org/drawingml/2006/main"/>
           <a:p xmlns:a="http://schemas.openxmlformats.org/drawingml/2006/main">
             <a:pPr algn="ctr">
+              <a:buNone/>
               <a:defRPr sz="1200" b="1">
                 <a:solidFill>
                   <a:srgbClr val="FFFFFF"/>
@@ -4013,6 +4038,7 @@
           <a:lstStyle xmlns:a="http://schemas.openxmlformats.org/drawingml/2006/main"/>
           <a:p xmlns:a="http://schemas.openxmlformats.org/drawingml/2006/main">
             <a:pPr algn="ctr">
+              <a:buNone/>
               <a:defRPr sz="1575" b="1">
                 <a:solidFill>
                   <a:srgbClr val="101820"/>
@@ -4069,6 +4095,7 @@
           <a:lstStyle xmlns:a="http://schemas.openxmlformats.org/drawingml/2006/main"/>
           <a:p xmlns:a="http://schemas.openxmlformats.org/drawingml/2006/main">
             <a:pPr algn="ctr">
+              <a:buNone/>
               <a:defRPr sz="1200" b="0">
                 <a:solidFill>
                   <a:srgbClr val="59636E"/>
@@ -4129,6 +4156,7 @@
           <a:lstStyle xmlns:a="http://schemas.openxmlformats.org/drawingml/2006/main"/>
           <a:p xmlns:a="http://schemas.openxmlformats.org/drawingml/2006/main">
             <a:pPr algn="ctr">
+              <a:buNone/>
               <a:defRPr sz="1200" b="1">
                 <a:solidFill>
                   <a:srgbClr val="FFFFFF"/>
@@ -4218,6 +4246,7 @@
           <a:lstStyle xmlns:a="http://schemas.openxmlformats.org/drawingml/2006/main"/>
           <a:p xmlns:a="http://schemas.openxmlformats.org/drawingml/2006/main">
             <a:pPr algn="ctr">
+              <a:buNone/>
               <a:defRPr sz="1575" b="1">
                 <a:solidFill>
                   <a:srgbClr val="101820"/>
@@ -4274,6 +4303,7 @@
           <a:lstStyle xmlns:a="http://schemas.openxmlformats.org/drawingml/2006/main"/>
           <a:p xmlns:a="http://schemas.openxmlformats.org/drawingml/2006/main">
             <a:pPr algn="ctr">
+              <a:buNone/>
               <a:defRPr sz="1200" b="0">
                 <a:solidFill>
                   <a:srgbClr val="59636E"/>
@@ -4334,6 +4364,7 @@
           <a:lstStyle xmlns:a="http://schemas.openxmlformats.org/drawingml/2006/main"/>
           <a:p xmlns:a="http://schemas.openxmlformats.org/drawingml/2006/main">
             <a:pPr algn="ctr">
+              <a:buNone/>
               <a:defRPr sz="1200" b="1">
                 <a:solidFill>
                   <a:srgbClr val="FFFFFF"/>
@@ -4390,6 +4421,7 @@
           <a:lstStyle xmlns:a="http://schemas.openxmlformats.org/drawingml/2006/main"/>
           <a:p xmlns:a="http://schemas.openxmlformats.org/drawingml/2006/main">
             <a:pPr algn="ctr">
+              <a:buNone/>
               <a:defRPr sz="1575" b="1">
                 <a:solidFill>
                   <a:srgbClr val="101820"/>
@@ -4446,6 +4478,7 @@
           <a:lstStyle xmlns:a="http://schemas.openxmlformats.org/drawingml/2006/main"/>
           <a:p xmlns:a="http://schemas.openxmlformats.org/drawingml/2006/main">
             <a:pPr algn="ctr">
+              <a:buNone/>
               <a:defRPr sz="1200" b="0">
                 <a:solidFill>
                   <a:srgbClr val="59636E"/>
@@ -4537,6 +4570,7 @@
           <a:lstStyle xmlns:a="http://schemas.openxmlformats.org/drawingml/2006/main"/>
           <a:p xmlns:a="http://schemas.openxmlformats.org/drawingml/2006/main">
             <a:pPr algn="ctr">
+              <a:buNone/>
               <a:defRPr sz="2100" b="1">
                 <a:solidFill>
                   <a:srgbClr val="FFFFFF"/>
@@ -4593,6 +4627,7 @@
           <a:lstStyle xmlns:a="http://schemas.openxmlformats.org/drawingml/2006/main"/>
           <a:p xmlns:a="http://schemas.openxmlformats.org/drawingml/2006/main">
             <a:pPr algn="ctr">
+              <a:buNone/>
               <a:defRPr sz="1350" b="0">
                 <a:solidFill>
                   <a:srgbClr val="CBE1E3"/>
@@ -4684,6 +4719,7 @@
           <a:lstStyle xmlns:a="http://schemas.openxmlformats.org/drawingml/2006/main"/>
           <a:p xmlns:a="http://schemas.openxmlformats.org/drawingml/2006/main">
             <a:pPr algn="ctr">
+              <a:buNone/>
               <a:defRPr sz="1050" b="1">
                 <a:solidFill>
                   <a:srgbClr val="B4382C"/>
@@ -4769,6 +4805,7 @@
           <a:lstStyle xmlns:a="http://schemas.openxmlformats.org/drawingml/2006/main"/>
           <a:p xmlns:a="http://schemas.openxmlformats.org/drawingml/2006/main">
             <a:pPr algn="l">
+              <a:buNone/>
               <a:defRPr sz="900" b="1">
                 <a:solidFill>
                   <a:srgbClr val="2D8CFF"/>
@@ -4825,6 +4862,7 @@
           <a:lstStyle xmlns:a="http://schemas.openxmlformats.org/drawingml/2006/main"/>
           <a:p xmlns:a="http://schemas.openxmlformats.org/drawingml/2006/main">
             <a:pPr algn="l">
+              <a:buNone/>
               <a:defRPr sz="3300" b="1">
                 <a:solidFill>
                   <a:srgbClr val="101820"/>
@@ -4914,6 +4952,7 @@
           <a:lstStyle xmlns:a="http://schemas.openxmlformats.org/drawingml/2006/main"/>
           <a:p xmlns:a="http://schemas.openxmlformats.org/drawingml/2006/main">
             <a:pPr algn="l">
+              <a:buNone/>
               <a:defRPr sz="750" b="1">
                 <a:solidFill>
                   <a:srgbClr val="59636E"/>
@@ -4970,6 +5009,7 @@
           <a:lstStyle xmlns:a="http://schemas.openxmlformats.org/drawingml/2006/main"/>
           <a:p xmlns:a="http://schemas.openxmlformats.org/drawingml/2006/main">
             <a:pPr algn="r">
+              <a:buNone/>
               <a:defRPr sz="900" b="1">
                 <a:solidFill>
                   <a:srgbClr val="59636E"/>
@@ -5061,6 +5101,7 @@
           <a:lstStyle xmlns:a="http://schemas.openxmlformats.org/drawingml/2006/main"/>
           <a:p xmlns:a="http://schemas.openxmlformats.org/drawingml/2006/main">
             <a:pPr algn="l">
+              <a:buNone/>
               <a:defRPr sz="1200" b="1">
                 <a:solidFill>
                   <a:srgbClr val="FFFFFF"/>
@@ -5117,6 +5158,7 @@
           <a:lstStyle xmlns:a="http://schemas.openxmlformats.org/drawingml/2006/main"/>
           <a:p xmlns:a="http://schemas.openxmlformats.org/drawingml/2006/main">
             <a:pPr algn="l">
+              <a:buNone/>
               <a:defRPr sz="1200" b="1">
                 <a:solidFill>
                   <a:srgbClr val="FFFFFF"/>
@@ -5173,6 +5215,7 @@
           <a:lstStyle xmlns:a="http://schemas.openxmlformats.org/drawingml/2006/main"/>
           <a:p xmlns:a="http://schemas.openxmlformats.org/drawingml/2006/main">
             <a:pPr algn="l">
+              <a:buNone/>
               <a:defRPr sz="1200" b="1">
                 <a:solidFill>
                   <a:srgbClr val="FFFFFF"/>
@@ -5264,6 +5307,7 @@
           <a:lstStyle xmlns:a="http://schemas.openxmlformats.org/drawingml/2006/main"/>
           <a:p xmlns:a="http://schemas.openxmlformats.org/drawingml/2006/main">
             <a:pPr algn="l">
+              <a:buNone/>
               <a:defRPr sz="1200" b="1">
                 <a:solidFill>
                   <a:srgbClr val="101820"/>
@@ -5320,6 +5364,7 @@
           <a:lstStyle xmlns:a="http://schemas.openxmlformats.org/drawingml/2006/main"/>
           <a:p xmlns:a="http://schemas.openxmlformats.org/drawingml/2006/main">
             <a:pPr algn="l">
+              <a:buNone/>
               <a:defRPr sz="1125" b="0">
                 <a:solidFill>
                   <a:srgbClr val="59636E"/>
@@ -5376,6 +5421,7 @@
           <a:lstStyle xmlns:a="http://schemas.openxmlformats.org/drawingml/2006/main"/>
           <a:p xmlns:a="http://schemas.openxmlformats.org/drawingml/2006/main">
             <a:pPr algn="l">
+              <a:buNone/>
               <a:defRPr sz="1125" b="0">
                 <a:solidFill>
                   <a:srgbClr val="101820"/>
@@ -5467,6 +5513,7 @@
           <a:lstStyle xmlns:a="http://schemas.openxmlformats.org/drawingml/2006/main"/>
           <a:p xmlns:a="http://schemas.openxmlformats.org/drawingml/2006/main">
             <a:pPr algn="l">
+              <a:buNone/>
               <a:defRPr sz="1200" b="1">
                 <a:solidFill>
                   <a:srgbClr val="101820"/>
@@ -5523,6 +5570,7 @@
           <a:lstStyle xmlns:a="http://schemas.openxmlformats.org/drawingml/2006/main"/>
           <a:p xmlns:a="http://schemas.openxmlformats.org/drawingml/2006/main">
             <a:pPr algn="l">
+              <a:buNone/>
               <a:defRPr sz="1125" b="0">
                 <a:solidFill>
                   <a:srgbClr val="59636E"/>
@@ -5579,6 +5627,7 @@
           <a:lstStyle xmlns:a="http://schemas.openxmlformats.org/drawingml/2006/main"/>
           <a:p xmlns:a="http://schemas.openxmlformats.org/drawingml/2006/main">
             <a:pPr algn="l">
+              <a:buNone/>
               <a:defRPr sz="1125" b="0">
                 <a:solidFill>
                   <a:srgbClr val="101820"/>
@@ -5670,6 +5719,7 @@
           <a:lstStyle xmlns:a="http://schemas.openxmlformats.org/drawingml/2006/main"/>
           <a:p xmlns:a="http://schemas.openxmlformats.org/drawingml/2006/main">
             <a:pPr algn="l">
+              <a:buNone/>
               <a:defRPr sz="1200" b="1">
                 <a:solidFill>
                   <a:srgbClr val="101820"/>
@@ -5726,6 +5776,7 @@
           <a:lstStyle xmlns:a="http://schemas.openxmlformats.org/drawingml/2006/main"/>
           <a:p xmlns:a="http://schemas.openxmlformats.org/drawingml/2006/main">
             <a:pPr algn="l">
+              <a:buNone/>
               <a:defRPr sz="1125" b="0">
                 <a:solidFill>
                   <a:srgbClr val="59636E"/>
@@ -5782,6 +5833,7 @@
           <a:lstStyle xmlns:a="http://schemas.openxmlformats.org/drawingml/2006/main"/>
           <a:p xmlns:a="http://schemas.openxmlformats.org/drawingml/2006/main">
             <a:pPr algn="l">
+              <a:buNone/>
               <a:defRPr sz="1125" b="0">
                 <a:solidFill>
                   <a:srgbClr val="101820"/>
@@ -5873,6 +5925,7 @@
           <a:lstStyle xmlns:a="http://schemas.openxmlformats.org/drawingml/2006/main"/>
           <a:p xmlns:a="http://schemas.openxmlformats.org/drawingml/2006/main">
             <a:pPr algn="l">
+              <a:buNone/>
               <a:defRPr sz="1200" b="1">
                 <a:solidFill>
                   <a:srgbClr val="101820"/>
@@ -5929,6 +5982,7 @@
           <a:lstStyle xmlns:a="http://schemas.openxmlformats.org/drawingml/2006/main"/>
           <a:p xmlns:a="http://schemas.openxmlformats.org/drawingml/2006/main">
             <a:pPr algn="l">
+              <a:buNone/>
               <a:defRPr sz="1125" b="0">
                 <a:solidFill>
                   <a:srgbClr val="59636E"/>
@@ -5985,6 +6039,7 @@
           <a:lstStyle xmlns:a="http://schemas.openxmlformats.org/drawingml/2006/main"/>
           <a:p xmlns:a="http://schemas.openxmlformats.org/drawingml/2006/main">
             <a:pPr algn="l">
+              <a:buNone/>
               <a:defRPr sz="1125" b="0">
                 <a:solidFill>
                   <a:srgbClr val="101820"/>
@@ -6076,6 +6131,7 @@
           <a:lstStyle xmlns:a="http://schemas.openxmlformats.org/drawingml/2006/main"/>
           <a:p xmlns:a="http://schemas.openxmlformats.org/drawingml/2006/main">
             <a:pPr algn="l">
+              <a:buNone/>
               <a:defRPr sz="1200" b="1">
                 <a:solidFill>
                   <a:srgbClr val="B4382C"/>
@@ -6132,6 +6188,7 @@
           <a:lstStyle xmlns:a="http://schemas.openxmlformats.org/drawingml/2006/main"/>
           <a:p xmlns:a="http://schemas.openxmlformats.org/drawingml/2006/main">
             <a:pPr algn="l">
+              <a:buNone/>
               <a:defRPr sz="1125" b="0">
                 <a:solidFill>
                   <a:srgbClr val="59636E"/>
@@ -6188,6 +6245,7 @@
           <a:lstStyle xmlns:a="http://schemas.openxmlformats.org/drawingml/2006/main"/>
           <a:p xmlns:a="http://schemas.openxmlformats.org/drawingml/2006/main">
             <a:pPr algn="l">
+              <a:buNone/>
               <a:defRPr sz="1125" b="0">
                 <a:solidFill>
                   <a:srgbClr val="101820"/>
@@ -6279,6 +6337,7 @@
           <a:lstStyle xmlns:a="http://schemas.openxmlformats.org/drawingml/2006/main"/>
           <a:p xmlns:a="http://schemas.openxmlformats.org/drawingml/2006/main">
             <a:pPr algn="l">
+              <a:buNone/>
               <a:defRPr sz="1200" b="1">
                 <a:solidFill>
                   <a:srgbClr val="101820"/>
@@ -6335,6 +6394,7 @@
           <a:lstStyle xmlns:a="http://schemas.openxmlformats.org/drawingml/2006/main"/>
           <a:p xmlns:a="http://schemas.openxmlformats.org/drawingml/2006/main">
             <a:pPr algn="l">
+              <a:buNone/>
               <a:defRPr sz="1125" b="0">
                 <a:solidFill>
                   <a:srgbClr val="59636E"/>
@@ -6391,6 +6451,7 @@
           <a:lstStyle xmlns:a="http://schemas.openxmlformats.org/drawingml/2006/main"/>
           <a:p xmlns:a="http://schemas.openxmlformats.org/drawingml/2006/main">
             <a:pPr algn="l">
+              <a:buNone/>
               <a:defRPr sz="1125" b="0">
                 <a:solidFill>
                   <a:srgbClr val="101820"/>
@@ -6476,6 +6537,7 @@
           <a:lstStyle xmlns:a="http://schemas.openxmlformats.org/drawingml/2006/main"/>
           <a:p xmlns:a="http://schemas.openxmlformats.org/drawingml/2006/main">
             <a:pPr algn="l">
+              <a:buNone/>
               <a:defRPr sz="900" b="1">
                 <a:solidFill>
                   <a:srgbClr val="2D8CFF"/>
@@ -6532,6 +6594,7 @@
           <a:lstStyle xmlns:a="http://schemas.openxmlformats.org/drawingml/2006/main"/>
           <a:p xmlns:a="http://schemas.openxmlformats.org/drawingml/2006/main">
             <a:pPr algn="l">
+              <a:buNone/>
               <a:defRPr sz="2700" b="1">
                 <a:solidFill>
                   <a:srgbClr val="101820"/>
@@ -6621,6 +6684,7 @@
           <a:lstStyle xmlns:a="http://schemas.openxmlformats.org/drawingml/2006/main"/>
           <a:p xmlns:a="http://schemas.openxmlformats.org/drawingml/2006/main">
             <a:pPr algn="l">
+              <a:buNone/>
               <a:defRPr sz="750" b="1">
                 <a:solidFill>
                   <a:srgbClr val="59636E"/>
@@ -6677,6 +6741,7 @@
           <a:lstStyle xmlns:a="http://schemas.openxmlformats.org/drawingml/2006/main"/>
           <a:p xmlns:a="http://schemas.openxmlformats.org/drawingml/2006/main">
             <a:pPr algn="r">
+              <a:buNone/>
               <a:defRPr sz="900" b="1">
                 <a:solidFill>
                   <a:srgbClr val="59636E"/>
@@ -6733,6 +6798,7 @@
           <a:lstStyle xmlns:a="http://schemas.openxmlformats.org/drawingml/2006/main"/>
           <a:p xmlns:a="http://schemas.openxmlformats.org/drawingml/2006/main">
             <a:pPr algn="l">
+              <a:buNone/>
               <a:defRPr sz="900" b="1">
                 <a:solidFill>
                   <a:srgbClr val="2D8CFF"/>
@@ -6793,14 +6859,14 @@
       </p:sp>
       <p:pic>
         <p:nvPicPr>
-          <p:cNvPr id="25" name=""/>
+          <p:cNvPr id="27" name=""/>
           <p:cNvPicPr>
             <a:picLocks xmlns:a="http://schemas.openxmlformats.org/drawingml/2006/main" noChangeAspect="1"/>
           </p:cNvPicPr>
           <p:nvPr/>
         </p:nvPicPr>
         <p:blipFill>
-          <a:blip xmlns:r="http://schemas.openxmlformats.org/officeDocument/2006/relationships" xmlns:a="http://schemas.openxmlformats.org/drawingml/2006/main" r:embed="Rad5d39a910ab4c25"/>
+          <a:blip xmlns:r="http://schemas.openxmlformats.org/officeDocument/2006/relationships" xmlns:a="http://schemas.openxmlformats.org/drawingml/2006/main" r:embed="R369d0f25f61349b0"/>
           <a:srcRect xmlns:a="http://schemas.openxmlformats.org/drawingml/2006/main" l="0" t="4048" r="0" b="4048"/>
           <a:stretch xmlns:a="http://schemas.openxmlformats.org/drawingml/2006/main">
             <a:fillRect l="0" t="0" r="0" b="0"/>
@@ -6886,6 +6952,7 @@
           <a:lstStyle xmlns:a="http://schemas.openxmlformats.org/drawingml/2006/main"/>
           <a:p xmlns:a="http://schemas.openxmlformats.org/drawingml/2006/main">
             <a:pPr algn="ctr">
+              <a:buNone/>
               <a:defRPr sz="1050" b="1">
                 <a:solidFill>
                   <a:srgbClr val="E79A54"/>
@@ -6942,6 +7009,7 @@
           <a:lstStyle xmlns:a="http://schemas.openxmlformats.org/drawingml/2006/main"/>
           <a:p xmlns:a="http://schemas.openxmlformats.org/drawingml/2006/main">
             <a:pPr algn="l">
+              <a:buNone/>
               <a:defRPr sz="1050" b="1">
                 <a:solidFill>
                   <a:srgbClr val="59636E"/>
@@ -6998,6 +7066,7 @@
           <a:lstStyle xmlns:a="http://schemas.openxmlformats.org/drawingml/2006/main"/>
           <a:p xmlns:a="http://schemas.openxmlformats.org/drawingml/2006/main">
             <a:pPr algn="l">
+              <a:buNone/>
               <a:defRPr sz="1350" b="1">
                 <a:solidFill>
                   <a:srgbClr val="1B5964"/>
@@ -7054,6 +7123,7 @@
           <a:lstStyle xmlns:a="http://schemas.openxmlformats.org/drawingml/2006/main"/>
           <a:p xmlns:a="http://schemas.openxmlformats.org/drawingml/2006/main">
             <a:pPr algn="l">
+              <a:buNone/>
               <a:defRPr sz="1050" b="1">
                 <a:solidFill>
                   <a:srgbClr val="59636E"/>
@@ -7110,6 +7180,7 @@
           <a:lstStyle xmlns:a="http://schemas.openxmlformats.org/drawingml/2006/main"/>
           <a:p xmlns:a="http://schemas.openxmlformats.org/drawingml/2006/main">
             <a:pPr algn="l">
+              <a:buNone/>
               <a:defRPr sz="1500" b="1">
                 <a:solidFill>
                   <a:srgbClr val="101820"/>
@@ -7133,6 +7204,7 @@
           </a:p>
           <a:p xmlns:a="http://schemas.openxmlformats.org/drawingml/2006/main">
             <a:pPr algn="l">
+              <a:buNone/>
               <a:defRPr sz="1500" b="1">
                 <a:solidFill>
                   <a:srgbClr val="101820"/>
@@ -7224,6 +7296,7 @@
           <a:lstStyle xmlns:a="http://schemas.openxmlformats.org/drawingml/2006/main"/>
           <a:p xmlns:a="http://schemas.openxmlformats.org/drawingml/2006/main">
             <a:pPr algn="ctr">
+              <a:buNone/>
               <a:defRPr sz="1350" b="1">
                 <a:solidFill>
                   <a:srgbClr val="2D8CFF"/>
@@ -7280,6 +7353,7 @@
           <a:lstStyle xmlns:a="http://schemas.openxmlformats.org/drawingml/2006/main"/>
           <a:p xmlns:a="http://schemas.openxmlformats.org/drawingml/2006/main">
             <a:pPr algn="l">
+              <a:buNone/>
               <a:defRPr sz="900" b="1">
                 <a:solidFill>
                   <a:srgbClr val="2D8CFF"/>
@@ -7365,6 +7439,7 @@
           <a:lstStyle xmlns:a="http://schemas.openxmlformats.org/drawingml/2006/main"/>
           <a:p xmlns:a="http://schemas.openxmlformats.org/drawingml/2006/main">
             <a:pPr algn="l">
+              <a:buNone/>
               <a:defRPr sz="975" b="1">
                 <a:solidFill>
                   <a:srgbClr val="2D8CFF"/>
@@ -7421,6 +7496,7 @@
           <a:lstStyle xmlns:a="http://schemas.openxmlformats.org/drawingml/2006/main"/>
           <a:p xmlns:a="http://schemas.openxmlformats.org/drawingml/2006/main">
             <a:pPr algn="l">
+              <a:buNone/>
               <a:defRPr sz="3900" b="1">
                 <a:solidFill>
                   <a:srgbClr val="101820"/>
@@ -7481,6 +7557,7 @@
           <a:lstStyle xmlns:a="http://schemas.openxmlformats.org/drawingml/2006/main"/>
           <a:p xmlns:a="http://schemas.openxmlformats.org/drawingml/2006/main">
             <a:pPr algn="ctr">
+              <a:buNone/>
               <a:defRPr sz="1425" b="1">
                 <a:solidFill>
                   <a:srgbClr val="FFFFFF"/>
@@ -7537,6 +7614,7 @@
           <a:lstStyle xmlns:a="http://schemas.openxmlformats.org/drawingml/2006/main"/>
           <a:p xmlns:a="http://schemas.openxmlformats.org/drawingml/2006/main">
             <a:pPr algn="l">
+              <a:buNone/>
               <a:defRPr sz="1575" b="0">
                 <a:solidFill>
                   <a:srgbClr val="101820"/>
@@ -7597,6 +7675,7 @@
           <a:lstStyle xmlns:a="http://schemas.openxmlformats.org/drawingml/2006/main"/>
           <a:p xmlns:a="http://schemas.openxmlformats.org/drawingml/2006/main">
             <a:pPr algn="ctr">
+              <a:buNone/>
               <a:defRPr sz="1425" b="1">
                 <a:solidFill>
                   <a:srgbClr val="FFFFFF"/>
@@ -7653,6 +7732,7 @@
           <a:lstStyle xmlns:a="http://schemas.openxmlformats.org/drawingml/2006/main"/>
           <a:p xmlns:a="http://schemas.openxmlformats.org/drawingml/2006/main">
             <a:pPr algn="l">
+              <a:buNone/>
               <a:defRPr sz="1575" b="0">
                 <a:solidFill>
                   <a:srgbClr val="101820"/>
@@ -7713,6 +7793,7 @@
           <a:lstStyle xmlns:a="http://schemas.openxmlformats.org/drawingml/2006/main"/>
           <a:p xmlns:a="http://schemas.openxmlformats.org/drawingml/2006/main">
             <a:pPr algn="ctr">
+              <a:buNone/>
               <a:defRPr sz="1425" b="1">
                 <a:solidFill>
                   <a:srgbClr val="FFFFFF"/>
@@ -7769,6 +7850,7 @@
           <a:lstStyle xmlns:a="http://schemas.openxmlformats.org/drawingml/2006/main"/>
           <a:p xmlns:a="http://schemas.openxmlformats.org/drawingml/2006/main">
             <a:pPr algn="l">
+              <a:buNone/>
               <a:defRPr sz="1575" b="0">
                 <a:solidFill>
                   <a:srgbClr val="101820"/>
@@ -7829,6 +7911,7 @@
           <a:lstStyle xmlns:a="http://schemas.openxmlformats.org/drawingml/2006/main"/>
           <a:p xmlns:a="http://schemas.openxmlformats.org/drawingml/2006/main">
             <a:pPr algn="ctr">
+              <a:buNone/>
               <a:defRPr sz="1425" b="1">
                 <a:solidFill>
                   <a:srgbClr val="FFFFFF"/>
@@ -7885,6 +7968,7 @@
           <a:lstStyle xmlns:a="http://schemas.openxmlformats.org/drawingml/2006/main"/>
           <a:p xmlns:a="http://schemas.openxmlformats.org/drawingml/2006/main">
             <a:pPr algn="l">
+              <a:buNone/>
               <a:defRPr sz="1575" b="1">
                 <a:solidFill>
                   <a:srgbClr val="1B5964"/>
@@ -7945,6 +8029,7 @@
           <a:lstStyle xmlns:a="http://schemas.openxmlformats.org/drawingml/2006/main"/>
           <a:p xmlns:a="http://schemas.openxmlformats.org/drawingml/2006/main">
             <a:pPr algn="ctr">
+              <a:buNone/>
               <a:defRPr sz="1425" b="1">
                 <a:solidFill>
                   <a:srgbClr val="FFFFFF"/>
@@ -8001,6 +8086,7 @@
           <a:lstStyle xmlns:a="http://schemas.openxmlformats.org/drawingml/2006/main"/>
           <a:p xmlns:a="http://schemas.openxmlformats.org/drawingml/2006/main">
             <a:pPr algn="l">
+              <a:buNone/>
               <a:defRPr sz="1575" b="0">
                 <a:solidFill>
                   <a:srgbClr val="101820"/>
@@ -8092,6 +8178,7 @@
           <a:lstStyle xmlns:a="http://schemas.openxmlformats.org/drawingml/2006/main"/>
           <a:p xmlns:a="http://schemas.openxmlformats.org/drawingml/2006/main">
             <a:pPr algn="ctr">
+              <a:buNone/>
               <a:defRPr sz="1500" b="1">
                 <a:solidFill>
                   <a:srgbClr val="FFFFFF"/>
@@ -8148,6 +8235,7 @@
           <a:lstStyle xmlns:a="http://schemas.openxmlformats.org/drawingml/2006/main"/>
           <a:p xmlns:a="http://schemas.openxmlformats.org/drawingml/2006/main">
             <a:pPr algn="ctr">
+              <a:buNone/>
               <a:defRPr sz="2475" b="1">
                 <a:solidFill>
                   <a:srgbClr val="FFFFFF"/>
@@ -8171,6 +8259,7 @@
           </a:p>
           <a:p xmlns:a="http://schemas.openxmlformats.org/drawingml/2006/main">
             <a:pPr algn="ctr">
+              <a:buNone/>
               <a:defRPr sz="2475" b="1">
                 <a:solidFill>
                   <a:srgbClr val="FFFFFF"/>
@@ -8194,6 +8283,7 @@
           </a:p>
           <a:p xmlns:a="http://schemas.openxmlformats.org/drawingml/2006/main">
             <a:pPr algn="ctr">
+              <a:buNone/>
               <a:defRPr sz="2475" b="1">
                 <a:solidFill>
                   <a:srgbClr val="FFFFFF"/>
@@ -8250,6 +8340,7 @@
           <a:lstStyle xmlns:a="http://schemas.openxmlformats.org/drawingml/2006/main"/>
           <a:p xmlns:a="http://schemas.openxmlformats.org/drawingml/2006/main">
             <a:pPr algn="ctr">
+              <a:buNone/>
               <a:defRPr sz="1125" b="0">
                 <a:solidFill>
                   <a:srgbClr val="DCEBFF"/>
@@ -8273,6 +8364,7 @@
           </a:p>
           <a:p xmlns:a="http://schemas.openxmlformats.org/drawingml/2006/main">
             <a:pPr algn="ctr">
+              <a:buNone/>
               <a:defRPr sz="1125" b="0">
                 <a:solidFill>
                   <a:srgbClr val="DCEBFF"/>
@@ -8362,6 +8454,7 @@
           <a:lstStyle xmlns:a="http://schemas.openxmlformats.org/drawingml/2006/main"/>
           <a:p xmlns:a="http://schemas.openxmlformats.org/drawingml/2006/main">
             <a:pPr algn="l">
+              <a:buNone/>
               <a:defRPr sz="750" b="1">
                 <a:solidFill>
                   <a:srgbClr val="59636E"/>
@@ -8418,6 +8511,7 @@
           <a:lstStyle xmlns:a="http://schemas.openxmlformats.org/drawingml/2006/main"/>
           <a:p xmlns:a="http://schemas.openxmlformats.org/drawingml/2006/main">
             <a:pPr algn="r">
+              <a:buNone/>
               <a:defRPr sz="900" b="1">
                 <a:solidFill>
                   <a:srgbClr val="59636E"/>
@@ -8503,6 +8597,7 @@
           <a:lstStyle xmlns:a="http://schemas.openxmlformats.org/drawingml/2006/main"/>
           <a:p xmlns:a="http://schemas.openxmlformats.org/drawingml/2006/main">
             <a:pPr algn="l">
+              <a:buNone/>
               <a:defRPr sz="900" b="1">
                 <a:solidFill>
                   <a:srgbClr val="2D8CFF"/>
@@ -8559,6 +8654,7 @@
           <a:lstStyle xmlns:a="http://schemas.openxmlformats.org/drawingml/2006/main"/>
           <a:p xmlns:a="http://schemas.openxmlformats.org/drawingml/2006/main">
             <a:pPr algn="l">
+              <a:buNone/>
               <a:defRPr sz="3300" b="1">
                 <a:solidFill>
                   <a:srgbClr val="101820"/>
@@ -8648,6 +8744,7 @@
           <a:lstStyle xmlns:a="http://schemas.openxmlformats.org/drawingml/2006/main"/>
           <a:p xmlns:a="http://schemas.openxmlformats.org/drawingml/2006/main">
             <a:pPr algn="l">
+              <a:buNone/>
               <a:defRPr sz="750" b="1">
                 <a:solidFill>
                   <a:srgbClr val="59636E"/>
@@ -8704,6 +8801,7 @@
           <a:lstStyle xmlns:a="http://schemas.openxmlformats.org/drawingml/2006/main"/>
           <a:p xmlns:a="http://schemas.openxmlformats.org/drawingml/2006/main">
             <a:pPr algn="r">
+              <a:buNone/>
               <a:defRPr sz="900" b="1">
                 <a:solidFill>
                   <a:srgbClr val="59636E"/>
@@ -8760,6 +8858,7 @@
           <a:lstStyle xmlns:a="http://schemas.openxmlformats.org/drawingml/2006/main"/>
           <a:p xmlns:a="http://schemas.openxmlformats.org/drawingml/2006/main">
             <a:pPr algn="l">
+              <a:buNone/>
               <a:defRPr sz="900" b="1">
                 <a:solidFill>
                   <a:srgbClr val="2D8CFF"/>
@@ -8855,6 +8954,7 @@
           <a:lstStyle xmlns:a="http://schemas.openxmlformats.org/drawingml/2006/main"/>
           <a:p xmlns:a="http://schemas.openxmlformats.org/drawingml/2006/main">
             <a:pPr algn="ctr">
+              <a:buNone/>
               <a:defRPr sz="1200" b="1">
                 <a:solidFill>
                   <a:srgbClr val="FFFFFF"/>
@@ -8911,6 +9011,7 @@
           <a:lstStyle xmlns:a="http://schemas.openxmlformats.org/drawingml/2006/main"/>
           <a:p xmlns:a="http://schemas.openxmlformats.org/drawingml/2006/main">
             <a:pPr algn="l">
+              <a:buNone/>
               <a:defRPr sz="1500" b="1">
                 <a:solidFill>
                   <a:srgbClr val="101820"/>
@@ -8967,6 +9068,7 @@
           <a:lstStyle xmlns:a="http://schemas.openxmlformats.org/drawingml/2006/main"/>
           <a:p xmlns:a="http://schemas.openxmlformats.org/drawingml/2006/main">
             <a:pPr algn="l">
+              <a:buNone/>
               <a:defRPr sz="1200" b="0">
                 <a:solidFill>
                   <a:srgbClr val="59636E"/>
@@ -9062,6 +9164,7 @@
           <a:lstStyle xmlns:a="http://schemas.openxmlformats.org/drawingml/2006/main"/>
           <a:p xmlns:a="http://schemas.openxmlformats.org/drawingml/2006/main">
             <a:pPr algn="ctr">
+              <a:buNone/>
               <a:defRPr sz="1200" b="1">
                 <a:solidFill>
                   <a:srgbClr val="FFFFFF"/>
@@ -9118,6 +9221,7 @@
           <a:lstStyle xmlns:a="http://schemas.openxmlformats.org/drawingml/2006/main"/>
           <a:p xmlns:a="http://schemas.openxmlformats.org/drawingml/2006/main">
             <a:pPr algn="l">
+              <a:buNone/>
               <a:defRPr sz="1500" b="1">
                 <a:solidFill>
                   <a:srgbClr val="101820"/>
@@ -9174,6 +9278,7 @@
           <a:lstStyle xmlns:a="http://schemas.openxmlformats.org/drawingml/2006/main"/>
           <a:p xmlns:a="http://schemas.openxmlformats.org/drawingml/2006/main">
             <a:pPr algn="l">
+              <a:buNone/>
               <a:defRPr sz="1200" b="0">
                 <a:solidFill>
                   <a:srgbClr val="59636E"/>
@@ -9269,6 +9374,7 @@
           <a:lstStyle xmlns:a="http://schemas.openxmlformats.org/drawingml/2006/main"/>
           <a:p xmlns:a="http://schemas.openxmlformats.org/drawingml/2006/main">
             <a:pPr algn="ctr">
+              <a:buNone/>
               <a:defRPr sz="1200" b="1">
                 <a:solidFill>
                   <a:srgbClr val="FFFFFF"/>
@@ -9325,6 +9431,7 @@
           <a:lstStyle xmlns:a="http://schemas.openxmlformats.org/drawingml/2006/main"/>
           <a:p xmlns:a="http://schemas.openxmlformats.org/drawingml/2006/main">
             <a:pPr algn="l">
+              <a:buNone/>
               <a:defRPr sz="1500" b="1">
                 <a:solidFill>
                   <a:srgbClr val="101820"/>
@@ -9381,6 +9488,7 @@
           <a:lstStyle xmlns:a="http://schemas.openxmlformats.org/drawingml/2006/main"/>
           <a:p xmlns:a="http://schemas.openxmlformats.org/drawingml/2006/main">
             <a:pPr algn="l">
+              <a:buNone/>
               <a:defRPr sz="1200" b="0">
                 <a:solidFill>
                   <a:srgbClr val="59636E"/>
@@ -9476,6 +9584,7 @@
           <a:lstStyle xmlns:a="http://schemas.openxmlformats.org/drawingml/2006/main"/>
           <a:p xmlns:a="http://schemas.openxmlformats.org/drawingml/2006/main">
             <a:pPr algn="ctr">
+              <a:buNone/>
               <a:defRPr sz="1200" b="1">
                 <a:solidFill>
                   <a:srgbClr val="FFFFFF"/>
@@ -9532,6 +9641,7 @@
           <a:lstStyle xmlns:a="http://schemas.openxmlformats.org/drawingml/2006/main"/>
           <a:p xmlns:a="http://schemas.openxmlformats.org/drawingml/2006/main">
             <a:pPr algn="l">
+              <a:buNone/>
               <a:defRPr sz="1500" b="1">
                 <a:solidFill>
                   <a:srgbClr val="101820"/>
@@ -9588,6 +9698,7 @@
           <a:lstStyle xmlns:a="http://schemas.openxmlformats.org/drawingml/2006/main"/>
           <a:p xmlns:a="http://schemas.openxmlformats.org/drawingml/2006/main">
             <a:pPr algn="l">
+              <a:buNone/>
               <a:defRPr sz="1200" b="0">
                 <a:solidFill>
                   <a:srgbClr val="59636E"/>
@@ -9679,6 +9790,7 @@
           <a:lstStyle xmlns:a="http://schemas.openxmlformats.org/drawingml/2006/main"/>
           <a:p xmlns:a="http://schemas.openxmlformats.org/drawingml/2006/main">
             <a:pPr algn="ctr">
+              <a:buNone/>
               <a:defRPr sz="1725" b="1">
                 <a:solidFill>
                   <a:srgbClr val="B4382C"/>
@@ -9764,6 +9876,7 @@
           <a:lstStyle xmlns:a="http://schemas.openxmlformats.org/drawingml/2006/main"/>
           <a:p xmlns:a="http://schemas.openxmlformats.org/drawingml/2006/main">
             <a:pPr algn="l">
+              <a:buNone/>
               <a:defRPr sz="900" b="1">
                 <a:solidFill>
                   <a:srgbClr val="2D8CFF"/>
@@ -9820,6 +9933,7 @@
           <a:lstStyle xmlns:a="http://schemas.openxmlformats.org/drawingml/2006/main"/>
           <a:p xmlns:a="http://schemas.openxmlformats.org/drawingml/2006/main">
             <a:pPr algn="l">
+              <a:buNone/>
               <a:defRPr sz="3300" b="1">
                 <a:solidFill>
                   <a:srgbClr val="101820"/>
@@ -9909,6 +10023,7 @@
           <a:lstStyle xmlns:a="http://schemas.openxmlformats.org/drawingml/2006/main"/>
           <a:p xmlns:a="http://schemas.openxmlformats.org/drawingml/2006/main">
             <a:pPr algn="l">
+              <a:buNone/>
               <a:defRPr sz="750" b="1">
                 <a:solidFill>
                   <a:srgbClr val="59636E"/>
@@ -9965,6 +10080,7 @@
           <a:lstStyle xmlns:a="http://schemas.openxmlformats.org/drawingml/2006/main"/>
           <a:p xmlns:a="http://schemas.openxmlformats.org/drawingml/2006/main">
             <a:pPr algn="r">
+              <a:buNone/>
               <a:defRPr sz="900" b="1">
                 <a:solidFill>
                   <a:srgbClr val="59636E"/>
@@ -10091,6 +10207,7 @@
           <a:lstStyle xmlns:a="http://schemas.openxmlformats.org/drawingml/2006/main"/>
           <a:p xmlns:a="http://schemas.openxmlformats.org/drawingml/2006/main">
             <a:pPr algn="ctr">
+              <a:buNone/>
               <a:defRPr sz="1050" b="1">
                 <a:solidFill>
                   <a:srgbClr val="2D8CFF"/>
@@ -10147,6 +10264,7 @@
           <a:lstStyle xmlns:a="http://schemas.openxmlformats.org/drawingml/2006/main"/>
           <a:p xmlns:a="http://schemas.openxmlformats.org/drawingml/2006/main">
             <a:pPr algn="l">
+              <a:buNone/>
               <a:defRPr sz="1425" b="1">
                 <a:solidFill>
                   <a:srgbClr val="101820"/>
@@ -10203,6 +10321,7 @@
           <a:lstStyle xmlns:a="http://schemas.openxmlformats.org/drawingml/2006/main"/>
           <a:p xmlns:a="http://schemas.openxmlformats.org/drawingml/2006/main">
             <a:pPr algn="l">
+              <a:buNone/>
               <a:defRPr sz="1050" b="0">
                 <a:solidFill>
                   <a:srgbClr val="59636E"/>
@@ -10329,6 +10448,7 @@
           <a:lstStyle xmlns:a="http://schemas.openxmlformats.org/drawingml/2006/main"/>
           <a:p xmlns:a="http://schemas.openxmlformats.org/drawingml/2006/main">
             <a:pPr algn="ctr">
+              <a:buNone/>
               <a:defRPr sz="1050" b="1">
                 <a:solidFill>
                   <a:srgbClr val="2D8CFF"/>
@@ -10385,6 +10505,7 @@
           <a:lstStyle xmlns:a="http://schemas.openxmlformats.org/drawingml/2006/main"/>
           <a:p xmlns:a="http://schemas.openxmlformats.org/drawingml/2006/main">
             <a:pPr algn="l">
+              <a:buNone/>
               <a:defRPr sz="1425" b="1">
                 <a:solidFill>
                   <a:srgbClr val="101820"/>
@@ -10441,6 +10562,7 @@
           <a:lstStyle xmlns:a="http://schemas.openxmlformats.org/drawingml/2006/main"/>
           <a:p xmlns:a="http://schemas.openxmlformats.org/drawingml/2006/main">
             <a:pPr algn="l">
+              <a:buNone/>
               <a:defRPr sz="1050" b="0">
                 <a:solidFill>
                   <a:srgbClr val="59636E"/>
@@ -10567,6 +10689,7 @@
           <a:lstStyle xmlns:a="http://schemas.openxmlformats.org/drawingml/2006/main"/>
           <a:p xmlns:a="http://schemas.openxmlformats.org/drawingml/2006/main">
             <a:pPr algn="ctr">
+              <a:buNone/>
               <a:defRPr sz="1050" b="1">
                 <a:solidFill>
                   <a:srgbClr val="E79A54"/>
@@ -10623,6 +10746,7 @@
           <a:lstStyle xmlns:a="http://schemas.openxmlformats.org/drawingml/2006/main"/>
           <a:p xmlns:a="http://schemas.openxmlformats.org/drawingml/2006/main">
             <a:pPr algn="l">
+              <a:buNone/>
               <a:defRPr sz="1425" b="1">
                 <a:solidFill>
                   <a:srgbClr val="101820"/>
@@ -10679,6 +10803,7 @@
           <a:lstStyle xmlns:a="http://schemas.openxmlformats.org/drawingml/2006/main"/>
           <a:p xmlns:a="http://schemas.openxmlformats.org/drawingml/2006/main">
             <a:pPr algn="l">
+              <a:buNone/>
               <a:defRPr sz="1050" b="0">
                 <a:solidFill>
                   <a:srgbClr val="59636E"/>
@@ -10770,6 +10895,7 @@
           <a:lstStyle xmlns:a="http://schemas.openxmlformats.org/drawingml/2006/main"/>
           <a:p xmlns:a="http://schemas.openxmlformats.org/drawingml/2006/main">
             <a:pPr algn="l">
+              <a:buNone/>
               <a:defRPr sz="2025" b="1">
                 <a:solidFill>
                   <a:srgbClr val="FFFFFF"/>
@@ -10826,6 +10952,7 @@
           <a:lstStyle xmlns:a="http://schemas.openxmlformats.org/drawingml/2006/main"/>
           <a:p xmlns:a="http://schemas.openxmlformats.org/drawingml/2006/main">
             <a:pPr algn="l">
+              <a:buNone/>
               <a:defRPr sz="975" b="1">
                 <a:solidFill>
                   <a:srgbClr val="A8D5DA"/>
@@ -10882,6 +11009,7 @@
           <a:lstStyle xmlns:a="http://schemas.openxmlformats.org/drawingml/2006/main"/>
           <a:p xmlns:a="http://schemas.openxmlformats.org/drawingml/2006/main">
             <a:pPr algn="l">
+              <a:buNone/>
               <a:defRPr sz="1500" b="0">
                 <a:solidFill>
                   <a:srgbClr val="FFFFFF"/>
@@ -10938,6 +11066,7 @@
           <a:lstStyle xmlns:a="http://schemas.openxmlformats.org/drawingml/2006/main"/>
           <a:p xmlns:a="http://schemas.openxmlformats.org/drawingml/2006/main">
             <a:pPr algn="l">
+              <a:buNone/>
               <a:defRPr sz="975" b="1">
                 <a:solidFill>
                   <a:srgbClr val="A8D5DA"/>
@@ -10994,6 +11123,7 @@
           <a:lstStyle xmlns:a="http://schemas.openxmlformats.org/drawingml/2006/main"/>
           <a:p xmlns:a="http://schemas.openxmlformats.org/drawingml/2006/main">
             <a:pPr algn="l">
+              <a:buNone/>
               <a:defRPr sz="1425" b="0">
                 <a:solidFill>
                   <a:srgbClr val="FFFFFF"/>
@@ -11085,6 +11215,7 @@
           <a:lstStyle xmlns:a="http://schemas.openxmlformats.org/drawingml/2006/main"/>
           <a:p xmlns:a="http://schemas.openxmlformats.org/drawingml/2006/main">
             <a:pPr algn="ctr">
+              <a:buNone/>
               <a:defRPr sz="1050" b="1">
                 <a:solidFill>
                   <a:srgbClr val="B4382C"/>
@@ -11170,6 +11301,7 @@
           <a:lstStyle xmlns:a="http://schemas.openxmlformats.org/drawingml/2006/main"/>
           <a:p xmlns:a="http://schemas.openxmlformats.org/drawingml/2006/main">
             <a:pPr algn="l">
+              <a:buNone/>
               <a:defRPr sz="900" b="1">
                 <a:solidFill>
                   <a:srgbClr val="2D8CFF"/>
@@ -11226,6 +11358,7 @@
           <a:lstStyle xmlns:a="http://schemas.openxmlformats.org/drawingml/2006/main"/>
           <a:p xmlns:a="http://schemas.openxmlformats.org/drawingml/2006/main">
             <a:pPr algn="l">
+              <a:buNone/>
               <a:defRPr sz="3300" b="1">
                 <a:solidFill>
                   <a:srgbClr val="101820"/>
@@ -11315,6 +11448,7 @@
           <a:lstStyle xmlns:a="http://schemas.openxmlformats.org/drawingml/2006/main"/>
           <a:p xmlns:a="http://schemas.openxmlformats.org/drawingml/2006/main">
             <a:pPr algn="l">
+              <a:buNone/>
               <a:defRPr sz="750" b="1">
                 <a:solidFill>
                   <a:srgbClr val="59636E"/>
@@ -11371,6 +11505,7 @@
           <a:lstStyle xmlns:a="http://schemas.openxmlformats.org/drawingml/2006/main"/>
           <a:p xmlns:a="http://schemas.openxmlformats.org/drawingml/2006/main">
             <a:pPr algn="r">
+              <a:buNone/>
               <a:defRPr sz="900" b="1">
                 <a:solidFill>
                   <a:srgbClr val="59636E"/>
@@ -11427,6 +11562,7 @@
           <a:lstStyle xmlns:a="http://schemas.openxmlformats.org/drawingml/2006/main"/>
           <a:p xmlns:a="http://schemas.openxmlformats.org/drawingml/2006/main">
             <a:pPr algn="l">
+              <a:buNone/>
               <a:defRPr sz="900" b="1">
                 <a:solidFill>
                   <a:srgbClr val="2D8CFF"/>
@@ -11487,14 +11623,14 @@
       </p:sp>
       <p:pic>
         <p:nvPicPr>
-          <p:cNvPr id="25" name=""/>
+          <p:cNvPr id="27" name=""/>
           <p:cNvPicPr>
             <a:picLocks xmlns:a="http://schemas.openxmlformats.org/drawingml/2006/main" noChangeAspect="1"/>
           </p:cNvPicPr>
           <p:nvPr/>
         </p:nvPicPr>
         <p:blipFill>
-          <a:blip xmlns:r="http://schemas.openxmlformats.org/officeDocument/2006/relationships" xmlns:a="http://schemas.openxmlformats.org/drawingml/2006/main" r:embed="R5b06538b8e1e4f9e"/>
+          <a:blip xmlns:r="http://schemas.openxmlformats.org/officeDocument/2006/relationships" xmlns:a="http://schemas.openxmlformats.org/drawingml/2006/main" r:embed="R078d4a8c10364fdf"/>
           <a:srcRect xmlns:a="http://schemas.openxmlformats.org/drawingml/2006/main" l="0" t="4073" r="0" b="4073"/>
           <a:stretch xmlns:a="http://schemas.openxmlformats.org/drawingml/2006/main">
             <a:fillRect l="0" t="0" r="0" b="0"/>
@@ -11545,6 +11681,7 @@
           <a:lstStyle xmlns:a="http://schemas.openxmlformats.org/drawingml/2006/main"/>
           <a:p xmlns:a="http://schemas.openxmlformats.org/drawingml/2006/main">
             <a:pPr algn="l">
+              <a:buNone/>
               <a:defRPr sz="1800" b="1">
                 <a:solidFill>
                   <a:srgbClr val="1B5964"/>
@@ -11568,6 +11705,7 @@
           </a:p>
           <a:p xmlns:a="http://schemas.openxmlformats.org/drawingml/2006/main">
             <a:pPr algn="l">
+              <a:buNone/>
               <a:defRPr sz="1800" b="1">
                 <a:solidFill>
                   <a:srgbClr val="1B5964"/>
@@ -11591,6 +11729,7 @@
           </a:p>
           <a:p xmlns:a="http://schemas.openxmlformats.org/drawingml/2006/main">
             <a:pPr algn="l">
+              <a:buNone/>
               <a:defRPr sz="1800" b="1">
                 <a:solidFill>
                   <a:srgbClr val="1B5964"/>
@@ -11651,6 +11790,7 @@
           <a:lstStyle xmlns:a="http://schemas.openxmlformats.org/drawingml/2006/main"/>
           <a:p xmlns:a="http://schemas.openxmlformats.org/drawingml/2006/main">
             <a:pPr algn="ctr">
+              <a:buNone/>
               <a:defRPr sz="1200" b="1">
                 <a:solidFill>
                   <a:srgbClr val="FFFFFF"/>
@@ -11707,6 +11847,7 @@
           <a:lstStyle xmlns:a="http://schemas.openxmlformats.org/drawingml/2006/main"/>
           <a:p xmlns:a="http://schemas.openxmlformats.org/drawingml/2006/main">
             <a:pPr algn="l">
+              <a:buNone/>
               <a:defRPr sz="1350" b="0">
                 <a:solidFill>
                   <a:srgbClr val="101820"/>
@@ -11767,6 +11908,7 @@
           <a:lstStyle xmlns:a="http://schemas.openxmlformats.org/drawingml/2006/main"/>
           <a:p xmlns:a="http://schemas.openxmlformats.org/drawingml/2006/main">
             <a:pPr algn="ctr">
+              <a:buNone/>
               <a:defRPr sz="1200" b="1">
                 <a:solidFill>
                   <a:srgbClr val="FFFFFF"/>
@@ -11823,6 +11965,7 @@
           <a:lstStyle xmlns:a="http://schemas.openxmlformats.org/drawingml/2006/main"/>
           <a:p xmlns:a="http://schemas.openxmlformats.org/drawingml/2006/main">
             <a:pPr algn="l">
+              <a:buNone/>
               <a:defRPr sz="1350" b="0">
                 <a:solidFill>
                   <a:srgbClr val="101820"/>
@@ -11883,6 +12026,7 @@
           <a:lstStyle xmlns:a="http://schemas.openxmlformats.org/drawingml/2006/main"/>
           <a:p xmlns:a="http://schemas.openxmlformats.org/drawingml/2006/main">
             <a:pPr algn="ctr">
+              <a:buNone/>
               <a:defRPr sz="1200" b="1">
                 <a:solidFill>
                   <a:srgbClr val="FFFFFF"/>
@@ -11939,6 +12083,7 @@
           <a:lstStyle xmlns:a="http://schemas.openxmlformats.org/drawingml/2006/main"/>
           <a:p xmlns:a="http://schemas.openxmlformats.org/drawingml/2006/main">
             <a:pPr algn="l">
+              <a:buNone/>
               <a:defRPr sz="1350" b="0">
                 <a:solidFill>
                   <a:srgbClr val="101820"/>
@@ -12030,6 +12175,7 @@
           <a:lstStyle xmlns:a="http://schemas.openxmlformats.org/drawingml/2006/main"/>
           <a:p xmlns:a="http://schemas.openxmlformats.org/drawingml/2006/main">
             <a:pPr algn="ctr">
+              <a:buNone/>
               <a:defRPr sz="1050" b="1">
                 <a:solidFill>
                   <a:srgbClr val="1B5964"/>
@@ -12115,6 +12261,7 @@
           <a:lstStyle xmlns:a="http://schemas.openxmlformats.org/drawingml/2006/main"/>
           <a:p xmlns:a="http://schemas.openxmlformats.org/drawingml/2006/main">
             <a:pPr algn="l">
+              <a:buNone/>
               <a:defRPr sz="900" b="1">
                 <a:solidFill>
                   <a:srgbClr val="2D8CFF"/>
@@ -12171,6 +12318,7 @@
           <a:lstStyle xmlns:a="http://schemas.openxmlformats.org/drawingml/2006/main"/>
           <a:p xmlns:a="http://schemas.openxmlformats.org/drawingml/2006/main">
             <a:pPr algn="l">
+              <a:buNone/>
               <a:defRPr sz="3300" b="1">
                 <a:solidFill>
                   <a:srgbClr val="101820"/>
@@ -12260,6 +12408,7 @@
           <a:lstStyle xmlns:a="http://schemas.openxmlformats.org/drawingml/2006/main"/>
           <a:p xmlns:a="http://schemas.openxmlformats.org/drawingml/2006/main">
             <a:pPr algn="l">
+              <a:buNone/>
               <a:defRPr sz="750" b="1">
                 <a:solidFill>
                   <a:srgbClr val="59636E"/>
@@ -12316,6 +12465,7 @@
           <a:lstStyle xmlns:a="http://schemas.openxmlformats.org/drawingml/2006/main"/>
           <a:p xmlns:a="http://schemas.openxmlformats.org/drawingml/2006/main">
             <a:pPr algn="r">
+              <a:buNone/>
               <a:defRPr sz="900" b="1">
                 <a:solidFill>
                   <a:srgbClr val="59636E"/>
@@ -12376,14 +12526,14 @@
       </p:sp>
       <p:pic>
         <p:nvPicPr>
-          <p:cNvPr id="20" name=""/>
+          <p:cNvPr id="22" name=""/>
           <p:cNvPicPr>
             <a:picLocks xmlns:a="http://schemas.openxmlformats.org/drawingml/2006/main" noChangeAspect="1"/>
           </p:cNvPicPr>
           <p:nvPr/>
         </p:nvPicPr>
         <p:blipFill>
-          <a:blip xmlns:r="http://schemas.openxmlformats.org/officeDocument/2006/relationships" xmlns:a="http://schemas.openxmlformats.org/drawingml/2006/main" r:embed="R079d53d5ab7e4e05"/>
+          <a:blip xmlns:r="http://schemas.openxmlformats.org/officeDocument/2006/relationships" xmlns:a="http://schemas.openxmlformats.org/drawingml/2006/main" r:embed="Rce77e171be6c4ebc"/>
           <a:srcRect xmlns:a="http://schemas.openxmlformats.org/drawingml/2006/main" l="0" t="4073" r="0" b="4073"/>
           <a:stretch xmlns:a="http://schemas.openxmlformats.org/drawingml/2006/main">
             <a:fillRect l="0" t="0" r="0" b="0"/>
@@ -12469,6 +12619,7 @@
           <a:lstStyle xmlns:a="http://schemas.openxmlformats.org/drawingml/2006/main"/>
           <a:p xmlns:a="http://schemas.openxmlformats.org/drawingml/2006/main">
             <a:pPr algn="ctr">
+              <a:buNone/>
               <a:defRPr sz="1875" b="1">
                 <a:solidFill>
                   <a:srgbClr val="2D8CFF"/>
@@ -12492,6 +12643,7 @@
           </a:p>
           <a:p xmlns:a="http://schemas.openxmlformats.org/drawingml/2006/main">
             <a:pPr algn="ctr">
+              <a:buNone/>
               <a:defRPr sz="1875" b="1">
                 <a:solidFill>
                   <a:srgbClr val="2D8CFF"/>
@@ -12548,6 +12700,7 @@
           <a:lstStyle xmlns:a="http://schemas.openxmlformats.org/drawingml/2006/main"/>
           <a:p xmlns:a="http://schemas.openxmlformats.org/drawingml/2006/main">
             <a:pPr algn="l">
+              <a:buNone/>
               <a:defRPr sz="1875" b="1">
                 <a:solidFill>
                   <a:srgbClr val="B4382C"/>
@@ -12604,6 +12757,7 @@
           <a:lstStyle xmlns:a="http://schemas.openxmlformats.org/drawingml/2006/main"/>
           <a:p xmlns:a="http://schemas.openxmlformats.org/drawingml/2006/main">
             <a:pPr algn="l">
+              <a:buNone/>
               <a:defRPr sz="1425" b="0">
                 <a:solidFill>
                   <a:srgbClr val="101820"/>
@@ -12695,6 +12849,7 @@
           <a:lstStyle xmlns:a="http://schemas.openxmlformats.org/drawingml/2006/main"/>
           <a:p xmlns:a="http://schemas.openxmlformats.org/drawingml/2006/main">
             <a:pPr algn="ctr">
+              <a:buNone/>
               <a:defRPr sz="1125" b="1">
                 <a:solidFill>
                   <a:srgbClr val="1B5964"/>
@@ -12780,6 +12935,7 @@
           <a:lstStyle xmlns:a="http://schemas.openxmlformats.org/drawingml/2006/main"/>
           <a:p xmlns:a="http://schemas.openxmlformats.org/drawingml/2006/main">
             <a:pPr algn="l">
+              <a:buNone/>
               <a:defRPr sz="900" b="1">
                 <a:solidFill>
                   <a:srgbClr val="2D8CFF"/>
@@ -12836,6 +12992,7 @@
           <a:lstStyle xmlns:a="http://schemas.openxmlformats.org/drawingml/2006/main"/>
           <a:p xmlns:a="http://schemas.openxmlformats.org/drawingml/2006/main">
             <a:pPr algn="l">
+              <a:buNone/>
               <a:defRPr sz="3000" b="1">
                 <a:solidFill>
                   <a:srgbClr val="101820"/>
@@ -12892,6 +13049,7 @@
           <a:lstStyle xmlns:a="http://schemas.openxmlformats.org/drawingml/2006/main"/>
           <a:p xmlns:a="http://schemas.openxmlformats.org/drawingml/2006/main">
             <a:pPr algn="l">
+              <a:buNone/>
               <a:defRPr sz="3000" b="1">
                 <a:solidFill>
                   <a:srgbClr val="101820"/>
@@ -12981,6 +13139,7 @@
           <a:lstStyle xmlns:a="http://schemas.openxmlformats.org/drawingml/2006/main"/>
           <a:p xmlns:a="http://schemas.openxmlformats.org/drawingml/2006/main">
             <a:pPr algn="l">
+              <a:buNone/>
               <a:defRPr sz="750" b="1">
                 <a:solidFill>
                   <a:srgbClr val="59636E"/>
@@ -13037,6 +13196,7 @@
           <a:lstStyle xmlns:a="http://schemas.openxmlformats.org/drawingml/2006/main"/>
           <a:p xmlns:a="http://schemas.openxmlformats.org/drawingml/2006/main">
             <a:pPr algn="r">
+              <a:buNone/>
               <a:defRPr sz="900" b="1">
                 <a:solidFill>
                   <a:srgbClr val="59636E"/>
@@ -13093,6 +13253,7 @@
           <a:lstStyle xmlns:a="http://schemas.openxmlformats.org/drawingml/2006/main"/>
           <a:p xmlns:a="http://schemas.openxmlformats.org/drawingml/2006/main">
             <a:pPr algn="l">
+              <a:buNone/>
               <a:defRPr sz="900" b="1">
                 <a:solidFill>
                   <a:srgbClr val="2D8CFF"/>
@@ -13149,6 +13310,7 @@
           <a:lstStyle xmlns:a="http://schemas.openxmlformats.org/drawingml/2006/main"/>
           <a:p xmlns:a="http://schemas.openxmlformats.org/drawingml/2006/main">
             <a:pPr algn="l">
+              <a:buNone/>
               <a:defRPr sz="3000" b="1">
                 <a:solidFill>
                   <a:srgbClr val="101820"/>
@@ -13209,14 +13371,14 @@
       </p:sp>
       <p:pic>
         <p:nvPicPr>
-          <p:cNvPr id="33" name=""/>
+          <p:cNvPr id="35" name=""/>
           <p:cNvPicPr>
             <a:picLocks xmlns:a="http://schemas.openxmlformats.org/drawingml/2006/main" noChangeAspect="1"/>
           </p:cNvPicPr>
           <p:nvPr/>
         </p:nvPicPr>
         <p:blipFill>
-          <a:blip xmlns:r="http://schemas.openxmlformats.org/officeDocument/2006/relationships" xmlns:a="http://schemas.openxmlformats.org/drawingml/2006/main" r:embed="Rb3d1fbb0ed1b496f"/>
+          <a:blip xmlns:r="http://schemas.openxmlformats.org/officeDocument/2006/relationships" xmlns:a="http://schemas.openxmlformats.org/drawingml/2006/main" r:embed="R077116e77a15495a"/>
           <a:srcRect xmlns:a="http://schemas.openxmlformats.org/drawingml/2006/main" l="0" t="1023" r="0" b="1023"/>
           <a:stretch xmlns:a="http://schemas.openxmlformats.org/drawingml/2006/main">
             <a:fillRect l="0" t="0" r="0" b="0"/>
@@ -13267,6 +13429,7 @@
           <a:lstStyle xmlns:a="http://schemas.openxmlformats.org/drawingml/2006/main"/>
           <a:p xmlns:a="http://schemas.openxmlformats.org/drawingml/2006/main">
             <a:pPr algn="l">
+              <a:buNone/>
               <a:defRPr sz="1875" b="1">
                 <a:solidFill>
                   <a:srgbClr val="101820"/>
@@ -13327,6 +13490,7 @@
           <a:lstStyle xmlns:a="http://schemas.openxmlformats.org/drawingml/2006/main"/>
           <a:p xmlns:a="http://schemas.openxmlformats.org/drawingml/2006/main">
             <a:pPr algn="ctr">
+              <a:buNone/>
               <a:defRPr sz="1200" b="1">
                 <a:solidFill>
                   <a:srgbClr val="FFFFFF"/>
@@ -13383,6 +13547,7 @@
           <a:lstStyle xmlns:a="http://schemas.openxmlformats.org/drawingml/2006/main"/>
           <a:p xmlns:a="http://schemas.openxmlformats.org/drawingml/2006/main">
             <a:pPr algn="l">
+              <a:buNone/>
               <a:defRPr sz="1350" b="0">
                 <a:solidFill>
                   <a:srgbClr val="101820"/>
@@ -13443,6 +13608,7 @@
           <a:lstStyle xmlns:a="http://schemas.openxmlformats.org/drawingml/2006/main"/>
           <a:p xmlns:a="http://schemas.openxmlformats.org/drawingml/2006/main">
             <a:pPr algn="ctr">
+              <a:buNone/>
               <a:defRPr sz="1200" b="1">
                 <a:solidFill>
                   <a:srgbClr val="FFFFFF"/>
@@ -13499,6 +13665,7 @@
           <a:lstStyle xmlns:a="http://schemas.openxmlformats.org/drawingml/2006/main"/>
           <a:p xmlns:a="http://schemas.openxmlformats.org/drawingml/2006/main">
             <a:pPr algn="l">
+              <a:buNone/>
               <a:defRPr sz="1350" b="0">
                 <a:solidFill>
                   <a:srgbClr val="101820"/>
@@ -13559,6 +13726,7 @@
           <a:lstStyle xmlns:a="http://schemas.openxmlformats.org/drawingml/2006/main"/>
           <a:p xmlns:a="http://schemas.openxmlformats.org/drawingml/2006/main">
             <a:pPr algn="ctr">
+              <a:buNone/>
               <a:defRPr sz="1200" b="1">
                 <a:solidFill>
                   <a:srgbClr val="FFFFFF"/>
@@ -13615,6 +13783,7 @@
           <a:lstStyle xmlns:a="http://schemas.openxmlformats.org/drawingml/2006/main"/>
           <a:p xmlns:a="http://schemas.openxmlformats.org/drawingml/2006/main">
             <a:pPr algn="l">
+              <a:buNone/>
               <a:defRPr sz="1350" b="0">
                 <a:solidFill>
                   <a:srgbClr val="101820"/>
@@ -13675,6 +13844,7 @@
           <a:lstStyle xmlns:a="http://schemas.openxmlformats.org/drawingml/2006/main"/>
           <a:p xmlns:a="http://schemas.openxmlformats.org/drawingml/2006/main">
             <a:pPr algn="ctr">
+              <a:buNone/>
               <a:defRPr sz="1200" b="1">
                 <a:solidFill>
                   <a:srgbClr val="FFFFFF"/>
@@ -13731,6 +13901,7 @@
           <a:lstStyle xmlns:a="http://schemas.openxmlformats.org/drawingml/2006/main"/>
           <a:p xmlns:a="http://schemas.openxmlformats.org/drawingml/2006/main">
             <a:pPr algn="l">
+              <a:buNone/>
               <a:defRPr sz="1350" b="0">
                 <a:solidFill>
                   <a:srgbClr val="101820"/>
@@ -13791,6 +13962,7 @@
           <a:lstStyle xmlns:a="http://schemas.openxmlformats.org/drawingml/2006/main"/>
           <a:p xmlns:a="http://schemas.openxmlformats.org/drawingml/2006/main">
             <a:pPr algn="ctr">
+              <a:buNone/>
               <a:defRPr sz="1200" b="1">
                 <a:solidFill>
                   <a:srgbClr val="FFFFFF"/>
@@ -13847,6 +14019,7 @@
           <a:lstStyle xmlns:a="http://schemas.openxmlformats.org/drawingml/2006/main"/>
           <a:p xmlns:a="http://schemas.openxmlformats.org/drawingml/2006/main">
             <a:pPr algn="l">
+              <a:buNone/>
               <a:defRPr sz="1350" b="0">
                 <a:solidFill>
                   <a:srgbClr val="101820"/>
@@ -13938,6 +14111,7 @@
           <a:lstStyle xmlns:a="http://schemas.openxmlformats.org/drawingml/2006/main"/>
           <a:p xmlns:a="http://schemas.openxmlformats.org/drawingml/2006/main">
             <a:pPr algn="ctr">
+              <a:buNone/>
               <a:defRPr sz="1050" b="1">
                 <a:solidFill>
                   <a:srgbClr val="2D8CFF"/>
@@ -14023,6 +14197,7 @@
           <a:lstStyle xmlns:a="http://schemas.openxmlformats.org/drawingml/2006/main"/>
           <a:p xmlns:a="http://schemas.openxmlformats.org/drawingml/2006/main">
             <a:pPr algn="l">
+              <a:buNone/>
               <a:defRPr sz="900" b="1">
                 <a:solidFill>
                   <a:srgbClr val="2D8CFF"/>
@@ -14079,6 +14254,7 @@
           <a:lstStyle xmlns:a="http://schemas.openxmlformats.org/drawingml/2006/main"/>
           <a:p xmlns:a="http://schemas.openxmlformats.org/drawingml/2006/main">
             <a:pPr algn="l">
+              <a:buNone/>
               <a:defRPr sz="3300" b="1">
                 <a:solidFill>
                   <a:srgbClr val="101820"/>
@@ -14168,6 +14344,7 @@
           <a:lstStyle xmlns:a="http://schemas.openxmlformats.org/drawingml/2006/main"/>
           <a:p xmlns:a="http://schemas.openxmlformats.org/drawingml/2006/main">
             <a:pPr algn="l">
+              <a:buNone/>
               <a:defRPr sz="750" b="1">
                 <a:solidFill>
                   <a:srgbClr val="59636E"/>
@@ -14224,6 +14401,7 @@
           <a:lstStyle xmlns:a="http://schemas.openxmlformats.org/drawingml/2006/main"/>
           <a:p xmlns:a="http://schemas.openxmlformats.org/drawingml/2006/main">
             <a:pPr algn="r">
+              <a:buNone/>
               <a:defRPr sz="900" b="1">
                 <a:solidFill>
                   <a:srgbClr val="59636E"/>
@@ -14315,6 +14493,7 @@
           <a:lstStyle xmlns:a="http://schemas.openxmlformats.org/drawingml/2006/main"/>
           <a:p xmlns:a="http://schemas.openxmlformats.org/drawingml/2006/main">
             <a:pPr algn="l">
+              <a:buNone/>
               <a:defRPr sz="1200" b="1">
                 <a:solidFill>
                   <a:srgbClr val="FFFFFF"/>
@@ -14371,6 +14550,7 @@
           <a:lstStyle xmlns:a="http://schemas.openxmlformats.org/drawingml/2006/main"/>
           <a:p xmlns:a="http://schemas.openxmlformats.org/drawingml/2006/main">
             <a:pPr algn="l">
+              <a:buNone/>
               <a:defRPr sz="1200" b="1">
                 <a:solidFill>
                   <a:srgbClr val="FFFFFF"/>
@@ -14462,6 +14642,7 @@
           <a:lstStyle xmlns:a="http://schemas.openxmlformats.org/drawingml/2006/main"/>
           <a:p xmlns:a="http://schemas.openxmlformats.org/drawingml/2006/main">
             <a:pPr algn="l">
+              <a:buNone/>
               <a:defRPr sz="1125" b="1">
                 <a:solidFill>
                   <a:srgbClr val="101820"/>
@@ -14518,6 +14699,7 @@
           <a:lstStyle xmlns:a="http://schemas.openxmlformats.org/drawingml/2006/main"/>
           <a:p xmlns:a="http://schemas.openxmlformats.org/drawingml/2006/main">
             <a:pPr algn="l">
+              <a:buNone/>
               <a:defRPr sz="1200" b="0">
                 <a:solidFill>
                   <a:srgbClr val="59636E"/>
@@ -14609,6 +14791,7 @@
           <a:lstStyle xmlns:a="http://schemas.openxmlformats.org/drawingml/2006/main"/>
           <a:p xmlns:a="http://schemas.openxmlformats.org/drawingml/2006/main">
             <a:pPr algn="l">
+              <a:buNone/>
               <a:defRPr sz="1125" b="1">
                 <a:solidFill>
                   <a:srgbClr val="101820"/>
@@ -14665,6 +14848,7 @@
           <a:lstStyle xmlns:a="http://schemas.openxmlformats.org/drawingml/2006/main"/>
           <a:p xmlns:a="http://schemas.openxmlformats.org/drawingml/2006/main">
             <a:pPr algn="l">
+              <a:buNone/>
               <a:defRPr sz="1200" b="0">
                 <a:solidFill>
                   <a:srgbClr val="59636E"/>
@@ -14756,6 +14940,7 @@
           <a:lstStyle xmlns:a="http://schemas.openxmlformats.org/drawingml/2006/main"/>
           <a:p xmlns:a="http://schemas.openxmlformats.org/drawingml/2006/main">
             <a:pPr algn="l">
+              <a:buNone/>
               <a:defRPr sz="1125" b="1">
                 <a:solidFill>
                   <a:srgbClr val="101820"/>
@@ -14812,6 +14997,7 @@
           <a:lstStyle xmlns:a="http://schemas.openxmlformats.org/drawingml/2006/main"/>
           <a:p xmlns:a="http://schemas.openxmlformats.org/drawingml/2006/main">
             <a:pPr algn="l">
+              <a:buNone/>
               <a:defRPr sz="1200" b="0">
                 <a:solidFill>
                   <a:srgbClr val="59636E"/>
@@ -14903,6 +15089,7 @@
           <a:lstStyle xmlns:a="http://schemas.openxmlformats.org/drawingml/2006/main"/>
           <a:p xmlns:a="http://schemas.openxmlformats.org/drawingml/2006/main">
             <a:pPr algn="l">
+              <a:buNone/>
               <a:defRPr sz="1125" b="0">
                 <a:solidFill>
                   <a:srgbClr val="101820"/>
@@ -14959,6 +15146,7 @@
           <a:lstStyle xmlns:a="http://schemas.openxmlformats.org/drawingml/2006/main"/>
           <a:p xmlns:a="http://schemas.openxmlformats.org/drawingml/2006/main">
             <a:pPr algn="l">
+              <a:buNone/>
               <a:defRPr sz="1200" b="0">
                 <a:solidFill>
                   <a:srgbClr val="59636E"/>
@@ -15050,6 +15238,7 @@
           <a:lstStyle xmlns:a="http://schemas.openxmlformats.org/drawingml/2006/main"/>
           <a:p xmlns:a="http://schemas.openxmlformats.org/drawingml/2006/main">
             <a:pPr algn="l">
+              <a:buNone/>
               <a:defRPr sz="1125" b="0">
                 <a:solidFill>
                   <a:srgbClr val="101820"/>
@@ -15106,6 +15295,7 @@
           <a:lstStyle xmlns:a="http://schemas.openxmlformats.org/drawingml/2006/main"/>
           <a:p xmlns:a="http://schemas.openxmlformats.org/drawingml/2006/main">
             <a:pPr algn="l">
+              <a:buNone/>
               <a:defRPr sz="1200" b="0">
                 <a:solidFill>
                   <a:srgbClr val="59636E"/>
@@ -15197,6 +15387,7 @@
           <a:lstStyle xmlns:a="http://schemas.openxmlformats.org/drawingml/2006/main"/>
           <a:p xmlns:a="http://schemas.openxmlformats.org/drawingml/2006/main">
             <a:pPr algn="l">
+              <a:buNone/>
               <a:defRPr sz="1125" b="0">
                 <a:solidFill>
                   <a:srgbClr val="101820"/>
@@ -15253,6 +15444,7 @@
           <a:lstStyle xmlns:a="http://schemas.openxmlformats.org/drawingml/2006/main"/>
           <a:p xmlns:a="http://schemas.openxmlformats.org/drawingml/2006/main">
             <a:pPr algn="l">
+              <a:buNone/>
               <a:defRPr sz="1200" b="0">
                 <a:solidFill>
                   <a:srgbClr val="59636E"/>
@@ -15344,6 +15536,7 @@
           <a:lstStyle xmlns:a="http://schemas.openxmlformats.org/drawingml/2006/main"/>
           <a:p xmlns:a="http://schemas.openxmlformats.org/drawingml/2006/main">
             <a:pPr algn="l">
+              <a:buNone/>
               <a:defRPr sz="1125" b="0">
                 <a:solidFill>
                   <a:srgbClr val="101820"/>
@@ -15400,6 +15593,7 @@
           <a:lstStyle xmlns:a="http://schemas.openxmlformats.org/drawingml/2006/main"/>
           <a:p xmlns:a="http://schemas.openxmlformats.org/drawingml/2006/main">
             <a:pPr algn="l">
+              <a:buNone/>
               <a:defRPr sz="1200" b="1">
                 <a:solidFill>
                   <a:srgbClr val="E79A54"/>
@@ -15418,7 +15612,7 @@
                 <a:ea typeface="Arial"/>
                 <a:cs typeface="Arial"/>
               </a:rPr>
-              <a:t>Участники — рекомендуется</a:t>
+              <a:t>Участники — обязательно</a:t>
             </a:r>
           </a:p>
         </p:txBody>
@@ -15456,6 +15650,7 @@
           <a:lstStyle xmlns:a="http://schemas.openxmlformats.org/drawingml/2006/main"/>
           <a:p xmlns:a="http://schemas.openxmlformats.org/drawingml/2006/main">
             <a:pPr algn="l">
+              <a:buNone/>
               <a:defRPr sz="1275" b="1">
                 <a:solidFill>
                   <a:srgbClr val="B4382C"/>
@@ -15541,6 +15736,7 @@
           <a:lstStyle xmlns:a="http://schemas.openxmlformats.org/drawingml/2006/main"/>
           <a:p xmlns:a="http://schemas.openxmlformats.org/drawingml/2006/main">
             <a:pPr algn="l">
+              <a:buNone/>
               <a:defRPr sz="900" b="1">
                 <a:solidFill>
                   <a:srgbClr val="2D8CFF"/>
@@ -15597,6 +15793,7 @@
           <a:lstStyle xmlns:a="http://schemas.openxmlformats.org/drawingml/2006/main"/>
           <a:p xmlns:a="http://schemas.openxmlformats.org/drawingml/2006/main">
             <a:pPr algn="l">
+              <a:buNone/>
               <a:defRPr sz="3000" b="1">
                 <a:solidFill>
                   <a:srgbClr val="101820"/>
@@ -15686,6 +15883,7 @@
           <a:lstStyle xmlns:a="http://schemas.openxmlformats.org/drawingml/2006/main"/>
           <a:p xmlns:a="http://schemas.openxmlformats.org/drawingml/2006/main">
             <a:pPr algn="l">
+              <a:buNone/>
               <a:defRPr sz="750" b="1">
                 <a:solidFill>
                   <a:srgbClr val="59636E"/>
@@ -15742,6 +15940,7 @@
           <a:lstStyle xmlns:a="http://schemas.openxmlformats.org/drawingml/2006/main"/>
           <a:p xmlns:a="http://schemas.openxmlformats.org/drawingml/2006/main">
             <a:pPr algn="r">
+              <a:buNone/>
               <a:defRPr sz="900" b="1">
                 <a:solidFill>
                   <a:srgbClr val="59636E"/>
@@ -15798,6 +15997,7 @@
           <a:lstStyle xmlns:a="http://schemas.openxmlformats.org/drawingml/2006/main"/>
           <a:p xmlns:a="http://schemas.openxmlformats.org/drawingml/2006/main">
             <a:pPr algn="l">
+              <a:buNone/>
               <a:defRPr sz="900" b="1">
                 <a:solidFill>
                   <a:srgbClr val="2D8CFF"/>
@@ -15889,6 +16089,7 @@
           <a:lstStyle xmlns:a="http://schemas.openxmlformats.org/drawingml/2006/main"/>
           <a:p xmlns:a="http://schemas.openxmlformats.org/drawingml/2006/main">
             <a:pPr algn="l">
+              <a:buNone/>
               <a:defRPr sz="1050" b="1">
                 <a:solidFill>
                   <a:srgbClr val="2D8CFF"/>
@@ -15945,6 +16146,7 @@
           <a:lstStyle xmlns:a="http://schemas.openxmlformats.org/drawingml/2006/main"/>
           <a:p xmlns:a="http://schemas.openxmlformats.org/drawingml/2006/main">
             <a:pPr algn="l">
+              <a:buNone/>
               <a:defRPr sz="1575" b="1">
                 <a:solidFill>
                   <a:srgbClr val="101820"/>
@@ -16036,6 +16238,7 @@
           <a:lstStyle xmlns:a="http://schemas.openxmlformats.org/drawingml/2006/main"/>
           <a:p xmlns:a="http://schemas.openxmlformats.org/drawingml/2006/main">
             <a:pPr algn="l">
+              <a:buNone/>
               <a:defRPr sz="1050" b="1">
                 <a:solidFill>
                   <a:srgbClr val="1B5964"/>
@@ -16092,6 +16295,7 @@
           <a:lstStyle xmlns:a="http://schemas.openxmlformats.org/drawingml/2006/main"/>
           <a:p xmlns:a="http://schemas.openxmlformats.org/drawingml/2006/main">
             <a:pPr algn="l">
+              <a:buNone/>
               <a:defRPr sz="1575" b="1">
                 <a:solidFill>
                   <a:srgbClr val="101820"/>
@@ -16183,6 +16387,7 @@
           <a:lstStyle xmlns:a="http://schemas.openxmlformats.org/drawingml/2006/main"/>
           <a:p xmlns:a="http://schemas.openxmlformats.org/drawingml/2006/main">
             <a:pPr algn="l">
+              <a:buNone/>
               <a:defRPr sz="1050" b="1">
                 <a:solidFill>
                   <a:srgbClr val="E79A54"/>
@@ -16239,6 +16444,7 @@
           <a:lstStyle xmlns:a="http://schemas.openxmlformats.org/drawingml/2006/main"/>
           <a:p xmlns:a="http://schemas.openxmlformats.org/drawingml/2006/main">
             <a:pPr algn="l">
+              <a:buNone/>
               <a:defRPr sz="1575" b="1">
                 <a:solidFill>
                   <a:srgbClr val="101820"/>
@@ -16330,6 +16536,7 @@
           <a:lstStyle xmlns:a="http://schemas.openxmlformats.org/drawingml/2006/main"/>
           <a:p xmlns:a="http://schemas.openxmlformats.org/drawingml/2006/main">
             <a:pPr algn="l">
+              <a:buNone/>
               <a:defRPr sz="2025" b="1">
                 <a:solidFill>
                   <a:srgbClr val="FFFFFF"/>
@@ -16386,6 +16593,7 @@
           <a:lstStyle xmlns:a="http://schemas.openxmlformats.org/drawingml/2006/main"/>
           <a:p xmlns:a="http://schemas.openxmlformats.org/drawingml/2006/main">
             <a:pPr algn="l">
+              <a:buNone/>
               <a:defRPr sz="1350" b="0">
                 <a:solidFill>
                   <a:srgbClr val="FFFFFF"/>
@@ -16409,6 +16617,7 @@
           </a:p>
           <a:p xmlns:a="http://schemas.openxmlformats.org/drawingml/2006/main">
             <a:pPr algn="l">
+              <a:buNone/>
               <a:defRPr sz="1350" b="0">
                 <a:solidFill>
                   <a:srgbClr val="FFFFFF"/>
@@ -16432,6 +16641,7 @@
           </a:p>
           <a:p xmlns:a="http://schemas.openxmlformats.org/drawingml/2006/main">
             <a:pPr algn="l">
+              <a:buNone/>
               <a:defRPr sz="1350" b="0">
                 <a:solidFill>
                   <a:srgbClr val="FFFFFF"/>
@@ -16455,6 +16665,7 @@
           </a:p>
           <a:p xmlns:a="http://schemas.openxmlformats.org/drawingml/2006/main">
             <a:pPr algn="l">
+              <a:buNone/>
               <a:defRPr sz="1350" b="0">
                 <a:solidFill>
                   <a:srgbClr val="FFFFFF"/>
@@ -16546,6 +16757,7 @@
           <a:lstStyle xmlns:a="http://schemas.openxmlformats.org/drawingml/2006/main"/>
           <a:p xmlns:a="http://schemas.openxmlformats.org/drawingml/2006/main">
             <a:pPr algn="ctr">
+              <a:buNone/>
               <a:defRPr sz="1275" b="1">
                 <a:solidFill>
                   <a:srgbClr val="B4382C"/>
@@ -16602,6 +16814,7 @@
           <a:lstStyle xmlns:a="http://schemas.openxmlformats.org/drawingml/2006/main"/>
           <a:p xmlns:a="http://schemas.openxmlformats.org/drawingml/2006/main">
             <a:pPr algn="ctr">
+              <a:buNone/>
               <a:defRPr sz="1425" b="1">
                 <a:solidFill>
                   <a:srgbClr val="B4382C"/>
@@ -16630,6 +16843,7 @@
           </a:p>
           <a:p xmlns:a="http://schemas.openxmlformats.org/drawingml/2006/main">
             <a:pPr algn="ctr">
+              <a:buNone/>
               <a:defRPr sz="1425" b="1">
                 <a:solidFill>
                   <a:srgbClr val="B4382C"/>
@@ -16686,6 +16900,7 @@
           <a:lstStyle xmlns:a="http://schemas.openxmlformats.org/drawingml/2006/main"/>
           <a:p xmlns:a="http://schemas.openxmlformats.org/drawingml/2006/main">
             <a:pPr algn="l">
+              <a:buNone/>
               <a:defRPr sz="900" b="1">
                 <a:solidFill>
                   <a:srgbClr val="2D8CFF"/>
@@ -16771,6 +16986,7 @@
           <a:lstStyle xmlns:a="http://schemas.openxmlformats.org/drawingml/2006/main"/>
           <a:p xmlns:a="http://schemas.openxmlformats.org/drawingml/2006/main">
             <a:pPr algn="l">
+              <a:buNone/>
               <a:defRPr sz="900" b="1">
                 <a:solidFill>
                   <a:srgbClr val="2D8CFF"/>
@@ -16827,6 +17043,7 @@
           <a:lstStyle xmlns:a="http://schemas.openxmlformats.org/drawingml/2006/main"/>
           <a:p xmlns:a="http://schemas.openxmlformats.org/drawingml/2006/main">
             <a:pPr algn="l">
+              <a:buNone/>
               <a:defRPr sz="3300" b="1">
                 <a:solidFill>
                   <a:srgbClr val="101820"/>
@@ -16916,6 +17133,7 @@
           <a:lstStyle xmlns:a="http://schemas.openxmlformats.org/drawingml/2006/main"/>
           <a:p xmlns:a="http://schemas.openxmlformats.org/drawingml/2006/main">
             <a:pPr algn="l">
+              <a:buNone/>
               <a:defRPr sz="750" b="1">
                 <a:solidFill>
                   <a:srgbClr val="59636E"/>
@@ -16972,6 +17190,7 @@
           <a:lstStyle xmlns:a="http://schemas.openxmlformats.org/drawingml/2006/main"/>
           <a:p xmlns:a="http://schemas.openxmlformats.org/drawingml/2006/main">
             <a:pPr algn="r">
+              <a:buNone/>
               <a:defRPr sz="900" b="1">
                 <a:solidFill>
                   <a:srgbClr val="59636E"/>
@@ -17032,14 +17251,14 @@
       </p:sp>
       <p:pic>
         <p:nvPicPr>
-          <p:cNvPr id="24" name=""/>
+          <p:cNvPr id="26" name=""/>
           <p:cNvPicPr>
             <a:picLocks xmlns:a="http://schemas.openxmlformats.org/drawingml/2006/main" noChangeAspect="1"/>
           </p:cNvPicPr>
           <p:nvPr/>
         </p:nvPicPr>
         <p:blipFill>
-          <a:blip xmlns:r="http://schemas.openxmlformats.org/officeDocument/2006/relationships" xmlns:a="http://schemas.openxmlformats.org/drawingml/2006/main" r:embed="R6059730e6ab74b59"/>
+          <a:blip xmlns:r="http://schemas.openxmlformats.org/officeDocument/2006/relationships" xmlns:a="http://schemas.openxmlformats.org/drawingml/2006/main" r:embed="Rb79cb584bc6c40f2"/>
           <a:srcRect xmlns:a="http://schemas.openxmlformats.org/drawingml/2006/main" l="1972" t="0" r="1972" b="0"/>
           <a:stretch xmlns:a="http://schemas.openxmlformats.org/drawingml/2006/main">
             <a:fillRect l="0" t="0" r="0" b="0"/>
@@ -17090,6 +17309,7 @@
           <a:lstStyle xmlns:a="http://schemas.openxmlformats.org/drawingml/2006/main"/>
           <a:p xmlns:a="http://schemas.openxmlformats.org/drawingml/2006/main">
             <a:pPr algn="l">
+              <a:buNone/>
               <a:defRPr sz="1875" b="1">
                 <a:solidFill>
                   <a:srgbClr val="101820"/>
@@ -17150,6 +17370,7 @@
           <a:lstStyle xmlns:a="http://schemas.openxmlformats.org/drawingml/2006/main"/>
           <a:p xmlns:a="http://schemas.openxmlformats.org/drawingml/2006/main">
             <a:pPr algn="ctr">
+              <a:buNone/>
               <a:defRPr sz="1200" b="1">
                 <a:solidFill>
                   <a:srgbClr val="FFFFFF"/>
@@ -17206,6 +17427,7 @@
           <a:lstStyle xmlns:a="http://schemas.openxmlformats.org/drawingml/2006/main"/>
           <a:p xmlns:a="http://schemas.openxmlformats.org/drawingml/2006/main">
             <a:pPr algn="l">
+              <a:buNone/>
               <a:defRPr sz="1425" b="0">
                 <a:solidFill>
                   <a:srgbClr val="101820"/>
@@ -17266,6 +17488,7 @@
           <a:lstStyle xmlns:a="http://schemas.openxmlformats.org/drawingml/2006/main"/>
           <a:p xmlns:a="http://schemas.openxmlformats.org/drawingml/2006/main">
             <a:pPr algn="ctr">
+              <a:buNone/>
               <a:defRPr sz="1200" b="1">
                 <a:solidFill>
                   <a:srgbClr val="FFFFFF"/>
@@ -17322,6 +17545,7 @@
           <a:lstStyle xmlns:a="http://schemas.openxmlformats.org/drawingml/2006/main"/>
           <a:p xmlns:a="http://schemas.openxmlformats.org/drawingml/2006/main">
             <a:pPr algn="l">
+              <a:buNone/>
               <a:defRPr sz="1425" b="0">
                 <a:solidFill>
                   <a:srgbClr val="101820"/>
@@ -17382,6 +17606,7 @@
           <a:lstStyle xmlns:a="http://schemas.openxmlformats.org/drawingml/2006/main"/>
           <a:p xmlns:a="http://schemas.openxmlformats.org/drawingml/2006/main">
             <a:pPr algn="ctr">
+              <a:buNone/>
               <a:defRPr sz="1200" b="1">
                 <a:solidFill>
                   <a:srgbClr val="FFFFFF"/>
@@ -17438,6 +17663,7 @@
           <a:lstStyle xmlns:a="http://schemas.openxmlformats.org/drawingml/2006/main"/>
           <a:p xmlns:a="http://schemas.openxmlformats.org/drawingml/2006/main">
             <a:pPr algn="l">
+              <a:buNone/>
               <a:defRPr sz="1425" b="0">
                 <a:solidFill>
                   <a:srgbClr val="101820"/>
@@ -17529,6 +17755,7 @@
           <a:lstStyle xmlns:a="http://schemas.openxmlformats.org/drawingml/2006/main"/>
           <a:p xmlns:a="http://schemas.openxmlformats.org/drawingml/2006/main">
             <a:pPr algn="ctr">
+              <a:buNone/>
               <a:defRPr sz="1350" b="1">
                 <a:solidFill>
                   <a:srgbClr val="E79A54"/>
@@ -17585,6 +17812,7 @@
           <a:lstStyle xmlns:a="http://schemas.openxmlformats.org/drawingml/2006/main"/>
           <a:p xmlns:a="http://schemas.openxmlformats.org/drawingml/2006/main">
             <a:pPr algn="ctr">
+              <a:buNone/>
               <a:defRPr sz="1200" b="0">
                 <a:solidFill>
                   <a:srgbClr val="101820"/>

</xml_diff>

<commit_message>
Make Zoom participant scope mandatory (#12)
Treat the participant scope as required in the in-app guide and update the downloadable presentation.
</commit_message>
<xml_diff>
--- a/public/docs/Zoom_AxioMeet_setup_RU.pptx
+++ b/public/docs/Zoom_AxioMeet_setup_RU.pptx
@@ -2,25 +2,25 @@
 <file path=ppt/presentation.xml><?xml version="1.0" encoding="utf-8"?>
 <p:presentation xmlns:p="http://schemas.openxmlformats.org/presentationml/2006/main">
   <p:sldMasterIdLst>
-    <p:sldMasterId xmlns:r="http://schemas.openxmlformats.org/officeDocument/2006/relationships" id="2147483648" r:id="Rdb659b0a80b24c93"/>
+    <p:sldMasterId xmlns:r="http://schemas.openxmlformats.org/officeDocument/2006/relationships" id="2147483648" r:id="R64b18f981a8e4ff1"/>
   </p:sldMasterIdLst>
   <p:notesMasterIdLst>
-    <p:notesMasterId xmlns:r="http://schemas.openxmlformats.org/officeDocument/2006/relationships" r:id="Rbedf70944e674aeb"/>
+    <p:notesMasterId xmlns:r="http://schemas.openxmlformats.org/officeDocument/2006/relationships" r:id="R9491323b182d4241"/>
   </p:notesMasterIdLst>
   <p:sldIdLst>
-    <p:sldId xmlns:r="http://schemas.openxmlformats.org/officeDocument/2006/relationships" id="256" r:id="R0319733da6f14cf8"/>
-    <p:sldId xmlns:r="http://schemas.openxmlformats.org/officeDocument/2006/relationships" id="257" r:id="Rf3512b226bed4352"/>
-    <p:sldId xmlns:r="http://schemas.openxmlformats.org/officeDocument/2006/relationships" id="258" r:id="R42c2430aa7e6440e"/>
-    <p:sldId xmlns:r="http://schemas.openxmlformats.org/officeDocument/2006/relationships" id="259" r:id="Rdd714eb58dc44c47"/>
-    <p:sldId xmlns:r="http://schemas.openxmlformats.org/officeDocument/2006/relationships" id="260" r:id="R26dae08b75c64b76"/>
-    <p:sldId xmlns:r="http://schemas.openxmlformats.org/officeDocument/2006/relationships" id="261" r:id="R1814590f78524a8f"/>
-    <p:sldId xmlns:r="http://schemas.openxmlformats.org/officeDocument/2006/relationships" id="262" r:id="R7d4d3eb4cf49422f"/>
-    <p:sldId xmlns:r="http://schemas.openxmlformats.org/officeDocument/2006/relationships" id="263" r:id="Rd9aa8d6c8fc447be"/>
-    <p:sldId xmlns:r="http://schemas.openxmlformats.org/officeDocument/2006/relationships" id="264" r:id="R29431f6b474c47ed"/>
-    <p:sldId xmlns:r="http://schemas.openxmlformats.org/officeDocument/2006/relationships" id="265" r:id="R8f24037d70ea4d3c"/>
-    <p:sldId xmlns:r="http://schemas.openxmlformats.org/officeDocument/2006/relationships" id="266" r:id="Rc39f4d6cd3aa445c"/>
-    <p:sldId xmlns:r="http://schemas.openxmlformats.org/officeDocument/2006/relationships" id="267" r:id="R3a57e395ddcb4b17"/>
-    <p:sldId xmlns:r="http://schemas.openxmlformats.org/officeDocument/2006/relationships" id="268" r:id="R41c3c6824fcf4a51"/>
+    <p:sldId xmlns:r="http://schemas.openxmlformats.org/officeDocument/2006/relationships" id="256" r:id="R46898a2d7937406f"/>
+    <p:sldId xmlns:r="http://schemas.openxmlformats.org/officeDocument/2006/relationships" id="257" r:id="Rb025ebc94ebb4bc0"/>
+    <p:sldId xmlns:r="http://schemas.openxmlformats.org/officeDocument/2006/relationships" id="258" r:id="Ra216e14e3fa242c5"/>
+    <p:sldId xmlns:r="http://schemas.openxmlformats.org/officeDocument/2006/relationships" id="259" r:id="R5d089f7cf8f142f5"/>
+    <p:sldId xmlns:r="http://schemas.openxmlformats.org/officeDocument/2006/relationships" id="260" r:id="R762a50a74aa94479"/>
+    <p:sldId xmlns:r="http://schemas.openxmlformats.org/officeDocument/2006/relationships" id="261" r:id="Rc5815b3efc584fc9"/>
+    <p:sldId xmlns:r="http://schemas.openxmlformats.org/officeDocument/2006/relationships" id="262" r:id="R5b4b3405b86d40f7"/>
+    <p:sldId xmlns:r="http://schemas.openxmlformats.org/officeDocument/2006/relationships" id="263" r:id="R182a5db37d734322"/>
+    <p:sldId xmlns:r="http://schemas.openxmlformats.org/officeDocument/2006/relationships" id="264" r:id="Re41a79e8e5804861"/>
+    <p:sldId xmlns:r="http://schemas.openxmlformats.org/officeDocument/2006/relationships" id="265" r:id="Re46d728a79fc4bc2"/>
+    <p:sldId xmlns:r="http://schemas.openxmlformats.org/officeDocument/2006/relationships" id="266" r:id="R769b6eeb0368483c"/>
+    <p:sldId xmlns:r="http://schemas.openxmlformats.org/officeDocument/2006/relationships" id="267" r:id="R2967d57e944c481f"/>
+    <p:sldId xmlns:r="http://schemas.openxmlformats.org/officeDocument/2006/relationships" id="268" r:id="R355ddfd9b57446ec"/>
   </p:sldIdLst>
   <p:sldSz cx="12192000" cy="6858000"/>
   <p:notesSz cx="6858000" cy="9144000"/>
@@ -1409,7 +1409,7 @@
           <a:lstStyle xmlns:a="http://schemas.openxmlformats.org/drawingml/2006/main"/>
           <a:p xmlns:a="http://schemas.openxmlformats.org/drawingml/2006/main">
             <a:r>
-              <a:t>Первые шесть scopes — обязательные для текущей реализации. Scope участников нужен для списка участников; если его нет, запись может импортироваться, но данные участников будут неполными.</a:t>
+              <a:t>Все семь scopes обязательны для текущей реализации. Последний scope нужен для надёжного получения имён и состава участников встречи.</a:t>
             </a:r>
           </a:p>
           <a:p xmlns:a="http://schemas.openxmlformats.org/drawingml/2006/main">
@@ -1692,7 +1692,7 @@
   </p:cSld>
   <p:clrMap bg1="lt1" tx1="dk1" bg2="lt2" tx2="dk2" accent1="accent1" accent2="accent2" accent3="accent3" accent4="accent4" accent5="accent5" accent6="accent6" hlink="hlink" folHlink="folHlink"/>
   <p:sldLayoutIdLst>
-    <p:sldLayoutId xmlns:r="http://schemas.openxmlformats.org/officeDocument/2006/relationships" id="2147483649" r:id="R4355533f39cc4a9d"/>
+    <p:sldLayoutId xmlns:r="http://schemas.openxmlformats.org/officeDocument/2006/relationships" id="2147483649" r:id="R091e2e5421d94b89"/>
   </p:sldLayoutIdLst>
   <p:txStyles>
     <p:titleStyle>
@@ -2306,6 +2306,7 @@
           <a:lstStyle xmlns:a="http://schemas.openxmlformats.org/drawingml/2006/main"/>
           <a:p xmlns:a="http://schemas.openxmlformats.org/drawingml/2006/main">
             <a:pPr algn="ctr">
+              <a:buNone/>
               <a:defRPr sz="1050" b="1">
                 <a:solidFill>
                   <a:srgbClr val="2D8CFF"/>
@@ -2362,6 +2363,7 @@
           <a:lstStyle xmlns:a="http://schemas.openxmlformats.org/drawingml/2006/main"/>
           <a:p xmlns:a="http://schemas.openxmlformats.org/drawingml/2006/main">
             <a:pPr algn="l">
+              <a:buNone/>
               <a:defRPr sz="4050" b="1">
                 <a:solidFill>
                   <a:srgbClr val="101820"/>
@@ -2418,6 +2420,7 @@
           <a:lstStyle xmlns:a="http://schemas.openxmlformats.org/drawingml/2006/main"/>
           <a:p xmlns:a="http://schemas.openxmlformats.org/drawingml/2006/main">
             <a:pPr algn="l">
+              <a:buNone/>
               <a:defRPr sz="3000" b="1">
                 <a:solidFill>
                   <a:srgbClr val="1B5964"/>
@@ -2441,6 +2444,7 @@
           </a:p>
           <a:p xmlns:a="http://schemas.openxmlformats.org/drawingml/2006/main">
             <a:pPr algn="l">
+              <a:buNone/>
               <a:defRPr sz="3000" b="1">
                 <a:solidFill>
                   <a:srgbClr val="1B5964"/>
@@ -2497,6 +2501,7 @@
           <a:lstStyle xmlns:a="http://schemas.openxmlformats.org/drawingml/2006/main"/>
           <a:p xmlns:a="http://schemas.openxmlformats.org/drawingml/2006/main">
             <a:pPr algn="l">
+              <a:buNone/>
               <a:defRPr sz="1350" b="0">
                 <a:solidFill>
                   <a:srgbClr val="59636E"/>
@@ -2520,6 +2525,7 @@
           </a:p>
           <a:p xmlns:a="http://schemas.openxmlformats.org/drawingml/2006/main">
             <a:pPr algn="l">
+              <a:buNone/>
               <a:defRPr sz="1350" b="0">
                 <a:solidFill>
                   <a:srgbClr val="59636E"/>
@@ -2611,6 +2617,7 @@
           <a:lstStyle xmlns:a="http://schemas.openxmlformats.org/drawingml/2006/main"/>
           <a:p xmlns:a="http://schemas.openxmlformats.org/drawingml/2006/main">
             <a:pPr algn="ctr">
+              <a:buNone/>
               <a:defRPr sz="1050" b="1">
                 <a:solidFill>
                   <a:srgbClr val="101820"/>
@@ -2702,6 +2709,7 @@
           <a:lstStyle xmlns:a="http://schemas.openxmlformats.org/drawingml/2006/main"/>
           <a:p xmlns:a="http://schemas.openxmlformats.org/drawingml/2006/main">
             <a:pPr algn="ctr">
+              <a:buNone/>
               <a:defRPr sz="1050" b="1">
                 <a:solidFill>
                   <a:srgbClr val="101820"/>
@@ -2793,6 +2801,7 @@
           <a:lstStyle xmlns:a="http://schemas.openxmlformats.org/drawingml/2006/main"/>
           <a:p xmlns:a="http://schemas.openxmlformats.org/drawingml/2006/main">
             <a:pPr algn="ctr">
+              <a:buNone/>
               <a:defRPr sz="1050" b="1">
                 <a:solidFill>
                   <a:srgbClr val="101820"/>
@@ -2853,14 +2862,14 @@
       </p:sp>
       <p:pic>
         <p:nvPicPr>
-          <p:cNvPr id="29" name=""/>
+          <p:cNvPr id="31" name=""/>
           <p:cNvPicPr>
             <a:picLocks xmlns:a="http://schemas.openxmlformats.org/drawingml/2006/main" noChangeAspect="1"/>
           </p:cNvPicPr>
           <p:nvPr/>
         </p:nvPicPr>
         <p:blipFill>
-          <a:blip xmlns:r="http://schemas.openxmlformats.org/officeDocument/2006/relationships" xmlns:a="http://schemas.openxmlformats.org/drawingml/2006/main" r:embed="Rcbff927759c2489e"/>
+          <a:blip xmlns:r="http://schemas.openxmlformats.org/officeDocument/2006/relationships" xmlns:a="http://schemas.openxmlformats.org/drawingml/2006/main" r:embed="R26e8940e51e94b3c"/>
           <a:srcRect xmlns:a="http://schemas.openxmlformats.org/drawingml/2006/main" l="16367" t="0" r="16367" b="0"/>
           <a:stretch xmlns:a="http://schemas.openxmlformats.org/drawingml/2006/main">
             <a:fillRect l="0" t="0" r="0" b="0"/>
@@ -2944,6 +2953,7 @@
           <a:lstStyle xmlns:a="http://schemas.openxmlformats.org/drawingml/2006/main"/>
           <a:p xmlns:a="http://schemas.openxmlformats.org/drawingml/2006/main">
             <a:pPr algn="l">
+              <a:buNone/>
               <a:defRPr sz="750" b="1">
                 <a:solidFill>
                   <a:srgbClr val="59636E"/>
@@ -3000,6 +3010,7 @@
           <a:lstStyle xmlns:a="http://schemas.openxmlformats.org/drawingml/2006/main"/>
           <a:p xmlns:a="http://schemas.openxmlformats.org/drawingml/2006/main">
             <a:pPr algn="r">
+              <a:buNone/>
               <a:defRPr sz="900" b="1">
                 <a:solidFill>
                   <a:srgbClr val="59636E"/>
@@ -3085,6 +3096,7 @@
           <a:lstStyle xmlns:a="http://schemas.openxmlformats.org/drawingml/2006/main"/>
           <a:p xmlns:a="http://schemas.openxmlformats.org/drawingml/2006/main">
             <a:pPr algn="l">
+              <a:buNone/>
               <a:defRPr sz="900" b="1">
                 <a:solidFill>
                   <a:srgbClr val="2D8CFF"/>
@@ -3141,6 +3153,7 @@
           <a:lstStyle xmlns:a="http://schemas.openxmlformats.org/drawingml/2006/main"/>
           <a:p xmlns:a="http://schemas.openxmlformats.org/drawingml/2006/main">
             <a:pPr algn="l">
+              <a:buNone/>
               <a:defRPr sz="3000" b="1">
                 <a:solidFill>
                   <a:srgbClr val="101820"/>
@@ -3197,6 +3210,7 @@
           <a:lstStyle xmlns:a="http://schemas.openxmlformats.org/drawingml/2006/main"/>
           <a:p xmlns:a="http://schemas.openxmlformats.org/drawingml/2006/main">
             <a:pPr algn="l">
+              <a:buNone/>
               <a:defRPr sz="3000" b="1">
                 <a:solidFill>
                   <a:srgbClr val="101820"/>
@@ -3286,6 +3300,7 @@
           <a:lstStyle xmlns:a="http://schemas.openxmlformats.org/drawingml/2006/main"/>
           <a:p xmlns:a="http://schemas.openxmlformats.org/drawingml/2006/main">
             <a:pPr algn="l">
+              <a:buNone/>
               <a:defRPr sz="750" b="1">
                 <a:solidFill>
                   <a:srgbClr val="59636E"/>
@@ -3342,6 +3357,7 @@
           <a:lstStyle xmlns:a="http://schemas.openxmlformats.org/drawingml/2006/main"/>
           <a:p xmlns:a="http://schemas.openxmlformats.org/drawingml/2006/main">
             <a:pPr algn="r">
+              <a:buNone/>
               <a:defRPr sz="900" b="1">
                 <a:solidFill>
                   <a:srgbClr val="59636E"/>
@@ -3398,6 +3414,7 @@
           <a:lstStyle xmlns:a="http://schemas.openxmlformats.org/drawingml/2006/main"/>
           <a:p xmlns:a="http://schemas.openxmlformats.org/drawingml/2006/main">
             <a:pPr algn="l">
+              <a:buNone/>
               <a:defRPr sz="900" b="1">
                 <a:solidFill>
                   <a:srgbClr val="2D8CFF"/>
@@ -3454,6 +3471,7 @@
           <a:lstStyle xmlns:a="http://schemas.openxmlformats.org/drawingml/2006/main"/>
           <a:p xmlns:a="http://schemas.openxmlformats.org/drawingml/2006/main">
             <a:pPr algn="l">
+              <a:buNone/>
               <a:defRPr sz="3000" b="1">
                 <a:solidFill>
                   <a:srgbClr val="101820"/>
@@ -3514,6 +3532,7 @@
           <a:lstStyle xmlns:a="http://schemas.openxmlformats.org/drawingml/2006/main"/>
           <a:p xmlns:a="http://schemas.openxmlformats.org/drawingml/2006/main">
             <a:pPr algn="ctr">
+              <a:buNone/>
               <a:defRPr sz="1200" b="1">
                 <a:solidFill>
                   <a:srgbClr val="FFFFFF"/>
@@ -3603,6 +3622,7 @@
           <a:lstStyle xmlns:a="http://schemas.openxmlformats.org/drawingml/2006/main"/>
           <a:p xmlns:a="http://schemas.openxmlformats.org/drawingml/2006/main">
             <a:pPr algn="ctr">
+              <a:buNone/>
               <a:defRPr sz="1575" b="1">
                 <a:solidFill>
                   <a:srgbClr val="101820"/>
@@ -3659,6 +3679,7 @@
           <a:lstStyle xmlns:a="http://schemas.openxmlformats.org/drawingml/2006/main"/>
           <a:p xmlns:a="http://schemas.openxmlformats.org/drawingml/2006/main">
             <a:pPr algn="ctr">
+              <a:buNone/>
               <a:defRPr sz="1200" b="0">
                 <a:solidFill>
                   <a:srgbClr val="59636E"/>
@@ -3719,6 +3740,7 @@
           <a:lstStyle xmlns:a="http://schemas.openxmlformats.org/drawingml/2006/main"/>
           <a:p xmlns:a="http://schemas.openxmlformats.org/drawingml/2006/main">
             <a:pPr algn="ctr">
+              <a:buNone/>
               <a:defRPr sz="1200" b="1">
                 <a:solidFill>
                   <a:srgbClr val="FFFFFF"/>
@@ -3808,6 +3830,7 @@
           <a:lstStyle xmlns:a="http://schemas.openxmlformats.org/drawingml/2006/main"/>
           <a:p xmlns:a="http://schemas.openxmlformats.org/drawingml/2006/main">
             <a:pPr algn="ctr">
+              <a:buNone/>
               <a:defRPr sz="1575" b="1">
                 <a:solidFill>
                   <a:srgbClr val="101820"/>
@@ -3864,6 +3887,7 @@
           <a:lstStyle xmlns:a="http://schemas.openxmlformats.org/drawingml/2006/main"/>
           <a:p xmlns:a="http://schemas.openxmlformats.org/drawingml/2006/main">
             <a:pPr algn="ctr">
+              <a:buNone/>
               <a:defRPr sz="1200" b="0">
                 <a:solidFill>
                   <a:srgbClr val="59636E"/>
@@ -3924,6 +3948,7 @@
           <a:lstStyle xmlns:a="http://schemas.openxmlformats.org/drawingml/2006/main"/>
           <a:p xmlns:a="http://schemas.openxmlformats.org/drawingml/2006/main">
             <a:pPr algn="ctr">
+              <a:buNone/>
               <a:defRPr sz="1200" b="1">
                 <a:solidFill>
                   <a:srgbClr val="FFFFFF"/>
@@ -4013,6 +4038,7 @@
           <a:lstStyle xmlns:a="http://schemas.openxmlformats.org/drawingml/2006/main"/>
           <a:p xmlns:a="http://schemas.openxmlformats.org/drawingml/2006/main">
             <a:pPr algn="ctr">
+              <a:buNone/>
               <a:defRPr sz="1575" b="1">
                 <a:solidFill>
                   <a:srgbClr val="101820"/>
@@ -4069,6 +4095,7 @@
           <a:lstStyle xmlns:a="http://schemas.openxmlformats.org/drawingml/2006/main"/>
           <a:p xmlns:a="http://schemas.openxmlformats.org/drawingml/2006/main">
             <a:pPr algn="ctr">
+              <a:buNone/>
               <a:defRPr sz="1200" b="0">
                 <a:solidFill>
                   <a:srgbClr val="59636E"/>
@@ -4129,6 +4156,7 @@
           <a:lstStyle xmlns:a="http://schemas.openxmlformats.org/drawingml/2006/main"/>
           <a:p xmlns:a="http://schemas.openxmlformats.org/drawingml/2006/main">
             <a:pPr algn="ctr">
+              <a:buNone/>
               <a:defRPr sz="1200" b="1">
                 <a:solidFill>
                   <a:srgbClr val="FFFFFF"/>
@@ -4218,6 +4246,7 @@
           <a:lstStyle xmlns:a="http://schemas.openxmlformats.org/drawingml/2006/main"/>
           <a:p xmlns:a="http://schemas.openxmlformats.org/drawingml/2006/main">
             <a:pPr algn="ctr">
+              <a:buNone/>
               <a:defRPr sz="1575" b="1">
                 <a:solidFill>
                   <a:srgbClr val="101820"/>
@@ -4274,6 +4303,7 @@
           <a:lstStyle xmlns:a="http://schemas.openxmlformats.org/drawingml/2006/main"/>
           <a:p xmlns:a="http://schemas.openxmlformats.org/drawingml/2006/main">
             <a:pPr algn="ctr">
+              <a:buNone/>
               <a:defRPr sz="1200" b="0">
                 <a:solidFill>
                   <a:srgbClr val="59636E"/>
@@ -4334,6 +4364,7 @@
           <a:lstStyle xmlns:a="http://schemas.openxmlformats.org/drawingml/2006/main"/>
           <a:p xmlns:a="http://schemas.openxmlformats.org/drawingml/2006/main">
             <a:pPr algn="ctr">
+              <a:buNone/>
               <a:defRPr sz="1200" b="1">
                 <a:solidFill>
                   <a:srgbClr val="FFFFFF"/>
@@ -4390,6 +4421,7 @@
           <a:lstStyle xmlns:a="http://schemas.openxmlformats.org/drawingml/2006/main"/>
           <a:p xmlns:a="http://schemas.openxmlformats.org/drawingml/2006/main">
             <a:pPr algn="ctr">
+              <a:buNone/>
               <a:defRPr sz="1575" b="1">
                 <a:solidFill>
                   <a:srgbClr val="101820"/>
@@ -4446,6 +4478,7 @@
           <a:lstStyle xmlns:a="http://schemas.openxmlformats.org/drawingml/2006/main"/>
           <a:p xmlns:a="http://schemas.openxmlformats.org/drawingml/2006/main">
             <a:pPr algn="ctr">
+              <a:buNone/>
               <a:defRPr sz="1200" b="0">
                 <a:solidFill>
                   <a:srgbClr val="59636E"/>
@@ -4537,6 +4570,7 @@
           <a:lstStyle xmlns:a="http://schemas.openxmlformats.org/drawingml/2006/main"/>
           <a:p xmlns:a="http://schemas.openxmlformats.org/drawingml/2006/main">
             <a:pPr algn="ctr">
+              <a:buNone/>
               <a:defRPr sz="2100" b="1">
                 <a:solidFill>
                   <a:srgbClr val="FFFFFF"/>
@@ -4593,6 +4627,7 @@
           <a:lstStyle xmlns:a="http://schemas.openxmlformats.org/drawingml/2006/main"/>
           <a:p xmlns:a="http://schemas.openxmlformats.org/drawingml/2006/main">
             <a:pPr algn="ctr">
+              <a:buNone/>
               <a:defRPr sz="1350" b="0">
                 <a:solidFill>
                   <a:srgbClr val="CBE1E3"/>
@@ -4684,6 +4719,7 @@
           <a:lstStyle xmlns:a="http://schemas.openxmlformats.org/drawingml/2006/main"/>
           <a:p xmlns:a="http://schemas.openxmlformats.org/drawingml/2006/main">
             <a:pPr algn="ctr">
+              <a:buNone/>
               <a:defRPr sz="1050" b="1">
                 <a:solidFill>
                   <a:srgbClr val="B4382C"/>
@@ -4769,6 +4805,7 @@
           <a:lstStyle xmlns:a="http://schemas.openxmlformats.org/drawingml/2006/main"/>
           <a:p xmlns:a="http://schemas.openxmlformats.org/drawingml/2006/main">
             <a:pPr algn="l">
+              <a:buNone/>
               <a:defRPr sz="900" b="1">
                 <a:solidFill>
                   <a:srgbClr val="2D8CFF"/>
@@ -4825,6 +4862,7 @@
           <a:lstStyle xmlns:a="http://schemas.openxmlformats.org/drawingml/2006/main"/>
           <a:p xmlns:a="http://schemas.openxmlformats.org/drawingml/2006/main">
             <a:pPr algn="l">
+              <a:buNone/>
               <a:defRPr sz="3300" b="1">
                 <a:solidFill>
                   <a:srgbClr val="101820"/>
@@ -4914,6 +4952,7 @@
           <a:lstStyle xmlns:a="http://schemas.openxmlformats.org/drawingml/2006/main"/>
           <a:p xmlns:a="http://schemas.openxmlformats.org/drawingml/2006/main">
             <a:pPr algn="l">
+              <a:buNone/>
               <a:defRPr sz="750" b="1">
                 <a:solidFill>
                   <a:srgbClr val="59636E"/>
@@ -4970,6 +5009,7 @@
           <a:lstStyle xmlns:a="http://schemas.openxmlformats.org/drawingml/2006/main"/>
           <a:p xmlns:a="http://schemas.openxmlformats.org/drawingml/2006/main">
             <a:pPr algn="r">
+              <a:buNone/>
               <a:defRPr sz="900" b="1">
                 <a:solidFill>
                   <a:srgbClr val="59636E"/>
@@ -5061,6 +5101,7 @@
           <a:lstStyle xmlns:a="http://schemas.openxmlformats.org/drawingml/2006/main"/>
           <a:p xmlns:a="http://schemas.openxmlformats.org/drawingml/2006/main">
             <a:pPr algn="l">
+              <a:buNone/>
               <a:defRPr sz="1200" b="1">
                 <a:solidFill>
                   <a:srgbClr val="FFFFFF"/>
@@ -5117,6 +5158,7 @@
           <a:lstStyle xmlns:a="http://schemas.openxmlformats.org/drawingml/2006/main"/>
           <a:p xmlns:a="http://schemas.openxmlformats.org/drawingml/2006/main">
             <a:pPr algn="l">
+              <a:buNone/>
               <a:defRPr sz="1200" b="1">
                 <a:solidFill>
                   <a:srgbClr val="FFFFFF"/>
@@ -5173,6 +5215,7 @@
           <a:lstStyle xmlns:a="http://schemas.openxmlformats.org/drawingml/2006/main"/>
           <a:p xmlns:a="http://schemas.openxmlformats.org/drawingml/2006/main">
             <a:pPr algn="l">
+              <a:buNone/>
               <a:defRPr sz="1200" b="1">
                 <a:solidFill>
                   <a:srgbClr val="FFFFFF"/>
@@ -5264,6 +5307,7 @@
           <a:lstStyle xmlns:a="http://schemas.openxmlformats.org/drawingml/2006/main"/>
           <a:p xmlns:a="http://schemas.openxmlformats.org/drawingml/2006/main">
             <a:pPr algn="l">
+              <a:buNone/>
               <a:defRPr sz="1200" b="1">
                 <a:solidFill>
                   <a:srgbClr val="101820"/>
@@ -5320,6 +5364,7 @@
           <a:lstStyle xmlns:a="http://schemas.openxmlformats.org/drawingml/2006/main"/>
           <a:p xmlns:a="http://schemas.openxmlformats.org/drawingml/2006/main">
             <a:pPr algn="l">
+              <a:buNone/>
               <a:defRPr sz="1125" b="0">
                 <a:solidFill>
                   <a:srgbClr val="59636E"/>
@@ -5376,6 +5421,7 @@
           <a:lstStyle xmlns:a="http://schemas.openxmlformats.org/drawingml/2006/main"/>
           <a:p xmlns:a="http://schemas.openxmlformats.org/drawingml/2006/main">
             <a:pPr algn="l">
+              <a:buNone/>
               <a:defRPr sz="1125" b="0">
                 <a:solidFill>
                   <a:srgbClr val="101820"/>
@@ -5467,6 +5513,7 @@
           <a:lstStyle xmlns:a="http://schemas.openxmlformats.org/drawingml/2006/main"/>
           <a:p xmlns:a="http://schemas.openxmlformats.org/drawingml/2006/main">
             <a:pPr algn="l">
+              <a:buNone/>
               <a:defRPr sz="1200" b="1">
                 <a:solidFill>
                   <a:srgbClr val="101820"/>
@@ -5523,6 +5570,7 @@
           <a:lstStyle xmlns:a="http://schemas.openxmlformats.org/drawingml/2006/main"/>
           <a:p xmlns:a="http://schemas.openxmlformats.org/drawingml/2006/main">
             <a:pPr algn="l">
+              <a:buNone/>
               <a:defRPr sz="1125" b="0">
                 <a:solidFill>
                   <a:srgbClr val="59636E"/>
@@ -5579,6 +5627,7 @@
           <a:lstStyle xmlns:a="http://schemas.openxmlformats.org/drawingml/2006/main"/>
           <a:p xmlns:a="http://schemas.openxmlformats.org/drawingml/2006/main">
             <a:pPr algn="l">
+              <a:buNone/>
               <a:defRPr sz="1125" b="0">
                 <a:solidFill>
                   <a:srgbClr val="101820"/>
@@ -5670,6 +5719,7 @@
           <a:lstStyle xmlns:a="http://schemas.openxmlformats.org/drawingml/2006/main"/>
           <a:p xmlns:a="http://schemas.openxmlformats.org/drawingml/2006/main">
             <a:pPr algn="l">
+              <a:buNone/>
               <a:defRPr sz="1200" b="1">
                 <a:solidFill>
                   <a:srgbClr val="101820"/>
@@ -5726,6 +5776,7 @@
           <a:lstStyle xmlns:a="http://schemas.openxmlformats.org/drawingml/2006/main"/>
           <a:p xmlns:a="http://schemas.openxmlformats.org/drawingml/2006/main">
             <a:pPr algn="l">
+              <a:buNone/>
               <a:defRPr sz="1125" b="0">
                 <a:solidFill>
                   <a:srgbClr val="59636E"/>
@@ -5782,6 +5833,7 @@
           <a:lstStyle xmlns:a="http://schemas.openxmlformats.org/drawingml/2006/main"/>
           <a:p xmlns:a="http://schemas.openxmlformats.org/drawingml/2006/main">
             <a:pPr algn="l">
+              <a:buNone/>
               <a:defRPr sz="1125" b="0">
                 <a:solidFill>
                   <a:srgbClr val="101820"/>
@@ -5873,6 +5925,7 @@
           <a:lstStyle xmlns:a="http://schemas.openxmlformats.org/drawingml/2006/main"/>
           <a:p xmlns:a="http://schemas.openxmlformats.org/drawingml/2006/main">
             <a:pPr algn="l">
+              <a:buNone/>
               <a:defRPr sz="1200" b="1">
                 <a:solidFill>
                   <a:srgbClr val="101820"/>
@@ -5929,6 +5982,7 @@
           <a:lstStyle xmlns:a="http://schemas.openxmlformats.org/drawingml/2006/main"/>
           <a:p xmlns:a="http://schemas.openxmlformats.org/drawingml/2006/main">
             <a:pPr algn="l">
+              <a:buNone/>
               <a:defRPr sz="1125" b="0">
                 <a:solidFill>
                   <a:srgbClr val="59636E"/>
@@ -5985,6 +6039,7 @@
           <a:lstStyle xmlns:a="http://schemas.openxmlformats.org/drawingml/2006/main"/>
           <a:p xmlns:a="http://schemas.openxmlformats.org/drawingml/2006/main">
             <a:pPr algn="l">
+              <a:buNone/>
               <a:defRPr sz="1125" b="0">
                 <a:solidFill>
                   <a:srgbClr val="101820"/>
@@ -6076,6 +6131,7 @@
           <a:lstStyle xmlns:a="http://schemas.openxmlformats.org/drawingml/2006/main"/>
           <a:p xmlns:a="http://schemas.openxmlformats.org/drawingml/2006/main">
             <a:pPr algn="l">
+              <a:buNone/>
               <a:defRPr sz="1200" b="1">
                 <a:solidFill>
                   <a:srgbClr val="B4382C"/>
@@ -6132,6 +6188,7 @@
           <a:lstStyle xmlns:a="http://schemas.openxmlformats.org/drawingml/2006/main"/>
           <a:p xmlns:a="http://schemas.openxmlformats.org/drawingml/2006/main">
             <a:pPr algn="l">
+              <a:buNone/>
               <a:defRPr sz="1125" b="0">
                 <a:solidFill>
                   <a:srgbClr val="59636E"/>
@@ -6188,6 +6245,7 @@
           <a:lstStyle xmlns:a="http://schemas.openxmlformats.org/drawingml/2006/main"/>
           <a:p xmlns:a="http://schemas.openxmlformats.org/drawingml/2006/main">
             <a:pPr algn="l">
+              <a:buNone/>
               <a:defRPr sz="1125" b="0">
                 <a:solidFill>
                   <a:srgbClr val="101820"/>
@@ -6279,6 +6337,7 @@
           <a:lstStyle xmlns:a="http://schemas.openxmlformats.org/drawingml/2006/main"/>
           <a:p xmlns:a="http://schemas.openxmlformats.org/drawingml/2006/main">
             <a:pPr algn="l">
+              <a:buNone/>
               <a:defRPr sz="1200" b="1">
                 <a:solidFill>
                   <a:srgbClr val="101820"/>
@@ -6335,6 +6394,7 @@
           <a:lstStyle xmlns:a="http://schemas.openxmlformats.org/drawingml/2006/main"/>
           <a:p xmlns:a="http://schemas.openxmlformats.org/drawingml/2006/main">
             <a:pPr algn="l">
+              <a:buNone/>
               <a:defRPr sz="1125" b="0">
                 <a:solidFill>
                   <a:srgbClr val="59636E"/>
@@ -6391,6 +6451,7 @@
           <a:lstStyle xmlns:a="http://schemas.openxmlformats.org/drawingml/2006/main"/>
           <a:p xmlns:a="http://schemas.openxmlformats.org/drawingml/2006/main">
             <a:pPr algn="l">
+              <a:buNone/>
               <a:defRPr sz="1125" b="0">
                 <a:solidFill>
                   <a:srgbClr val="101820"/>
@@ -6476,6 +6537,7 @@
           <a:lstStyle xmlns:a="http://schemas.openxmlformats.org/drawingml/2006/main"/>
           <a:p xmlns:a="http://schemas.openxmlformats.org/drawingml/2006/main">
             <a:pPr algn="l">
+              <a:buNone/>
               <a:defRPr sz="900" b="1">
                 <a:solidFill>
                   <a:srgbClr val="2D8CFF"/>
@@ -6532,6 +6594,7 @@
           <a:lstStyle xmlns:a="http://schemas.openxmlformats.org/drawingml/2006/main"/>
           <a:p xmlns:a="http://schemas.openxmlformats.org/drawingml/2006/main">
             <a:pPr algn="l">
+              <a:buNone/>
               <a:defRPr sz="2700" b="1">
                 <a:solidFill>
                   <a:srgbClr val="101820"/>
@@ -6621,6 +6684,7 @@
           <a:lstStyle xmlns:a="http://schemas.openxmlformats.org/drawingml/2006/main"/>
           <a:p xmlns:a="http://schemas.openxmlformats.org/drawingml/2006/main">
             <a:pPr algn="l">
+              <a:buNone/>
               <a:defRPr sz="750" b="1">
                 <a:solidFill>
                   <a:srgbClr val="59636E"/>
@@ -6677,6 +6741,7 @@
           <a:lstStyle xmlns:a="http://schemas.openxmlformats.org/drawingml/2006/main"/>
           <a:p xmlns:a="http://schemas.openxmlformats.org/drawingml/2006/main">
             <a:pPr algn="r">
+              <a:buNone/>
               <a:defRPr sz="900" b="1">
                 <a:solidFill>
                   <a:srgbClr val="59636E"/>
@@ -6733,6 +6798,7 @@
           <a:lstStyle xmlns:a="http://schemas.openxmlformats.org/drawingml/2006/main"/>
           <a:p xmlns:a="http://schemas.openxmlformats.org/drawingml/2006/main">
             <a:pPr algn="l">
+              <a:buNone/>
               <a:defRPr sz="900" b="1">
                 <a:solidFill>
                   <a:srgbClr val="2D8CFF"/>
@@ -6793,14 +6859,14 @@
       </p:sp>
       <p:pic>
         <p:nvPicPr>
-          <p:cNvPr id="25" name=""/>
+          <p:cNvPr id="27" name=""/>
           <p:cNvPicPr>
             <a:picLocks xmlns:a="http://schemas.openxmlformats.org/drawingml/2006/main" noChangeAspect="1"/>
           </p:cNvPicPr>
           <p:nvPr/>
         </p:nvPicPr>
         <p:blipFill>
-          <a:blip xmlns:r="http://schemas.openxmlformats.org/officeDocument/2006/relationships" xmlns:a="http://schemas.openxmlformats.org/drawingml/2006/main" r:embed="Rad5d39a910ab4c25"/>
+          <a:blip xmlns:r="http://schemas.openxmlformats.org/officeDocument/2006/relationships" xmlns:a="http://schemas.openxmlformats.org/drawingml/2006/main" r:embed="R369d0f25f61349b0"/>
           <a:srcRect xmlns:a="http://schemas.openxmlformats.org/drawingml/2006/main" l="0" t="4048" r="0" b="4048"/>
           <a:stretch xmlns:a="http://schemas.openxmlformats.org/drawingml/2006/main">
             <a:fillRect l="0" t="0" r="0" b="0"/>
@@ -6886,6 +6952,7 @@
           <a:lstStyle xmlns:a="http://schemas.openxmlformats.org/drawingml/2006/main"/>
           <a:p xmlns:a="http://schemas.openxmlformats.org/drawingml/2006/main">
             <a:pPr algn="ctr">
+              <a:buNone/>
               <a:defRPr sz="1050" b="1">
                 <a:solidFill>
                   <a:srgbClr val="E79A54"/>
@@ -6942,6 +7009,7 @@
           <a:lstStyle xmlns:a="http://schemas.openxmlformats.org/drawingml/2006/main"/>
           <a:p xmlns:a="http://schemas.openxmlformats.org/drawingml/2006/main">
             <a:pPr algn="l">
+              <a:buNone/>
               <a:defRPr sz="1050" b="1">
                 <a:solidFill>
                   <a:srgbClr val="59636E"/>
@@ -6998,6 +7066,7 @@
           <a:lstStyle xmlns:a="http://schemas.openxmlformats.org/drawingml/2006/main"/>
           <a:p xmlns:a="http://schemas.openxmlformats.org/drawingml/2006/main">
             <a:pPr algn="l">
+              <a:buNone/>
               <a:defRPr sz="1350" b="1">
                 <a:solidFill>
                   <a:srgbClr val="1B5964"/>
@@ -7054,6 +7123,7 @@
           <a:lstStyle xmlns:a="http://schemas.openxmlformats.org/drawingml/2006/main"/>
           <a:p xmlns:a="http://schemas.openxmlformats.org/drawingml/2006/main">
             <a:pPr algn="l">
+              <a:buNone/>
               <a:defRPr sz="1050" b="1">
                 <a:solidFill>
                   <a:srgbClr val="59636E"/>
@@ -7110,6 +7180,7 @@
           <a:lstStyle xmlns:a="http://schemas.openxmlformats.org/drawingml/2006/main"/>
           <a:p xmlns:a="http://schemas.openxmlformats.org/drawingml/2006/main">
             <a:pPr algn="l">
+              <a:buNone/>
               <a:defRPr sz="1500" b="1">
                 <a:solidFill>
                   <a:srgbClr val="101820"/>
@@ -7133,6 +7204,7 @@
           </a:p>
           <a:p xmlns:a="http://schemas.openxmlformats.org/drawingml/2006/main">
             <a:pPr algn="l">
+              <a:buNone/>
               <a:defRPr sz="1500" b="1">
                 <a:solidFill>
                   <a:srgbClr val="101820"/>
@@ -7224,6 +7296,7 @@
           <a:lstStyle xmlns:a="http://schemas.openxmlformats.org/drawingml/2006/main"/>
           <a:p xmlns:a="http://schemas.openxmlformats.org/drawingml/2006/main">
             <a:pPr algn="ctr">
+              <a:buNone/>
               <a:defRPr sz="1350" b="1">
                 <a:solidFill>
                   <a:srgbClr val="2D8CFF"/>
@@ -7280,6 +7353,7 @@
           <a:lstStyle xmlns:a="http://schemas.openxmlformats.org/drawingml/2006/main"/>
           <a:p xmlns:a="http://schemas.openxmlformats.org/drawingml/2006/main">
             <a:pPr algn="l">
+              <a:buNone/>
               <a:defRPr sz="900" b="1">
                 <a:solidFill>
                   <a:srgbClr val="2D8CFF"/>
@@ -7365,6 +7439,7 @@
           <a:lstStyle xmlns:a="http://schemas.openxmlformats.org/drawingml/2006/main"/>
           <a:p xmlns:a="http://schemas.openxmlformats.org/drawingml/2006/main">
             <a:pPr algn="l">
+              <a:buNone/>
               <a:defRPr sz="975" b="1">
                 <a:solidFill>
                   <a:srgbClr val="2D8CFF"/>
@@ -7421,6 +7496,7 @@
           <a:lstStyle xmlns:a="http://schemas.openxmlformats.org/drawingml/2006/main"/>
           <a:p xmlns:a="http://schemas.openxmlformats.org/drawingml/2006/main">
             <a:pPr algn="l">
+              <a:buNone/>
               <a:defRPr sz="3900" b="1">
                 <a:solidFill>
                   <a:srgbClr val="101820"/>
@@ -7481,6 +7557,7 @@
           <a:lstStyle xmlns:a="http://schemas.openxmlformats.org/drawingml/2006/main"/>
           <a:p xmlns:a="http://schemas.openxmlformats.org/drawingml/2006/main">
             <a:pPr algn="ctr">
+              <a:buNone/>
               <a:defRPr sz="1425" b="1">
                 <a:solidFill>
                   <a:srgbClr val="FFFFFF"/>
@@ -7537,6 +7614,7 @@
           <a:lstStyle xmlns:a="http://schemas.openxmlformats.org/drawingml/2006/main"/>
           <a:p xmlns:a="http://schemas.openxmlformats.org/drawingml/2006/main">
             <a:pPr algn="l">
+              <a:buNone/>
               <a:defRPr sz="1575" b="0">
                 <a:solidFill>
                   <a:srgbClr val="101820"/>
@@ -7597,6 +7675,7 @@
           <a:lstStyle xmlns:a="http://schemas.openxmlformats.org/drawingml/2006/main"/>
           <a:p xmlns:a="http://schemas.openxmlformats.org/drawingml/2006/main">
             <a:pPr algn="ctr">
+              <a:buNone/>
               <a:defRPr sz="1425" b="1">
                 <a:solidFill>
                   <a:srgbClr val="FFFFFF"/>
@@ -7653,6 +7732,7 @@
           <a:lstStyle xmlns:a="http://schemas.openxmlformats.org/drawingml/2006/main"/>
           <a:p xmlns:a="http://schemas.openxmlformats.org/drawingml/2006/main">
             <a:pPr algn="l">
+              <a:buNone/>
               <a:defRPr sz="1575" b="0">
                 <a:solidFill>
                   <a:srgbClr val="101820"/>
@@ -7713,6 +7793,7 @@
           <a:lstStyle xmlns:a="http://schemas.openxmlformats.org/drawingml/2006/main"/>
           <a:p xmlns:a="http://schemas.openxmlformats.org/drawingml/2006/main">
             <a:pPr algn="ctr">
+              <a:buNone/>
               <a:defRPr sz="1425" b="1">
                 <a:solidFill>
                   <a:srgbClr val="FFFFFF"/>
@@ -7769,6 +7850,7 @@
           <a:lstStyle xmlns:a="http://schemas.openxmlformats.org/drawingml/2006/main"/>
           <a:p xmlns:a="http://schemas.openxmlformats.org/drawingml/2006/main">
             <a:pPr algn="l">
+              <a:buNone/>
               <a:defRPr sz="1575" b="0">
                 <a:solidFill>
                   <a:srgbClr val="101820"/>
@@ -7829,6 +7911,7 @@
           <a:lstStyle xmlns:a="http://schemas.openxmlformats.org/drawingml/2006/main"/>
           <a:p xmlns:a="http://schemas.openxmlformats.org/drawingml/2006/main">
             <a:pPr algn="ctr">
+              <a:buNone/>
               <a:defRPr sz="1425" b="1">
                 <a:solidFill>
                   <a:srgbClr val="FFFFFF"/>
@@ -7885,6 +7968,7 @@
           <a:lstStyle xmlns:a="http://schemas.openxmlformats.org/drawingml/2006/main"/>
           <a:p xmlns:a="http://schemas.openxmlformats.org/drawingml/2006/main">
             <a:pPr algn="l">
+              <a:buNone/>
               <a:defRPr sz="1575" b="1">
                 <a:solidFill>
                   <a:srgbClr val="1B5964"/>
@@ -7945,6 +8029,7 @@
           <a:lstStyle xmlns:a="http://schemas.openxmlformats.org/drawingml/2006/main"/>
           <a:p xmlns:a="http://schemas.openxmlformats.org/drawingml/2006/main">
             <a:pPr algn="ctr">
+              <a:buNone/>
               <a:defRPr sz="1425" b="1">
                 <a:solidFill>
                   <a:srgbClr val="FFFFFF"/>
@@ -8001,6 +8086,7 @@
           <a:lstStyle xmlns:a="http://schemas.openxmlformats.org/drawingml/2006/main"/>
           <a:p xmlns:a="http://schemas.openxmlformats.org/drawingml/2006/main">
             <a:pPr algn="l">
+              <a:buNone/>
               <a:defRPr sz="1575" b="0">
                 <a:solidFill>
                   <a:srgbClr val="101820"/>
@@ -8092,6 +8178,7 @@
           <a:lstStyle xmlns:a="http://schemas.openxmlformats.org/drawingml/2006/main"/>
           <a:p xmlns:a="http://schemas.openxmlformats.org/drawingml/2006/main">
             <a:pPr algn="ctr">
+              <a:buNone/>
               <a:defRPr sz="1500" b="1">
                 <a:solidFill>
                   <a:srgbClr val="FFFFFF"/>
@@ -8148,6 +8235,7 @@
           <a:lstStyle xmlns:a="http://schemas.openxmlformats.org/drawingml/2006/main"/>
           <a:p xmlns:a="http://schemas.openxmlformats.org/drawingml/2006/main">
             <a:pPr algn="ctr">
+              <a:buNone/>
               <a:defRPr sz="2475" b="1">
                 <a:solidFill>
                   <a:srgbClr val="FFFFFF"/>
@@ -8171,6 +8259,7 @@
           </a:p>
           <a:p xmlns:a="http://schemas.openxmlformats.org/drawingml/2006/main">
             <a:pPr algn="ctr">
+              <a:buNone/>
               <a:defRPr sz="2475" b="1">
                 <a:solidFill>
                   <a:srgbClr val="FFFFFF"/>
@@ -8194,6 +8283,7 @@
           </a:p>
           <a:p xmlns:a="http://schemas.openxmlformats.org/drawingml/2006/main">
             <a:pPr algn="ctr">
+              <a:buNone/>
               <a:defRPr sz="2475" b="1">
                 <a:solidFill>
                   <a:srgbClr val="FFFFFF"/>
@@ -8250,6 +8340,7 @@
           <a:lstStyle xmlns:a="http://schemas.openxmlformats.org/drawingml/2006/main"/>
           <a:p xmlns:a="http://schemas.openxmlformats.org/drawingml/2006/main">
             <a:pPr algn="ctr">
+              <a:buNone/>
               <a:defRPr sz="1125" b="0">
                 <a:solidFill>
                   <a:srgbClr val="DCEBFF"/>
@@ -8273,6 +8364,7 @@
           </a:p>
           <a:p xmlns:a="http://schemas.openxmlformats.org/drawingml/2006/main">
             <a:pPr algn="ctr">
+              <a:buNone/>
               <a:defRPr sz="1125" b="0">
                 <a:solidFill>
                   <a:srgbClr val="DCEBFF"/>
@@ -8362,6 +8454,7 @@
           <a:lstStyle xmlns:a="http://schemas.openxmlformats.org/drawingml/2006/main"/>
           <a:p xmlns:a="http://schemas.openxmlformats.org/drawingml/2006/main">
             <a:pPr algn="l">
+              <a:buNone/>
               <a:defRPr sz="750" b="1">
                 <a:solidFill>
                   <a:srgbClr val="59636E"/>
@@ -8418,6 +8511,7 @@
           <a:lstStyle xmlns:a="http://schemas.openxmlformats.org/drawingml/2006/main"/>
           <a:p xmlns:a="http://schemas.openxmlformats.org/drawingml/2006/main">
             <a:pPr algn="r">
+              <a:buNone/>
               <a:defRPr sz="900" b="1">
                 <a:solidFill>
                   <a:srgbClr val="59636E"/>
@@ -8503,6 +8597,7 @@
           <a:lstStyle xmlns:a="http://schemas.openxmlformats.org/drawingml/2006/main"/>
           <a:p xmlns:a="http://schemas.openxmlformats.org/drawingml/2006/main">
             <a:pPr algn="l">
+              <a:buNone/>
               <a:defRPr sz="900" b="1">
                 <a:solidFill>
                   <a:srgbClr val="2D8CFF"/>
@@ -8559,6 +8654,7 @@
           <a:lstStyle xmlns:a="http://schemas.openxmlformats.org/drawingml/2006/main"/>
           <a:p xmlns:a="http://schemas.openxmlformats.org/drawingml/2006/main">
             <a:pPr algn="l">
+              <a:buNone/>
               <a:defRPr sz="3300" b="1">
                 <a:solidFill>
                   <a:srgbClr val="101820"/>
@@ -8648,6 +8744,7 @@
           <a:lstStyle xmlns:a="http://schemas.openxmlformats.org/drawingml/2006/main"/>
           <a:p xmlns:a="http://schemas.openxmlformats.org/drawingml/2006/main">
             <a:pPr algn="l">
+              <a:buNone/>
               <a:defRPr sz="750" b="1">
                 <a:solidFill>
                   <a:srgbClr val="59636E"/>
@@ -8704,6 +8801,7 @@
           <a:lstStyle xmlns:a="http://schemas.openxmlformats.org/drawingml/2006/main"/>
           <a:p xmlns:a="http://schemas.openxmlformats.org/drawingml/2006/main">
             <a:pPr algn="r">
+              <a:buNone/>
               <a:defRPr sz="900" b="1">
                 <a:solidFill>
                   <a:srgbClr val="59636E"/>
@@ -8760,6 +8858,7 @@
           <a:lstStyle xmlns:a="http://schemas.openxmlformats.org/drawingml/2006/main"/>
           <a:p xmlns:a="http://schemas.openxmlformats.org/drawingml/2006/main">
             <a:pPr algn="l">
+              <a:buNone/>
               <a:defRPr sz="900" b="1">
                 <a:solidFill>
                   <a:srgbClr val="2D8CFF"/>
@@ -8855,6 +8954,7 @@
           <a:lstStyle xmlns:a="http://schemas.openxmlformats.org/drawingml/2006/main"/>
           <a:p xmlns:a="http://schemas.openxmlformats.org/drawingml/2006/main">
             <a:pPr algn="ctr">
+              <a:buNone/>
               <a:defRPr sz="1200" b="1">
                 <a:solidFill>
                   <a:srgbClr val="FFFFFF"/>
@@ -8911,6 +9011,7 @@
           <a:lstStyle xmlns:a="http://schemas.openxmlformats.org/drawingml/2006/main"/>
           <a:p xmlns:a="http://schemas.openxmlformats.org/drawingml/2006/main">
             <a:pPr algn="l">
+              <a:buNone/>
               <a:defRPr sz="1500" b="1">
                 <a:solidFill>
                   <a:srgbClr val="101820"/>
@@ -8967,6 +9068,7 @@
           <a:lstStyle xmlns:a="http://schemas.openxmlformats.org/drawingml/2006/main"/>
           <a:p xmlns:a="http://schemas.openxmlformats.org/drawingml/2006/main">
             <a:pPr algn="l">
+              <a:buNone/>
               <a:defRPr sz="1200" b="0">
                 <a:solidFill>
                   <a:srgbClr val="59636E"/>
@@ -9062,6 +9164,7 @@
           <a:lstStyle xmlns:a="http://schemas.openxmlformats.org/drawingml/2006/main"/>
           <a:p xmlns:a="http://schemas.openxmlformats.org/drawingml/2006/main">
             <a:pPr algn="ctr">
+              <a:buNone/>
               <a:defRPr sz="1200" b="1">
                 <a:solidFill>
                   <a:srgbClr val="FFFFFF"/>
@@ -9118,6 +9221,7 @@
           <a:lstStyle xmlns:a="http://schemas.openxmlformats.org/drawingml/2006/main"/>
           <a:p xmlns:a="http://schemas.openxmlformats.org/drawingml/2006/main">
             <a:pPr algn="l">
+              <a:buNone/>
               <a:defRPr sz="1500" b="1">
                 <a:solidFill>
                   <a:srgbClr val="101820"/>
@@ -9174,6 +9278,7 @@
           <a:lstStyle xmlns:a="http://schemas.openxmlformats.org/drawingml/2006/main"/>
           <a:p xmlns:a="http://schemas.openxmlformats.org/drawingml/2006/main">
             <a:pPr algn="l">
+              <a:buNone/>
               <a:defRPr sz="1200" b="0">
                 <a:solidFill>
                   <a:srgbClr val="59636E"/>
@@ -9269,6 +9374,7 @@
           <a:lstStyle xmlns:a="http://schemas.openxmlformats.org/drawingml/2006/main"/>
           <a:p xmlns:a="http://schemas.openxmlformats.org/drawingml/2006/main">
             <a:pPr algn="ctr">
+              <a:buNone/>
               <a:defRPr sz="1200" b="1">
                 <a:solidFill>
                   <a:srgbClr val="FFFFFF"/>
@@ -9325,6 +9431,7 @@
           <a:lstStyle xmlns:a="http://schemas.openxmlformats.org/drawingml/2006/main"/>
           <a:p xmlns:a="http://schemas.openxmlformats.org/drawingml/2006/main">
             <a:pPr algn="l">
+              <a:buNone/>
               <a:defRPr sz="1500" b="1">
                 <a:solidFill>
                   <a:srgbClr val="101820"/>
@@ -9381,6 +9488,7 @@
           <a:lstStyle xmlns:a="http://schemas.openxmlformats.org/drawingml/2006/main"/>
           <a:p xmlns:a="http://schemas.openxmlformats.org/drawingml/2006/main">
             <a:pPr algn="l">
+              <a:buNone/>
               <a:defRPr sz="1200" b="0">
                 <a:solidFill>
                   <a:srgbClr val="59636E"/>
@@ -9476,6 +9584,7 @@
           <a:lstStyle xmlns:a="http://schemas.openxmlformats.org/drawingml/2006/main"/>
           <a:p xmlns:a="http://schemas.openxmlformats.org/drawingml/2006/main">
             <a:pPr algn="ctr">
+              <a:buNone/>
               <a:defRPr sz="1200" b="1">
                 <a:solidFill>
                   <a:srgbClr val="FFFFFF"/>
@@ -9532,6 +9641,7 @@
           <a:lstStyle xmlns:a="http://schemas.openxmlformats.org/drawingml/2006/main"/>
           <a:p xmlns:a="http://schemas.openxmlformats.org/drawingml/2006/main">
             <a:pPr algn="l">
+              <a:buNone/>
               <a:defRPr sz="1500" b="1">
                 <a:solidFill>
                   <a:srgbClr val="101820"/>
@@ -9588,6 +9698,7 @@
           <a:lstStyle xmlns:a="http://schemas.openxmlformats.org/drawingml/2006/main"/>
           <a:p xmlns:a="http://schemas.openxmlformats.org/drawingml/2006/main">
             <a:pPr algn="l">
+              <a:buNone/>
               <a:defRPr sz="1200" b="0">
                 <a:solidFill>
                   <a:srgbClr val="59636E"/>
@@ -9679,6 +9790,7 @@
           <a:lstStyle xmlns:a="http://schemas.openxmlformats.org/drawingml/2006/main"/>
           <a:p xmlns:a="http://schemas.openxmlformats.org/drawingml/2006/main">
             <a:pPr algn="ctr">
+              <a:buNone/>
               <a:defRPr sz="1725" b="1">
                 <a:solidFill>
                   <a:srgbClr val="B4382C"/>
@@ -9764,6 +9876,7 @@
           <a:lstStyle xmlns:a="http://schemas.openxmlformats.org/drawingml/2006/main"/>
           <a:p xmlns:a="http://schemas.openxmlformats.org/drawingml/2006/main">
             <a:pPr algn="l">
+              <a:buNone/>
               <a:defRPr sz="900" b="1">
                 <a:solidFill>
                   <a:srgbClr val="2D8CFF"/>
@@ -9820,6 +9933,7 @@
           <a:lstStyle xmlns:a="http://schemas.openxmlformats.org/drawingml/2006/main"/>
           <a:p xmlns:a="http://schemas.openxmlformats.org/drawingml/2006/main">
             <a:pPr algn="l">
+              <a:buNone/>
               <a:defRPr sz="3300" b="1">
                 <a:solidFill>
                   <a:srgbClr val="101820"/>
@@ -9909,6 +10023,7 @@
           <a:lstStyle xmlns:a="http://schemas.openxmlformats.org/drawingml/2006/main"/>
           <a:p xmlns:a="http://schemas.openxmlformats.org/drawingml/2006/main">
             <a:pPr algn="l">
+              <a:buNone/>
               <a:defRPr sz="750" b="1">
                 <a:solidFill>
                   <a:srgbClr val="59636E"/>
@@ -9965,6 +10080,7 @@
           <a:lstStyle xmlns:a="http://schemas.openxmlformats.org/drawingml/2006/main"/>
           <a:p xmlns:a="http://schemas.openxmlformats.org/drawingml/2006/main">
             <a:pPr algn="r">
+              <a:buNone/>
               <a:defRPr sz="900" b="1">
                 <a:solidFill>
                   <a:srgbClr val="59636E"/>
@@ -10091,6 +10207,7 @@
           <a:lstStyle xmlns:a="http://schemas.openxmlformats.org/drawingml/2006/main"/>
           <a:p xmlns:a="http://schemas.openxmlformats.org/drawingml/2006/main">
             <a:pPr algn="ctr">
+              <a:buNone/>
               <a:defRPr sz="1050" b="1">
                 <a:solidFill>
                   <a:srgbClr val="2D8CFF"/>
@@ -10147,6 +10264,7 @@
           <a:lstStyle xmlns:a="http://schemas.openxmlformats.org/drawingml/2006/main"/>
           <a:p xmlns:a="http://schemas.openxmlformats.org/drawingml/2006/main">
             <a:pPr algn="l">
+              <a:buNone/>
               <a:defRPr sz="1425" b="1">
                 <a:solidFill>
                   <a:srgbClr val="101820"/>
@@ -10203,6 +10321,7 @@
           <a:lstStyle xmlns:a="http://schemas.openxmlformats.org/drawingml/2006/main"/>
           <a:p xmlns:a="http://schemas.openxmlformats.org/drawingml/2006/main">
             <a:pPr algn="l">
+              <a:buNone/>
               <a:defRPr sz="1050" b="0">
                 <a:solidFill>
                   <a:srgbClr val="59636E"/>
@@ -10329,6 +10448,7 @@
           <a:lstStyle xmlns:a="http://schemas.openxmlformats.org/drawingml/2006/main"/>
           <a:p xmlns:a="http://schemas.openxmlformats.org/drawingml/2006/main">
             <a:pPr algn="ctr">
+              <a:buNone/>
               <a:defRPr sz="1050" b="1">
                 <a:solidFill>
                   <a:srgbClr val="2D8CFF"/>
@@ -10385,6 +10505,7 @@
           <a:lstStyle xmlns:a="http://schemas.openxmlformats.org/drawingml/2006/main"/>
           <a:p xmlns:a="http://schemas.openxmlformats.org/drawingml/2006/main">
             <a:pPr algn="l">
+              <a:buNone/>
               <a:defRPr sz="1425" b="1">
                 <a:solidFill>
                   <a:srgbClr val="101820"/>
@@ -10441,6 +10562,7 @@
           <a:lstStyle xmlns:a="http://schemas.openxmlformats.org/drawingml/2006/main"/>
           <a:p xmlns:a="http://schemas.openxmlformats.org/drawingml/2006/main">
             <a:pPr algn="l">
+              <a:buNone/>
               <a:defRPr sz="1050" b="0">
                 <a:solidFill>
                   <a:srgbClr val="59636E"/>
@@ -10567,6 +10689,7 @@
           <a:lstStyle xmlns:a="http://schemas.openxmlformats.org/drawingml/2006/main"/>
           <a:p xmlns:a="http://schemas.openxmlformats.org/drawingml/2006/main">
             <a:pPr algn="ctr">
+              <a:buNone/>
               <a:defRPr sz="1050" b="1">
                 <a:solidFill>
                   <a:srgbClr val="E79A54"/>
@@ -10623,6 +10746,7 @@
           <a:lstStyle xmlns:a="http://schemas.openxmlformats.org/drawingml/2006/main"/>
           <a:p xmlns:a="http://schemas.openxmlformats.org/drawingml/2006/main">
             <a:pPr algn="l">
+              <a:buNone/>
               <a:defRPr sz="1425" b="1">
                 <a:solidFill>
                   <a:srgbClr val="101820"/>
@@ -10679,6 +10803,7 @@
           <a:lstStyle xmlns:a="http://schemas.openxmlformats.org/drawingml/2006/main"/>
           <a:p xmlns:a="http://schemas.openxmlformats.org/drawingml/2006/main">
             <a:pPr algn="l">
+              <a:buNone/>
               <a:defRPr sz="1050" b="0">
                 <a:solidFill>
                   <a:srgbClr val="59636E"/>
@@ -10770,6 +10895,7 @@
           <a:lstStyle xmlns:a="http://schemas.openxmlformats.org/drawingml/2006/main"/>
           <a:p xmlns:a="http://schemas.openxmlformats.org/drawingml/2006/main">
             <a:pPr algn="l">
+              <a:buNone/>
               <a:defRPr sz="2025" b="1">
                 <a:solidFill>
                   <a:srgbClr val="FFFFFF"/>
@@ -10826,6 +10952,7 @@
           <a:lstStyle xmlns:a="http://schemas.openxmlformats.org/drawingml/2006/main"/>
           <a:p xmlns:a="http://schemas.openxmlformats.org/drawingml/2006/main">
             <a:pPr algn="l">
+              <a:buNone/>
               <a:defRPr sz="975" b="1">
                 <a:solidFill>
                   <a:srgbClr val="A8D5DA"/>
@@ -10882,6 +11009,7 @@
           <a:lstStyle xmlns:a="http://schemas.openxmlformats.org/drawingml/2006/main"/>
           <a:p xmlns:a="http://schemas.openxmlformats.org/drawingml/2006/main">
             <a:pPr algn="l">
+              <a:buNone/>
               <a:defRPr sz="1500" b="0">
                 <a:solidFill>
                   <a:srgbClr val="FFFFFF"/>
@@ -10938,6 +11066,7 @@
           <a:lstStyle xmlns:a="http://schemas.openxmlformats.org/drawingml/2006/main"/>
           <a:p xmlns:a="http://schemas.openxmlformats.org/drawingml/2006/main">
             <a:pPr algn="l">
+              <a:buNone/>
               <a:defRPr sz="975" b="1">
                 <a:solidFill>
                   <a:srgbClr val="A8D5DA"/>
@@ -10994,6 +11123,7 @@
           <a:lstStyle xmlns:a="http://schemas.openxmlformats.org/drawingml/2006/main"/>
           <a:p xmlns:a="http://schemas.openxmlformats.org/drawingml/2006/main">
             <a:pPr algn="l">
+              <a:buNone/>
               <a:defRPr sz="1425" b="0">
                 <a:solidFill>
                   <a:srgbClr val="FFFFFF"/>
@@ -11085,6 +11215,7 @@
           <a:lstStyle xmlns:a="http://schemas.openxmlformats.org/drawingml/2006/main"/>
           <a:p xmlns:a="http://schemas.openxmlformats.org/drawingml/2006/main">
             <a:pPr algn="ctr">
+              <a:buNone/>
               <a:defRPr sz="1050" b="1">
                 <a:solidFill>
                   <a:srgbClr val="B4382C"/>
@@ -11170,6 +11301,7 @@
           <a:lstStyle xmlns:a="http://schemas.openxmlformats.org/drawingml/2006/main"/>
           <a:p xmlns:a="http://schemas.openxmlformats.org/drawingml/2006/main">
             <a:pPr algn="l">
+              <a:buNone/>
               <a:defRPr sz="900" b="1">
                 <a:solidFill>
                   <a:srgbClr val="2D8CFF"/>
@@ -11226,6 +11358,7 @@
           <a:lstStyle xmlns:a="http://schemas.openxmlformats.org/drawingml/2006/main"/>
           <a:p xmlns:a="http://schemas.openxmlformats.org/drawingml/2006/main">
             <a:pPr algn="l">
+              <a:buNone/>
               <a:defRPr sz="3300" b="1">
                 <a:solidFill>
                   <a:srgbClr val="101820"/>
@@ -11315,6 +11448,7 @@
           <a:lstStyle xmlns:a="http://schemas.openxmlformats.org/drawingml/2006/main"/>
           <a:p xmlns:a="http://schemas.openxmlformats.org/drawingml/2006/main">
             <a:pPr algn="l">
+              <a:buNone/>
               <a:defRPr sz="750" b="1">
                 <a:solidFill>
                   <a:srgbClr val="59636E"/>
@@ -11371,6 +11505,7 @@
           <a:lstStyle xmlns:a="http://schemas.openxmlformats.org/drawingml/2006/main"/>
           <a:p xmlns:a="http://schemas.openxmlformats.org/drawingml/2006/main">
             <a:pPr algn="r">
+              <a:buNone/>
               <a:defRPr sz="900" b="1">
                 <a:solidFill>
                   <a:srgbClr val="59636E"/>
@@ -11427,6 +11562,7 @@
           <a:lstStyle xmlns:a="http://schemas.openxmlformats.org/drawingml/2006/main"/>
           <a:p xmlns:a="http://schemas.openxmlformats.org/drawingml/2006/main">
             <a:pPr algn="l">
+              <a:buNone/>
               <a:defRPr sz="900" b="1">
                 <a:solidFill>
                   <a:srgbClr val="2D8CFF"/>
@@ -11487,14 +11623,14 @@
       </p:sp>
       <p:pic>
         <p:nvPicPr>
-          <p:cNvPr id="25" name=""/>
+          <p:cNvPr id="27" name=""/>
           <p:cNvPicPr>
             <a:picLocks xmlns:a="http://schemas.openxmlformats.org/drawingml/2006/main" noChangeAspect="1"/>
           </p:cNvPicPr>
           <p:nvPr/>
         </p:nvPicPr>
         <p:blipFill>
-          <a:blip xmlns:r="http://schemas.openxmlformats.org/officeDocument/2006/relationships" xmlns:a="http://schemas.openxmlformats.org/drawingml/2006/main" r:embed="R5b06538b8e1e4f9e"/>
+          <a:blip xmlns:r="http://schemas.openxmlformats.org/officeDocument/2006/relationships" xmlns:a="http://schemas.openxmlformats.org/drawingml/2006/main" r:embed="R078d4a8c10364fdf"/>
           <a:srcRect xmlns:a="http://schemas.openxmlformats.org/drawingml/2006/main" l="0" t="4073" r="0" b="4073"/>
           <a:stretch xmlns:a="http://schemas.openxmlformats.org/drawingml/2006/main">
             <a:fillRect l="0" t="0" r="0" b="0"/>
@@ -11545,6 +11681,7 @@
           <a:lstStyle xmlns:a="http://schemas.openxmlformats.org/drawingml/2006/main"/>
           <a:p xmlns:a="http://schemas.openxmlformats.org/drawingml/2006/main">
             <a:pPr algn="l">
+              <a:buNone/>
               <a:defRPr sz="1800" b="1">
                 <a:solidFill>
                   <a:srgbClr val="1B5964"/>
@@ -11568,6 +11705,7 @@
           </a:p>
           <a:p xmlns:a="http://schemas.openxmlformats.org/drawingml/2006/main">
             <a:pPr algn="l">
+              <a:buNone/>
               <a:defRPr sz="1800" b="1">
                 <a:solidFill>
                   <a:srgbClr val="1B5964"/>
@@ -11591,6 +11729,7 @@
           </a:p>
           <a:p xmlns:a="http://schemas.openxmlformats.org/drawingml/2006/main">
             <a:pPr algn="l">
+              <a:buNone/>
               <a:defRPr sz="1800" b="1">
                 <a:solidFill>
                   <a:srgbClr val="1B5964"/>
@@ -11651,6 +11790,7 @@
           <a:lstStyle xmlns:a="http://schemas.openxmlformats.org/drawingml/2006/main"/>
           <a:p xmlns:a="http://schemas.openxmlformats.org/drawingml/2006/main">
             <a:pPr algn="ctr">
+              <a:buNone/>
               <a:defRPr sz="1200" b="1">
                 <a:solidFill>
                   <a:srgbClr val="FFFFFF"/>
@@ -11707,6 +11847,7 @@
           <a:lstStyle xmlns:a="http://schemas.openxmlformats.org/drawingml/2006/main"/>
           <a:p xmlns:a="http://schemas.openxmlformats.org/drawingml/2006/main">
             <a:pPr algn="l">
+              <a:buNone/>
               <a:defRPr sz="1350" b="0">
                 <a:solidFill>
                   <a:srgbClr val="101820"/>
@@ -11767,6 +11908,7 @@
           <a:lstStyle xmlns:a="http://schemas.openxmlformats.org/drawingml/2006/main"/>
           <a:p xmlns:a="http://schemas.openxmlformats.org/drawingml/2006/main">
             <a:pPr algn="ctr">
+              <a:buNone/>
               <a:defRPr sz="1200" b="1">
                 <a:solidFill>
                   <a:srgbClr val="FFFFFF"/>
@@ -11823,6 +11965,7 @@
           <a:lstStyle xmlns:a="http://schemas.openxmlformats.org/drawingml/2006/main"/>
           <a:p xmlns:a="http://schemas.openxmlformats.org/drawingml/2006/main">
             <a:pPr algn="l">
+              <a:buNone/>
               <a:defRPr sz="1350" b="0">
                 <a:solidFill>
                   <a:srgbClr val="101820"/>
@@ -11883,6 +12026,7 @@
           <a:lstStyle xmlns:a="http://schemas.openxmlformats.org/drawingml/2006/main"/>
           <a:p xmlns:a="http://schemas.openxmlformats.org/drawingml/2006/main">
             <a:pPr algn="ctr">
+              <a:buNone/>
               <a:defRPr sz="1200" b="1">
                 <a:solidFill>
                   <a:srgbClr val="FFFFFF"/>
@@ -11939,6 +12083,7 @@
           <a:lstStyle xmlns:a="http://schemas.openxmlformats.org/drawingml/2006/main"/>
           <a:p xmlns:a="http://schemas.openxmlformats.org/drawingml/2006/main">
             <a:pPr algn="l">
+              <a:buNone/>
               <a:defRPr sz="1350" b="0">
                 <a:solidFill>
                   <a:srgbClr val="101820"/>
@@ -12030,6 +12175,7 @@
           <a:lstStyle xmlns:a="http://schemas.openxmlformats.org/drawingml/2006/main"/>
           <a:p xmlns:a="http://schemas.openxmlformats.org/drawingml/2006/main">
             <a:pPr algn="ctr">
+              <a:buNone/>
               <a:defRPr sz="1050" b="1">
                 <a:solidFill>
                   <a:srgbClr val="1B5964"/>
@@ -12115,6 +12261,7 @@
           <a:lstStyle xmlns:a="http://schemas.openxmlformats.org/drawingml/2006/main"/>
           <a:p xmlns:a="http://schemas.openxmlformats.org/drawingml/2006/main">
             <a:pPr algn="l">
+              <a:buNone/>
               <a:defRPr sz="900" b="1">
                 <a:solidFill>
                   <a:srgbClr val="2D8CFF"/>
@@ -12171,6 +12318,7 @@
           <a:lstStyle xmlns:a="http://schemas.openxmlformats.org/drawingml/2006/main"/>
           <a:p xmlns:a="http://schemas.openxmlformats.org/drawingml/2006/main">
             <a:pPr algn="l">
+              <a:buNone/>
               <a:defRPr sz="3300" b="1">
                 <a:solidFill>
                   <a:srgbClr val="101820"/>
@@ -12260,6 +12408,7 @@
           <a:lstStyle xmlns:a="http://schemas.openxmlformats.org/drawingml/2006/main"/>
           <a:p xmlns:a="http://schemas.openxmlformats.org/drawingml/2006/main">
             <a:pPr algn="l">
+              <a:buNone/>
               <a:defRPr sz="750" b="1">
                 <a:solidFill>
                   <a:srgbClr val="59636E"/>
@@ -12316,6 +12465,7 @@
           <a:lstStyle xmlns:a="http://schemas.openxmlformats.org/drawingml/2006/main"/>
           <a:p xmlns:a="http://schemas.openxmlformats.org/drawingml/2006/main">
             <a:pPr algn="r">
+              <a:buNone/>
               <a:defRPr sz="900" b="1">
                 <a:solidFill>
                   <a:srgbClr val="59636E"/>
@@ -12376,14 +12526,14 @@
       </p:sp>
       <p:pic>
         <p:nvPicPr>
-          <p:cNvPr id="20" name=""/>
+          <p:cNvPr id="22" name=""/>
           <p:cNvPicPr>
             <a:picLocks xmlns:a="http://schemas.openxmlformats.org/drawingml/2006/main" noChangeAspect="1"/>
           </p:cNvPicPr>
           <p:nvPr/>
         </p:nvPicPr>
         <p:blipFill>
-          <a:blip xmlns:r="http://schemas.openxmlformats.org/officeDocument/2006/relationships" xmlns:a="http://schemas.openxmlformats.org/drawingml/2006/main" r:embed="R079d53d5ab7e4e05"/>
+          <a:blip xmlns:r="http://schemas.openxmlformats.org/officeDocument/2006/relationships" xmlns:a="http://schemas.openxmlformats.org/drawingml/2006/main" r:embed="Rce77e171be6c4ebc"/>
           <a:srcRect xmlns:a="http://schemas.openxmlformats.org/drawingml/2006/main" l="0" t="4073" r="0" b="4073"/>
           <a:stretch xmlns:a="http://schemas.openxmlformats.org/drawingml/2006/main">
             <a:fillRect l="0" t="0" r="0" b="0"/>
@@ -12469,6 +12619,7 @@
           <a:lstStyle xmlns:a="http://schemas.openxmlformats.org/drawingml/2006/main"/>
           <a:p xmlns:a="http://schemas.openxmlformats.org/drawingml/2006/main">
             <a:pPr algn="ctr">
+              <a:buNone/>
               <a:defRPr sz="1875" b="1">
                 <a:solidFill>
                   <a:srgbClr val="2D8CFF"/>
@@ -12492,6 +12643,7 @@
           </a:p>
           <a:p xmlns:a="http://schemas.openxmlformats.org/drawingml/2006/main">
             <a:pPr algn="ctr">
+              <a:buNone/>
               <a:defRPr sz="1875" b="1">
                 <a:solidFill>
                   <a:srgbClr val="2D8CFF"/>
@@ -12548,6 +12700,7 @@
           <a:lstStyle xmlns:a="http://schemas.openxmlformats.org/drawingml/2006/main"/>
           <a:p xmlns:a="http://schemas.openxmlformats.org/drawingml/2006/main">
             <a:pPr algn="l">
+              <a:buNone/>
               <a:defRPr sz="1875" b="1">
                 <a:solidFill>
                   <a:srgbClr val="B4382C"/>
@@ -12604,6 +12757,7 @@
           <a:lstStyle xmlns:a="http://schemas.openxmlformats.org/drawingml/2006/main"/>
           <a:p xmlns:a="http://schemas.openxmlformats.org/drawingml/2006/main">
             <a:pPr algn="l">
+              <a:buNone/>
               <a:defRPr sz="1425" b="0">
                 <a:solidFill>
                   <a:srgbClr val="101820"/>
@@ -12695,6 +12849,7 @@
           <a:lstStyle xmlns:a="http://schemas.openxmlformats.org/drawingml/2006/main"/>
           <a:p xmlns:a="http://schemas.openxmlformats.org/drawingml/2006/main">
             <a:pPr algn="ctr">
+              <a:buNone/>
               <a:defRPr sz="1125" b="1">
                 <a:solidFill>
                   <a:srgbClr val="1B5964"/>
@@ -12780,6 +12935,7 @@
           <a:lstStyle xmlns:a="http://schemas.openxmlformats.org/drawingml/2006/main"/>
           <a:p xmlns:a="http://schemas.openxmlformats.org/drawingml/2006/main">
             <a:pPr algn="l">
+              <a:buNone/>
               <a:defRPr sz="900" b="1">
                 <a:solidFill>
                   <a:srgbClr val="2D8CFF"/>
@@ -12836,6 +12992,7 @@
           <a:lstStyle xmlns:a="http://schemas.openxmlformats.org/drawingml/2006/main"/>
           <a:p xmlns:a="http://schemas.openxmlformats.org/drawingml/2006/main">
             <a:pPr algn="l">
+              <a:buNone/>
               <a:defRPr sz="3000" b="1">
                 <a:solidFill>
                   <a:srgbClr val="101820"/>
@@ -12892,6 +13049,7 @@
           <a:lstStyle xmlns:a="http://schemas.openxmlformats.org/drawingml/2006/main"/>
           <a:p xmlns:a="http://schemas.openxmlformats.org/drawingml/2006/main">
             <a:pPr algn="l">
+              <a:buNone/>
               <a:defRPr sz="3000" b="1">
                 <a:solidFill>
                   <a:srgbClr val="101820"/>
@@ -12981,6 +13139,7 @@
           <a:lstStyle xmlns:a="http://schemas.openxmlformats.org/drawingml/2006/main"/>
           <a:p xmlns:a="http://schemas.openxmlformats.org/drawingml/2006/main">
             <a:pPr algn="l">
+              <a:buNone/>
               <a:defRPr sz="750" b="1">
                 <a:solidFill>
                   <a:srgbClr val="59636E"/>
@@ -13037,6 +13196,7 @@
           <a:lstStyle xmlns:a="http://schemas.openxmlformats.org/drawingml/2006/main"/>
           <a:p xmlns:a="http://schemas.openxmlformats.org/drawingml/2006/main">
             <a:pPr algn="r">
+              <a:buNone/>
               <a:defRPr sz="900" b="1">
                 <a:solidFill>
                   <a:srgbClr val="59636E"/>
@@ -13093,6 +13253,7 @@
           <a:lstStyle xmlns:a="http://schemas.openxmlformats.org/drawingml/2006/main"/>
           <a:p xmlns:a="http://schemas.openxmlformats.org/drawingml/2006/main">
             <a:pPr algn="l">
+              <a:buNone/>
               <a:defRPr sz="900" b="1">
                 <a:solidFill>
                   <a:srgbClr val="2D8CFF"/>
@@ -13149,6 +13310,7 @@
           <a:lstStyle xmlns:a="http://schemas.openxmlformats.org/drawingml/2006/main"/>
           <a:p xmlns:a="http://schemas.openxmlformats.org/drawingml/2006/main">
             <a:pPr algn="l">
+              <a:buNone/>
               <a:defRPr sz="3000" b="1">
                 <a:solidFill>
                   <a:srgbClr val="101820"/>
@@ -13209,14 +13371,14 @@
       </p:sp>
       <p:pic>
         <p:nvPicPr>
-          <p:cNvPr id="33" name=""/>
+          <p:cNvPr id="35" name=""/>
           <p:cNvPicPr>
             <a:picLocks xmlns:a="http://schemas.openxmlformats.org/drawingml/2006/main" noChangeAspect="1"/>
           </p:cNvPicPr>
           <p:nvPr/>
         </p:nvPicPr>
         <p:blipFill>
-          <a:blip xmlns:r="http://schemas.openxmlformats.org/officeDocument/2006/relationships" xmlns:a="http://schemas.openxmlformats.org/drawingml/2006/main" r:embed="Rb3d1fbb0ed1b496f"/>
+          <a:blip xmlns:r="http://schemas.openxmlformats.org/officeDocument/2006/relationships" xmlns:a="http://schemas.openxmlformats.org/drawingml/2006/main" r:embed="R077116e77a15495a"/>
           <a:srcRect xmlns:a="http://schemas.openxmlformats.org/drawingml/2006/main" l="0" t="1023" r="0" b="1023"/>
           <a:stretch xmlns:a="http://schemas.openxmlformats.org/drawingml/2006/main">
             <a:fillRect l="0" t="0" r="0" b="0"/>
@@ -13267,6 +13429,7 @@
           <a:lstStyle xmlns:a="http://schemas.openxmlformats.org/drawingml/2006/main"/>
           <a:p xmlns:a="http://schemas.openxmlformats.org/drawingml/2006/main">
             <a:pPr algn="l">
+              <a:buNone/>
               <a:defRPr sz="1875" b="1">
                 <a:solidFill>
                   <a:srgbClr val="101820"/>
@@ -13327,6 +13490,7 @@
           <a:lstStyle xmlns:a="http://schemas.openxmlformats.org/drawingml/2006/main"/>
           <a:p xmlns:a="http://schemas.openxmlformats.org/drawingml/2006/main">
             <a:pPr algn="ctr">
+              <a:buNone/>
               <a:defRPr sz="1200" b="1">
                 <a:solidFill>
                   <a:srgbClr val="FFFFFF"/>
@@ -13383,6 +13547,7 @@
           <a:lstStyle xmlns:a="http://schemas.openxmlformats.org/drawingml/2006/main"/>
           <a:p xmlns:a="http://schemas.openxmlformats.org/drawingml/2006/main">
             <a:pPr algn="l">
+              <a:buNone/>
               <a:defRPr sz="1350" b="0">
                 <a:solidFill>
                   <a:srgbClr val="101820"/>
@@ -13443,6 +13608,7 @@
           <a:lstStyle xmlns:a="http://schemas.openxmlformats.org/drawingml/2006/main"/>
           <a:p xmlns:a="http://schemas.openxmlformats.org/drawingml/2006/main">
             <a:pPr algn="ctr">
+              <a:buNone/>
               <a:defRPr sz="1200" b="1">
                 <a:solidFill>
                   <a:srgbClr val="FFFFFF"/>
@@ -13499,6 +13665,7 @@
           <a:lstStyle xmlns:a="http://schemas.openxmlformats.org/drawingml/2006/main"/>
           <a:p xmlns:a="http://schemas.openxmlformats.org/drawingml/2006/main">
             <a:pPr algn="l">
+              <a:buNone/>
               <a:defRPr sz="1350" b="0">
                 <a:solidFill>
                   <a:srgbClr val="101820"/>
@@ -13559,6 +13726,7 @@
           <a:lstStyle xmlns:a="http://schemas.openxmlformats.org/drawingml/2006/main"/>
           <a:p xmlns:a="http://schemas.openxmlformats.org/drawingml/2006/main">
             <a:pPr algn="ctr">
+              <a:buNone/>
               <a:defRPr sz="1200" b="1">
                 <a:solidFill>
                   <a:srgbClr val="FFFFFF"/>
@@ -13615,6 +13783,7 @@
           <a:lstStyle xmlns:a="http://schemas.openxmlformats.org/drawingml/2006/main"/>
           <a:p xmlns:a="http://schemas.openxmlformats.org/drawingml/2006/main">
             <a:pPr algn="l">
+              <a:buNone/>
               <a:defRPr sz="1350" b="0">
                 <a:solidFill>
                   <a:srgbClr val="101820"/>
@@ -13675,6 +13844,7 @@
           <a:lstStyle xmlns:a="http://schemas.openxmlformats.org/drawingml/2006/main"/>
           <a:p xmlns:a="http://schemas.openxmlformats.org/drawingml/2006/main">
             <a:pPr algn="ctr">
+              <a:buNone/>
               <a:defRPr sz="1200" b="1">
                 <a:solidFill>
                   <a:srgbClr val="FFFFFF"/>
@@ -13731,6 +13901,7 @@
           <a:lstStyle xmlns:a="http://schemas.openxmlformats.org/drawingml/2006/main"/>
           <a:p xmlns:a="http://schemas.openxmlformats.org/drawingml/2006/main">
             <a:pPr algn="l">
+              <a:buNone/>
               <a:defRPr sz="1350" b="0">
                 <a:solidFill>
                   <a:srgbClr val="101820"/>
@@ -13791,6 +13962,7 @@
           <a:lstStyle xmlns:a="http://schemas.openxmlformats.org/drawingml/2006/main"/>
           <a:p xmlns:a="http://schemas.openxmlformats.org/drawingml/2006/main">
             <a:pPr algn="ctr">
+              <a:buNone/>
               <a:defRPr sz="1200" b="1">
                 <a:solidFill>
                   <a:srgbClr val="FFFFFF"/>
@@ -13847,6 +14019,7 @@
           <a:lstStyle xmlns:a="http://schemas.openxmlformats.org/drawingml/2006/main"/>
           <a:p xmlns:a="http://schemas.openxmlformats.org/drawingml/2006/main">
             <a:pPr algn="l">
+              <a:buNone/>
               <a:defRPr sz="1350" b="0">
                 <a:solidFill>
                   <a:srgbClr val="101820"/>
@@ -13938,6 +14111,7 @@
           <a:lstStyle xmlns:a="http://schemas.openxmlformats.org/drawingml/2006/main"/>
           <a:p xmlns:a="http://schemas.openxmlformats.org/drawingml/2006/main">
             <a:pPr algn="ctr">
+              <a:buNone/>
               <a:defRPr sz="1050" b="1">
                 <a:solidFill>
                   <a:srgbClr val="2D8CFF"/>
@@ -14023,6 +14197,7 @@
           <a:lstStyle xmlns:a="http://schemas.openxmlformats.org/drawingml/2006/main"/>
           <a:p xmlns:a="http://schemas.openxmlformats.org/drawingml/2006/main">
             <a:pPr algn="l">
+              <a:buNone/>
               <a:defRPr sz="900" b="1">
                 <a:solidFill>
                   <a:srgbClr val="2D8CFF"/>
@@ -14079,6 +14254,7 @@
           <a:lstStyle xmlns:a="http://schemas.openxmlformats.org/drawingml/2006/main"/>
           <a:p xmlns:a="http://schemas.openxmlformats.org/drawingml/2006/main">
             <a:pPr algn="l">
+              <a:buNone/>
               <a:defRPr sz="3300" b="1">
                 <a:solidFill>
                   <a:srgbClr val="101820"/>
@@ -14168,6 +14344,7 @@
           <a:lstStyle xmlns:a="http://schemas.openxmlformats.org/drawingml/2006/main"/>
           <a:p xmlns:a="http://schemas.openxmlformats.org/drawingml/2006/main">
             <a:pPr algn="l">
+              <a:buNone/>
               <a:defRPr sz="750" b="1">
                 <a:solidFill>
                   <a:srgbClr val="59636E"/>
@@ -14224,6 +14401,7 @@
           <a:lstStyle xmlns:a="http://schemas.openxmlformats.org/drawingml/2006/main"/>
           <a:p xmlns:a="http://schemas.openxmlformats.org/drawingml/2006/main">
             <a:pPr algn="r">
+              <a:buNone/>
               <a:defRPr sz="900" b="1">
                 <a:solidFill>
                   <a:srgbClr val="59636E"/>
@@ -14315,6 +14493,7 @@
           <a:lstStyle xmlns:a="http://schemas.openxmlformats.org/drawingml/2006/main"/>
           <a:p xmlns:a="http://schemas.openxmlformats.org/drawingml/2006/main">
             <a:pPr algn="l">
+              <a:buNone/>
               <a:defRPr sz="1200" b="1">
                 <a:solidFill>
                   <a:srgbClr val="FFFFFF"/>
@@ -14371,6 +14550,7 @@
           <a:lstStyle xmlns:a="http://schemas.openxmlformats.org/drawingml/2006/main"/>
           <a:p xmlns:a="http://schemas.openxmlformats.org/drawingml/2006/main">
             <a:pPr algn="l">
+              <a:buNone/>
               <a:defRPr sz="1200" b="1">
                 <a:solidFill>
                   <a:srgbClr val="FFFFFF"/>
@@ -14462,6 +14642,7 @@
           <a:lstStyle xmlns:a="http://schemas.openxmlformats.org/drawingml/2006/main"/>
           <a:p xmlns:a="http://schemas.openxmlformats.org/drawingml/2006/main">
             <a:pPr algn="l">
+              <a:buNone/>
               <a:defRPr sz="1125" b="1">
                 <a:solidFill>
                   <a:srgbClr val="101820"/>
@@ -14518,6 +14699,7 @@
           <a:lstStyle xmlns:a="http://schemas.openxmlformats.org/drawingml/2006/main"/>
           <a:p xmlns:a="http://schemas.openxmlformats.org/drawingml/2006/main">
             <a:pPr algn="l">
+              <a:buNone/>
               <a:defRPr sz="1200" b="0">
                 <a:solidFill>
                   <a:srgbClr val="59636E"/>
@@ -14609,6 +14791,7 @@
           <a:lstStyle xmlns:a="http://schemas.openxmlformats.org/drawingml/2006/main"/>
           <a:p xmlns:a="http://schemas.openxmlformats.org/drawingml/2006/main">
             <a:pPr algn="l">
+              <a:buNone/>
               <a:defRPr sz="1125" b="1">
                 <a:solidFill>
                   <a:srgbClr val="101820"/>
@@ -14665,6 +14848,7 @@
           <a:lstStyle xmlns:a="http://schemas.openxmlformats.org/drawingml/2006/main"/>
           <a:p xmlns:a="http://schemas.openxmlformats.org/drawingml/2006/main">
             <a:pPr algn="l">
+              <a:buNone/>
               <a:defRPr sz="1200" b="0">
                 <a:solidFill>
                   <a:srgbClr val="59636E"/>
@@ -14756,6 +14940,7 @@
           <a:lstStyle xmlns:a="http://schemas.openxmlformats.org/drawingml/2006/main"/>
           <a:p xmlns:a="http://schemas.openxmlformats.org/drawingml/2006/main">
             <a:pPr algn="l">
+              <a:buNone/>
               <a:defRPr sz="1125" b="1">
                 <a:solidFill>
                   <a:srgbClr val="101820"/>
@@ -14812,6 +14997,7 @@
           <a:lstStyle xmlns:a="http://schemas.openxmlformats.org/drawingml/2006/main"/>
           <a:p xmlns:a="http://schemas.openxmlformats.org/drawingml/2006/main">
             <a:pPr algn="l">
+              <a:buNone/>
               <a:defRPr sz="1200" b="0">
                 <a:solidFill>
                   <a:srgbClr val="59636E"/>
@@ -14903,6 +15089,7 @@
           <a:lstStyle xmlns:a="http://schemas.openxmlformats.org/drawingml/2006/main"/>
           <a:p xmlns:a="http://schemas.openxmlformats.org/drawingml/2006/main">
             <a:pPr algn="l">
+              <a:buNone/>
               <a:defRPr sz="1125" b="0">
                 <a:solidFill>
                   <a:srgbClr val="101820"/>
@@ -14959,6 +15146,7 @@
           <a:lstStyle xmlns:a="http://schemas.openxmlformats.org/drawingml/2006/main"/>
           <a:p xmlns:a="http://schemas.openxmlformats.org/drawingml/2006/main">
             <a:pPr algn="l">
+              <a:buNone/>
               <a:defRPr sz="1200" b="0">
                 <a:solidFill>
                   <a:srgbClr val="59636E"/>
@@ -15050,6 +15238,7 @@
           <a:lstStyle xmlns:a="http://schemas.openxmlformats.org/drawingml/2006/main"/>
           <a:p xmlns:a="http://schemas.openxmlformats.org/drawingml/2006/main">
             <a:pPr algn="l">
+              <a:buNone/>
               <a:defRPr sz="1125" b="0">
                 <a:solidFill>
                   <a:srgbClr val="101820"/>
@@ -15106,6 +15295,7 @@
           <a:lstStyle xmlns:a="http://schemas.openxmlformats.org/drawingml/2006/main"/>
           <a:p xmlns:a="http://schemas.openxmlformats.org/drawingml/2006/main">
             <a:pPr algn="l">
+              <a:buNone/>
               <a:defRPr sz="1200" b="0">
                 <a:solidFill>
                   <a:srgbClr val="59636E"/>
@@ -15197,6 +15387,7 @@
           <a:lstStyle xmlns:a="http://schemas.openxmlformats.org/drawingml/2006/main"/>
           <a:p xmlns:a="http://schemas.openxmlformats.org/drawingml/2006/main">
             <a:pPr algn="l">
+              <a:buNone/>
               <a:defRPr sz="1125" b="0">
                 <a:solidFill>
                   <a:srgbClr val="101820"/>
@@ -15253,6 +15444,7 @@
           <a:lstStyle xmlns:a="http://schemas.openxmlformats.org/drawingml/2006/main"/>
           <a:p xmlns:a="http://schemas.openxmlformats.org/drawingml/2006/main">
             <a:pPr algn="l">
+              <a:buNone/>
               <a:defRPr sz="1200" b="0">
                 <a:solidFill>
                   <a:srgbClr val="59636E"/>
@@ -15344,6 +15536,7 @@
           <a:lstStyle xmlns:a="http://schemas.openxmlformats.org/drawingml/2006/main"/>
           <a:p xmlns:a="http://schemas.openxmlformats.org/drawingml/2006/main">
             <a:pPr algn="l">
+              <a:buNone/>
               <a:defRPr sz="1125" b="0">
                 <a:solidFill>
                   <a:srgbClr val="101820"/>
@@ -15400,6 +15593,7 @@
           <a:lstStyle xmlns:a="http://schemas.openxmlformats.org/drawingml/2006/main"/>
           <a:p xmlns:a="http://schemas.openxmlformats.org/drawingml/2006/main">
             <a:pPr algn="l">
+              <a:buNone/>
               <a:defRPr sz="1200" b="1">
                 <a:solidFill>
                   <a:srgbClr val="E79A54"/>
@@ -15418,7 +15612,7 @@
                 <a:ea typeface="Arial"/>
                 <a:cs typeface="Arial"/>
               </a:rPr>
-              <a:t>Участники — рекомендуется</a:t>
+              <a:t>Участники — обязательно</a:t>
             </a:r>
           </a:p>
         </p:txBody>
@@ -15456,6 +15650,7 @@
           <a:lstStyle xmlns:a="http://schemas.openxmlformats.org/drawingml/2006/main"/>
           <a:p xmlns:a="http://schemas.openxmlformats.org/drawingml/2006/main">
             <a:pPr algn="l">
+              <a:buNone/>
               <a:defRPr sz="1275" b="1">
                 <a:solidFill>
                   <a:srgbClr val="B4382C"/>
@@ -15541,6 +15736,7 @@
           <a:lstStyle xmlns:a="http://schemas.openxmlformats.org/drawingml/2006/main"/>
           <a:p xmlns:a="http://schemas.openxmlformats.org/drawingml/2006/main">
             <a:pPr algn="l">
+              <a:buNone/>
               <a:defRPr sz="900" b="1">
                 <a:solidFill>
                   <a:srgbClr val="2D8CFF"/>
@@ -15597,6 +15793,7 @@
           <a:lstStyle xmlns:a="http://schemas.openxmlformats.org/drawingml/2006/main"/>
           <a:p xmlns:a="http://schemas.openxmlformats.org/drawingml/2006/main">
             <a:pPr algn="l">
+              <a:buNone/>
               <a:defRPr sz="3000" b="1">
                 <a:solidFill>
                   <a:srgbClr val="101820"/>
@@ -15686,6 +15883,7 @@
           <a:lstStyle xmlns:a="http://schemas.openxmlformats.org/drawingml/2006/main"/>
           <a:p xmlns:a="http://schemas.openxmlformats.org/drawingml/2006/main">
             <a:pPr algn="l">
+              <a:buNone/>
               <a:defRPr sz="750" b="1">
                 <a:solidFill>
                   <a:srgbClr val="59636E"/>
@@ -15742,6 +15940,7 @@
           <a:lstStyle xmlns:a="http://schemas.openxmlformats.org/drawingml/2006/main"/>
           <a:p xmlns:a="http://schemas.openxmlformats.org/drawingml/2006/main">
             <a:pPr algn="r">
+              <a:buNone/>
               <a:defRPr sz="900" b="1">
                 <a:solidFill>
                   <a:srgbClr val="59636E"/>
@@ -15798,6 +15997,7 @@
           <a:lstStyle xmlns:a="http://schemas.openxmlformats.org/drawingml/2006/main"/>
           <a:p xmlns:a="http://schemas.openxmlformats.org/drawingml/2006/main">
             <a:pPr algn="l">
+              <a:buNone/>
               <a:defRPr sz="900" b="1">
                 <a:solidFill>
                   <a:srgbClr val="2D8CFF"/>
@@ -15889,6 +16089,7 @@
           <a:lstStyle xmlns:a="http://schemas.openxmlformats.org/drawingml/2006/main"/>
           <a:p xmlns:a="http://schemas.openxmlformats.org/drawingml/2006/main">
             <a:pPr algn="l">
+              <a:buNone/>
               <a:defRPr sz="1050" b="1">
                 <a:solidFill>
                   <a:srgbClr val="2D8CFF"/>
@@ -15945,6 +16146,7 @@
           <a:lstStyle xmlns:a="http://schemas.openxmlformats.org/drawingml/2006/main"/>
           <a:p xmlns:a="http://schemas.openxmlformats.org/drawingml/2006/main">
             <a:pPr algn="l">
+              <a:buNone/>
               <a:defRPr sz="1575" b="1">
                 <a:solidFill>
                   <a:srgbClr val="101820"/>
@@ -16036,6 +16238,7 @@
           <a:lstStyle xmlns:a="http://schemas.openxmlformats.org/drawingml/2006/main"/>
           <a:p xmlns:a="http://schemas.openxmlformats.org/drawingml/2006/main">
             <a:pPr algn="l">
+              <a:buNone/>
               <a:defRPr sz="1050" b="1">
                 <a:solidFill>
                   <a:srgbClr val="1B5964"/>
@@ -16092,6 +16295,7 @@
           <a:lstStyle xmlns:a="http://schemas.openxmlformats.org/drawingml/2006/main"/>
           <a:p xmlns:a="http://schemas.openxmlformats.org/drawingml/2006/main">
             <a:pPr algn="l">
+              <a:buNone/>
               <a:defRPr sz="1575" b="1">
                 <a:solidFill>
                   <a:srgbClr val="101820"/>
@@ -16183,6 +16387,7 @@
           <a:lstStyle xmlns:a="http://schemas.openxmlformats.org/drawingml/2006/main"/>
           <a:p xmlns:a="http://schemas.openxmlformats.org/drawingml/2006/main">
             <a:pPr algn="l">
+              <a:buNone/>
               <a:defRPr sz="1050" b="1">
                 <a:solidFill>
                   <a:srgbClr val="E79A54"/>
@@ -16239,6 +16444,7 @@
           <a:lstStyle xmlns:a="http://schemas.openxmlformats.org/drawingml/2006/main"/>
           <a:p xmlns:a="http://schemas.openxmlformats.org/drawingml/2006/main">
             <a:pPr algn="l">
+              <a:buNone/>
               <a:defRPr sz="1575" b="1">
                 <a:solidFill>
                   <a:srgbClr val="101820"/>
@@ -16330,6 +16536,7 @@
           <a:lstStyle xmlns:a="http://schemas.openxmlformats.org/drawingml/2006/main"/>
           <a:p xmlns:a="http://schemas.openxmlformats.org/drawingml/2006/main">
             <a:pPr algn="l">
+              <a:buNone/>
               <a:defRPr sz="2025" b="1">
                 <a:solidFill>
                   <a:srgbClr val="FFFFFF"/>
@@ -16386,6 +16593,7 @@
           <a:lstStyle xmlns:a="http://schemas.openxmlformats.org/drawingml/2006/main"/>
           <a:p xmlns:a="http://schemas.openxmlformats.org/drawingml/2006/main">
             <a:pPr algn="l">
+              <a:buNone/>
               <a:defRPr sz="1350" b="0">
                 <a:solidFill>
                   <a:srgbClr val="FFFFFF"/>
@@ -16409,6 +16617,7 @@
           </a:p>
           <a:p xmlns:a="http://schemas.openxmlformats.org/drawingml/2006/main">
             <a:pPr algn="l">
+              <a:buNone/>
               <a:defRPr sz="1350" b="0">
                 <a:solidFill>
                   <a:srgbClr val="FFFFFF"/>
@@ -16432,6 +16641,7 @@
           </a:p>
           <a:p xmlns:a="http://schemas.openxmlformats.org/drawingml/2006/main">
             <a:pPr algn="l">
+              <a:buNone/>
               <a:defRPr sz="1350" b="0">
                 <a:solidFill>
                   <a:srgbClr val="FFFFFF"/>
@@ -16455,6 +16665,7 @@
           </a:p>
           <a:p xmlns:a="http://schemas.openxmlformats.org/drawingml/2006/main">
             <a:pPr algn="l">
+              <a:buNone/>
               <a:defRPr sz="1350" b="0">
                 <a:solidFill>
                   <a:srgbClr val="FFFFFF"/>
@@ -16546,6 +16757,7 @@
           <a:lstStyle xmlns:a="http://schemas.openxmlformats.org/drawingml/2006/main"/>
           <a:p xmlns:a="http://schemas.openxmlformats.org/drawingml/2006/main">
             <a:pPr algn="ctr">
+              <a:buNone/>
               <a:defRPr sz="1275" b="1">
                 <a:solidFill>
                   <a:srgbClr val="B4382C"/>
@@ -16602,6 +16814,7 @@
           <a:lstStyle xmlns:a="http://schemas.openxmlformats.org/drawingml/2006/main"/>
           <a:p xmlns:a="http://schemas.openxmlformats.org/drawingml/2006/main">
             <a:pPr algn="ctr">
+              <a:buNone/>
               <a:defRPr sz="1425" b="1">
                 <a:solidFill>
                   <a:srgbClr val="B4382C"/>
@@ -16630,6 +16843,7 @@
           </a:p>
           <a:p xmlns:a="http://schemas.openxmlformats.org/drawingml/2006/main">
             <a:pPr algn="ctr">
+              <a:buNone/>
               <a:defRPr sz="1425" b="1">
                 <a:solidFill>
                   <a:srgbClr val="B4382C"/>
@@ -16686,6 +16900,7 @@
           <a:lstStyle xmlns:a="http://schemas.openxmlformats.org/drawingml/2006/main"/>
           <a:p xmlns:a="http://schemas.openxmlformats.org/drawingml/2006/main">
             <a:pPr algn="l">
+              <a:buNone/>
               <a:defRPr sz="900" b="1">
                 <a:solidFill>
                   <a:srgbClr val="2D8CFF"/>
@@ -16771,6 +16986,7 @@
           <a:lstStyle xmlns:a="http://schemas.openxmlformats.org/drawingml/2006/main"/>
           <a:p xmlns:a="http://schemas.openxmlformats.org/drawingml/2006/main">
             <a:pPr algn="l">
+              <a:buNone/>
               <a:defRPr sz="900" b="1">
                 <a:solidFill>
                   <a:srgbClr val="2D8CFF"/>
@@ -16827,6 +17043,7 @@
           <a:lstStyle xmlns:a="http://schemas.openxmlformats.org/drawingml/2006/main"/>
           <a:p xmlns:a="http://schemas.openxmlformats.org/drawingml/2006/main">
             <a:pPr algn="l">
+              <a:buNone/>
               <a:defRPr sz="3300" b="1">
                 <a:solidFill>
                   <a:srgbClr val="101820"/>
@@ -16916,6 +17133,7 @@
           <a:lstStyle xmlns:a="http://schemas.openxmlformats.org/drawingml/2006/main"/>
           <a:p xmlns:a="http://schemas.openxmlformats.org/drawingml/2006/main">
             <a:pPr algn="l">
+              <a:buNone/>
               <a:defRPr sz="750" b="1">
                 <a:solidFill>
                   <a:srgbClr val="59636E"/>
@@ -16972,6 +17190,7 @@
           <a:lstStyle xmlns:a="http://schemas.openxmlformats.org/drawingml/2006/main"/>
           <a:p xmlns:a="http://schemas.openxmlformats.org/drawingml/2006/main">
             <a:pPr algn="r">
+              <a:buNone/>
               <a:defRPr sz="900" b="1">
                 <a:solidFill>
                   <a:srgbClr val="59636E"/>
@@ -17032,14 +17251,14 @@
       </p:sp>
       <p:pic>
         <p:nvPicPr>
-          <p:cNvPr id="24" name=""/>
+          <p:cNvPr id="26" name=""/>
           <p:cNvPicPr>
             <a:picLocks xmlns:a="http://schemas.openxmlformats.org/drawingml/2006/main" noChangeAspect="1"/>
           </p:cNvPicPr>
           <p:nvPr/>
         </p:nvPicPr>
         <p:blipFill>
-          <a:blip xmlns:r="http://schemas.openxmlformats.org/officeDocument/2006/relationships" xmlns:a="http://schemas.openxmlformats.org/drawingml/2006/main" r:embed="R6059730e6ab74b59"/>
+          <a:blip xmlns:r="http://schemas.openxmlformats.org/officeDocument/2006/relationships" xmlns:a="http://schemas.openxmlformats.org/drawingml/2006/main" r:embed="Rb79cb584bc6c40f2"/>
           <a:srcRect xmlns:a="http://schemas.openxmlformats.org/drawingml/2006/main" l="1972" t="0" r="1972" b="0"/>
           <a:stretch xmlns:a="http://schemas.openxmlformats.org/drawingml/2006/main">
             <a:fillRect l="0" t="0" r="0" b="0"/>
@@ -17090,6 +17309,7 @@
           <a:lstStyle xmlns:a="http://schemas.openxmlformats.org/drawingml/2006/main"/>
           <a:p xmlns:a="http://schemas.openxmlformats.org/drawingml/2006/main">
             <a:pPr algn="l">
+              <a:buNone/>
               <a:defRPr sz="1875" b="1">
                 <a:solidFill>
                   <a:srgbClr val="101820"/>
@@ -17150,6 +17370,7 @@
           <a:lstStyle xmlns:a="http://schemas.openxmlformats.org/drawingml/2006/main"/>
           <a:p xmlns:a="http://schemas.openxmlformats.org/drawingml/2006/main">
             <a:pPr algn="ctr">
+              <a:buNone/>
               <a:defRPr sz="1200" b="1">
                 <a:solidFill>
                   <a:srgbClr val="FFFFFF"/>
@@ -17206,6 +17427,7 @@
           <a:lstStyle xmlns:a="http://schemas.openxmlformats.org/drawingml/2006/main"/>
           <a:p xmlns:a="http://schemas.openxmlformats.org/drawingml/2006/main">
             <a:pPr algn="l">
+              <a:buNone/>
               <a:defRPr sz="1425" b="0">
                 <a:solidFill>
                   <a:srgbClr val="101820"/>
@@ -17266,6 +17488,7 @@
           <a:lstStyle xmlns:a="http://schemas.openxmlformats.org/drawingml/2006/main"/>
           <a:p xmlns:a="http://schemas.openxmlformats.org/drawingml/2006/main">
             <a:pPr algn="ctr">
+              <a:buNone/>
               <a:defRPr sz="1200" b="1">
                 <a:solidFill>
                   <a:srgbClr val="FFFFFF"/>
@@ -17322,6 +17545,7 @@
           <a:lstStyle xmlns:a="http://schemas.openxmlformats.org/drawingml/2006/main"/>
           <a:p xmlns:a="http://schemas.openxmlformats.org/drawingml/2006/main">
             <a:pPr algn="l">
+              <a:buNone/>
               <a:defRPr sz="1425" b="0">
                 <a:solidFill>
                   <a:srgbClr val="101820"/>
@@ -17382,6 +17606,7 @@
           <a:lstStyle xmlns:a="http://schemas.openxmlformats.org/drawingml/2006/main"/>
           <a:p xmlns:a="http://schemas.openxmlformats.org/drawingml/2006/main">
             <a:pPr algn="ctr">
+              <a:buNone/>
               <a:defRPr sz="1200" b="1">
                 <a:solidFill>
                   <a:srgbClr val="FFFFFF"/>
@@ -17438,6 +17663,7 @@
           <a:lstStyle xmlns:a="http://schemas.openxmlformats.org/drawingml/2006/main"/>
           <a:p xmlns:a="http://schemas.openxmlformats.org/drawingml/2006/main">
             <a:pPr algn="l">
+              <a:buNone/>
               <a:defRPr sz="1425" b="0">
                 <a:solidFill>
                   <a:srgbClr val="101820"/>
@@ -17529,6 +17755,7 @@
           <a:lstStyle xmlns:a="http://schemas.openxmlformats.org/drawingml/2006/main"/>
           <a:p xmlns:a="http://schemas.openxmlformats.org/drawingml/2006/main">
             <a:pPr algn="ctr">
+              <a:buNone/>
               <a:defRPr sz="1350" b="1">
                 <a:solidFill>
                   <a:srgbClr val="E79A54"/>
@@ -17585,6 +17812,7 @@
           <a:lstStyle xmlns:a="http://schemas.openxmlformats.org/drawingml/2006/main"/>
           <a:p xmlns:a="http://schemas.openxmlformats.org/drawingml/2006/main">
             <a:pPr algn="ctr">
+              <a:buNone/>
               <a:defRPr sz="1200" b="0">
                 <a:solidFill>
                   <a:srgbClr val="101820"/>

</xml_diff>